<commit_message>
Rewrite course docs for student-facing voice
</commit_message>
<xml_diff>
--- a/slides/deep-learning-project-directions.pptx
+++ b/slides/deep-learning-project-directions.pptx
@@ -5809,7 +5809,7 @@
             <a:pPr lvl="0"/>
             <a:r>
               <a:rPr/>
-              <a:t>In this course, the most realistic student projects are probably:</a:t>
+              <a:t>In this course, the most realistic projects are probably:</a:t>
             </a:r>
           </a:p>
           <a:p>
@@ -5975,7 +5975,7 @@
             <a:pPr lvl="0"/>
             <a:r>
               <a:rPr/>
-              <a:t>Some students may focus less on training and more on </a:t>
+              <a:t>You may want to focus less on training and more on </a:t>
             </a:r>
             <a:r>
               <a:rPr b="1"/>
@@ -7857,7 +7857,7 @@
             <a:pPr lvl="0"/>
             <a:r>
               <a:rPr/>
-              <a:t>In this short introduction, I want to give you a </a:t>
+              <a:t>This short introduction gives you a </a:t>
             </a:r>
             <a:r>
               <a:rPr b="1"/>

</xml_diff>

<commit_message>
Use deep-learning slide template directly
</commit_message>
<xml_diff>
--- a/slides/deep-learning-project-directions.pptx
+++ b/slides/deep-learning-project-directions.pptx
@@ -2,40 +2,40 @@
 <file path=ppt/presentation.xml><?xml version="1.0" encoding="utf-8"?>
 <p:presentation xmlns:a="http://schemas.openxmlformats.org/drawingml/2006/main" xmlns:p="http://schemas.openxmlformats.org/presentationml/2006/main" xmlns:r="http://schemas.openxmlformats.org/officeDocument/2006/relationships" saveSubsetFonts="1" showSpecialPlsOnTitleSld="0">
   <p:sldMasterIdLst>
-    <p:sldMasterId id="2147483648" r:id="rId4"/>
+    <p:sldMasterId id="2147483648" r:id="rId1"/>
   </p:sldMasterIdLst>
   <p:sldIdLst>
-    <p:sldId id="256" r:id="rId5"/>
-    <p:sldId id="257" r:id="rId6"/>
-    <p:sldId id="258" r:id="rId7"/>
-    <p:sldId id="259" r:id="rId8"/>
-    <p:sldId id="260" r:id="rId9"/>
-    <p:sldId id="261" r:id="rId10"/>
-    <p:sldId id="262" r:id="rId11"/>
-    <p:sldId id="263" r:id="rId12"/>
-    <p:sldId id="264" r:id="rId13"/>
-    <p:sldId id="265" r:id="rId14"/>
-    <p:sldId id="266" r:id="rId15"/>
-    <p:sldId id="267" r:id="rId16"/>
-    <p:sldId id="268" r:id="rId17"/>
-    <p:sldId id="269" r:id="rId18"/>
-    <p:sldId id="270" r:id="rId19"/>
-    <p:sldId id="271" r:id="rId20"/>
-    <p:sldId id="272" r:id="rId21"/>
-    <p:sldId id="273" r:id="rId22"/>
-    <p:sldId id="274" r:id="rId23"/>
-    <p:sldId id="275" r:id="rId24"/>
-    <p:sldId id="276" r:id="rId25"/>
-    <p:sldId id="277" r:id="rId26"/>
-    <p:sldId id="278" r:id="rId27"/>
-    <p:sldId id="279" r:id="rId28"/>
-    <p:sldId id="280" r:id="rId29"/>
-    <p:sldId id="281" r:id="rId30"/>
-    <p:sldId id="282" r:id="rId31"/>
-    <p:sldId id="283" r:id="rId32"/>
-    <p:sldId id="284" r:id="rId33"/>
-    <p:sldId id="285" r:id="rId34"/>
-    <p:sldId id="286" r:id="rId35"/>
+    <p:sldId id="256" r:id="rId2"/>
+    <p:sldId id="257" r:id="rId3"/>
+    <p:sldId id="258" r:id="rId4"/>
+    <p:sldId id="259" r:id="rId5"/>
+    <p:sldId id="260" r:id="rId6"/>
+    <p:sldId id="261" r:id="rId7"/>
+    <p:sldId id="262" r:id="rId8"/>
+    <p:sldId id="263" r:id="rId9"/>
+    <p:sldId id="264" r:id="rId10"/>
+    <p:sldId id="265" r:id="rId11"/>
+    <p:sldId id="266" r:id="rId12"/>
+    <p:sldId id="267" r:id="rId13"/>
+    <p:sldId id="268" r:id="rId14"/>
+    <p:sldId id="269" r:id="rId15"/>
+    <p:sldId id="270" r:id="rId16"/>
+    <p:sldId id="271" r:id="rId17"/>
+    <p:sldId id="272" r:id="rId18"/>
+    <p:sldId id="273" r:id="rId19"/>
+    <p:sldId id="274" r:id="rId20"/>
+    <p:sldId id="275" r:id="rId21"/>
+    <p:sldId id="276" r:id="rId22"/>
+    <p:sldId id="277" r:id="rId23"/>
+    <p:sldId id="278" r:id="rId24"/>
+    <p:sldId id="279" r:id="rId25"/>
+    <p:sldId id="280" r:id="rId26"/>
+    <p:sldId id="281" r:id="rId27"/>
+    <p:sldId id="282" r:id="rId28"/>
+    <p:sldId id="283" r:id="rId29"/>
+    <p:sldId id="284" r:id="rId30"/>
+    <p:sldId id="285" r:id="rId31"/>
+    <p:sldId id="286" r:id="rId32"/>
   </p:sldIdLst>
   <p:sldSz cx="12192000" cy="6858000"/>
   <p:notesSz cx="6858000" cy="9144000"/>
@@ -743,8 +743,8 @@
         </p:nvSpPr>
         <p:spPr>
           <a:xfrm>
-            <a:off x="138631" y="4157180"/>
-            <a:ext cx="257369" cy="1906003"/>
+            <a:off x="138631" y="3722445"/>
+            <a:ext cx="257369" cy="2340738"/>
           </a:xfrm>
           <a:prstGeom prst="rect">
             <a:avLst/>
@@ -959,7 +959,33 @@
                 <a:ea typeface="+mn-ea"/>
                 <a:cs typeface="+mn-cs"/>
               </a:rPr>
-              <a:t>VLAIO TETRA MLOps4ECM</a:t>
+              <a:t>Bachelor EO: </a:t>
+            </a:r>
+            <a:r>
+              <a:rPr lang="nl-NL" sz="1200" kern="1200" noProof="0" dirty="0" err="1">
+                <a:solidFill>
+                  <a:schemeClr val="tx1">
+                    <a:tint val="75000"/>
+                  </a:schemeClr>
+                </a:solidFill>
+                <a:latin typeface="+mn-lt"/>
+                <a:ea typeface="+mn-ea"/>
+                <a:cs typeface="+mn-cs"/>
+              </a:rPr>
+              <a:t>Deep</a:t>
+            </a:r>
+            <a:r>
+              <a:rPr lang="nl-NL" sz="1200" kern="1200" noProof="0" dirty="0">
+                <a:solidFill>
+                  <a:schemeClr val="tx1">
+                    <a:tint val="75000"/>
+                  </a:schemeClr>
+                </a:solidFill>
+                <a:latin typeface="+mn-lt"/>
+                <a:ea typeface="+mn-ea"/>
+                <a:cs typeface="+mn-cs"/>
+              </a:rPr>
+              <a:t> Learning 2026</a:t>
             </a:r>
             <a:endParaRPr lang="en-GB" sz="1200" kern="1200" noProof="0" dirty="0">
               <a:solidFill>
@@ -1425,8 +1451,8 @@
         </p:nvSpPr>
         <p:spPr>
           <a:xfrm>
-            <a:off x="138631" y="4157180"/>
-            <a:ext cx="257369" cy="1906003"/>
+            <a:off x="138631" y="3722445"/>
+            <a:ext cx="257369" cy="2340738"/>
           </a:xfrm>
           <a:prstGeom prst="rect">
             <a:avLst/>
@@ -1641,7 +1667,33 @@
                 <a:ea typeface="+mn-ea"/>
                 <a:cs typeface="+mn-cs"/>
               </a:rPr>
-              <a:t>VLAIO TETRA MLOps4ECM</a:t>
+              <a:t>Bachelor EO: </a:t>
+            </a:r>
+            <a:r>
+              <a:rPr lang="nl-NL" sz="1200" kern="1200" noProof="0" dirty="0" err="1">
+                <a:solidFill>
+                  <a:schemeClr val="tx1">
+                    <a:tint val="75000"/>
+                  </a:schemeClr>
+                </a:solidFill>
+                <a:latin typeface="+mn-lt"/>
+                <a:ea typeface="+mn-ea"/>
+                <a:cs typeface="+mn-cs"/>
+              </a:rPr>
+              <a:t>Deep</a:t>
+            </a:r>
+            <a:r>
+              <a:rPr lang="nl-NL" sz="1200" kern="1200" noProof="0" dirty="0">
+                <a:solidFill>
+                  <a:schemeClr val="tx1">
+                    <a:tint val="75000"/>
+                  </a:schemeClr>
+                </a:solidFill>
+                <a:latin typeface="+mn-lt"/>
+                <a:ea typeface="+mn-ea"/>
+                <a:cs typeface="+mn-cs"/>
+              </a:rPr>
+              <a:t> Learning 2026</a:t>
             </a:r>
             <a:endParaRPr lang="en-GB" sz="1200" kern="1200" noProof="0" dirty="0">
               <a:solidFill>
@@ -2226,8 +2278,8 @@
         </p:nvSpPr>
         <p:spPr>
           <a:xfrm>
-            <a:off x="138631" y="4157180"/>
-            <a:ext cx="257369" cy="1906003"/>
+            <a:off x="138631" y="3722445"/>
+            <a:ext cx="257369" cy="2340738"/>
           </a:xfrm>
           <a:prstGeom prst="rect">
             <a:avLst/>
@@ -2442,7 +2494,33 @@
                 <a:ea typeface="+mn-ea"/>
                 <a:cs typeface="+mn-cs"/>
               </a:rPr>
-              <a:t>VLAIO TETRA MLOps4ECM</a:t>
+              <a:t>Bachelor EO: </a:t>
+            </a:r>
+            <a:r>
+              <a:rPr lang="nl-NL" sz="1200" kern="1200" noProof="0" dirty="0" err="1">
+                <a:solidFill>
+                  <a:schemeClr val="tx1">
+                    <a:tint val="75000"/>
+                  </a:schemeClr>
+                </a:solidFill>
+                <a:latin typeface="+mn-lt"/>
+                <a:ea typeface="+mn-ea"/>
+                <a:cs typeface="+mn-cs"/>
+              </a:rPr>
+              <a:t>Deep</a:t>
+            </a:r>
+            <a:r>
+              <a:rPr lang="nl-NL" sz="1200" kern="1200" noProof="0" dirty="0">
+                <a:solidFill>
+                  <a:schemeClr val="tx1">
+                    <a:tint val="75000"/>
+                  </a:schemeClr>
+                </a:solidFill>
+                <a:latin typeface="+mn-lt"/>
+                <a:ea typeface="+mn-ea"/>
+                <a:cs typeface="+mn-cs"/>
+              </a:rPr>
+              <a:t> Learning 2026</a:t>
             </a:r>
             <a:endParaRPr lang="en-GB" sz="1200" kern="1200" noProof="0" dirty="0">
               <a:solidFill>
@@ -2984,8 +3062,8 @@
         </p:nvSpPr>
         <p:spPr>
           <a:xfrm>
-            <a:off x="138631" y="4157180"/>
-            <a:ext cx="257369" cy="1906003"/>
+            <a:off x="138631" y="3722445"/>
+            <a:ext cx="257369" cy="2340738"/>
           </a:xfrm>
           <a:prstGeom prst="rect">
             <a:avLst/>
@@ -3200,7 +3278,33 @@
                 <a:ea typeface="+mn-ea"/>
                 <a:cs typeface="+mn-cs"/>
               </a:rPr>
-              <a:t>VLAIO TETRA MLOps4ECM</a:t>
+              <a:t>Bachelor EO: </a:t>
+            </a:r>
+            <a:r>
+              <a:rPr lang="nl-NL" sz="1200" kern="1200" noProof="0" dirty="0" err="1">
+                <a:solidFill>
+                  <a:schemeClr val="tx1">
+                    <a:tint val="75000"/>
+                  </a:schemeClr>
+                </a:solidFill>
+                <a:latin typeface="+mn-lt"/>
+                <a:ea typeface="+mn-ea"/>
+                <a:cs typeface="+mn-cs"/>
+              </a:rPr>
+              <a:t>Deep</a:t>
+            </a:r>
+            <a:r>
+              <a:rPr lang="nl-NL" sz="1200" kern="1200" noProof="0" dirty="0">
+                <a:solidFill>
+                  <a:schemeClr val="tx1">
+                    <a:tint val="75000"/>
+                  </a:schemeClr>
+                </a:solidFill>
+                <a:latin typeface="+mn-lt"/>
+                <a:ea typeface="+mn-ea"/>
+                <a:cs typeface="+mn-cs"/>
+              </a:rPr>
+              <a:t> Learning 2026</a:t>
             </a:r>
             <a:endParaRPr lang="en-GB" sz="1200" kern="1200" noProof="0" dirty="0">
               <a:solidFill>
@@ -3443,8 +3547,8 @@
         </p:nvSpPr>
         <p:spPr>
           <a:xfrm>
-            <a:off x="138631" y="4157180"/>
-            <a:ext cx="257369" cy="1906003"/>
+            <a:off x="138631" y="3722445"/>
+            <a:ext cx="257369" cy="2340738"/>
           </a:xfrm>
           <a:prstGeom prst="rect">
             <a:avLst/>
@@ -3659,7 +3763,33 @@
                 <a:ea typeface="+mn-ea"/>
                 <a:cs typeface="+mn-cs"/>
               </a:rPr>
-              <a:t>VLAIO TETRA MLOps4ECM</a:t>
+              <a:t>Bachelor EO: </a:t>
+            </a:r>
+            <a:r>
+              <a:rPr lang="nl-NL" sz="1200" kern="1200" noProof="0" dirty="0" err="1">
+                <a:solidFill>
+                  <a:schemeClr val="tx1">
+                    <a:tint val="75000"/>
+                  </a:schemeClr>
+                </a:solidFill>
+                <a:latin typeface="+mn-lt"/>
+                <a:ea typeface="+mn-ea"/>
+                <a:cs typeface="+mn-cs"/>
+              </a:rPr>
+              <a:t>Deep</a:t>
+            </a:r>
+            <a:r>
+              <a:rPr lang="nl-NL" sz="1200" kern="1200" noProof="0" dirty="0">
+                <a:solidFill>
+                  <a:schemeClr val="tx1">
+                    <a:tint val="75000"/>
+                  </a:schemeClr>
+                </a:solidFill>
+                <a:latin typeface="+mn-lt"/>
+                <a:ea typeface="+mn-ea"/>
+                <a:cs typeface="+mn-cs"/>
+              </a:rPr>
+              <a:t> Learning 2026</a:t>
             </a:r>
             <a:endParaRPr lang="en-GB" sz="1200" kern="1200" noProof="0" dirty="0">
               <a:solidFill>
@@ -4538,13 +4668,13 @@
           <p:nvPr userDrawn="1"/>
         </p:nvPicPr>
         <p:blipFill>
-          <a:blip r:embed="rId9">
+          <a:blip>
             <a:extLst>
               <a:ext uri="{28A0092B-C50C-407E-A947-70E740481C1C}">
                 <a14:useLocalDpi xmlns:a14="http://schemas.microsoft.com/office/drawing/2010/main" val="0"/>
               </a:ext>
               <a:ext uri="{96DAC541-7B7A-43D3-8B79-37D633B846F1}">
-                <asvg:svgBlip xmlns:asvg="http://schemas.microsoft.com/office/drawing/2016/SVG/main" r:embed="rId10"/>
+                <asvg:svgBlip xmlns:asvg="http://schemas.microsoft.com/office/drawing/2016/SVG/main" r:embed="rId9"/>
               </a:ext>
             </a:extLst>
           </a:blip>
@@ -4556,36 +4686,6 @@
           <a:xfrm>
             <a:off x="-4050" y="0"/>
             <a:ext cx="400050" cy="1981200"/>
-          </a:xfrm>
-          <a:prstGeom prst="rect">
-            <a:avLst/>
-          </a:prstGeom>
-        </p:spPr>
-      </p:pic>
-      <p:pic>
-        <p:nvPicPr>
-          <p:cNvPr id="4" name="Picture 6">
-            <a:extLst>
-              <a:ext uri="{FF2B5EF4-FFF2-40B4-BE49-F238E27FC236}">
-                <a16:creationId xmlns:a16="http://schemas.microsoft.com/office/drawing/2014/main" id="{D6C89B78-77C7-B736-B81F-26DB8983FC3D}"/>
-              </a:ext>
-            </a:extLst>
-          </p:cNvPr>
-          <p:cNvPicPr>
-            <a:picLocks noChangeAspect="1"/>
-          </p:cNvPicPr>
-          <p:nvPr userDrawn="1"/>
-        </p:nvPicPr>
-        <p:blipFill>
-          <a:blip r:embed="rId11"/>
-          <a:stretch>
-            <a:fillRect/>
-          </a:stretch>
-        </p:blipFill>
-        <p:spPr>
-          <a:xfrm>
-            <a:off x="10720227" y="108088"/>
-            <a:ext cx="1294591" cy="467266"/>
           </a:xfrm>
           <a:prstGeom prst="rect">
             <a:avLst/>
@@ -4607,7 +4707,7 @@
           <p:nvPr userDrawn="1"/>
         </p:nvPicPr>
         <p:blipFill>
-          <a:blip r:embed="rId12">
+          <a:blip r:embed="rId10">
             <a:extLst>
               <a:ext uri="{28A0092B-C50C-407E-A947-70E740481C1C}">
                 <a14:useLocalDpi xmlns:a14="http://schemas.microsoft.com/office/drawing/2010/main" val="0"/>
@@ -4620,7 +4720,7 @@
         </p:blipFill>
         <p:spPr>
           <a:xfrm>
-            <a:off x="9265805" y="108089"/>
+            <a:off x="10699626" y="131494"/>
             <a:ext cx="1308347" cy="467266"/>
           </a:xfrm>
           <a:prstGeom prst="rect">

</xml_diff>

<commit_message>
Split retrieval and recommendation directions
</commit_message>
<xml_diff>
--- a/slides/deep-learning-project-directions.pptx
+++ b/slides/deep-learning-project-directions.pptx
@@ -36,6 +36,7 @@
     <p:sldId id="284" r:id="rId30"/>
     <p:sldId id="285" r:id="rId31"/>
     <p:sldId id="286" r:id="rId32"/>
+    <p:sldId id="287" r:id="rId33"/>
   </p:sldIdLst>
   <p:sldSz cx="12192000" cy="6858000"/>
   <p:notesSz cx="6858000" cy="9144000"/>
@@ -6801,7 +6802,7 @@
             </a:pPr>
             <a:r>
               <a:rPr/>
-              <a:t>Semantic Search, Retrieval, and Recommendation</a:t>
+              <a:t>Semantic Search and Retrieval</a:t>
             </a:r>
           </a:p>
         </p:txBody>
@@ -6879,13 +6880,6 @@
             <a:pPr lvl="1"/>
             <a:r>
               <a:rPr/>
-              <a:t>recommendation app</a:t>
-            </a:r>
-          </a:p>
-          <a:p>
-            <a:pPr lvl="1"/>
-            <a:r>
-              <a:rPr/>
               <a:t>similar-item finder</a:t>
             </a:r>
           </a:p>
@@ -6897,6 +6891,123 @@
 </file>
 
 <file path=ppt/slides/slide22.xml><?xml version="1.0" encoding="utf-8"?>
+<p:sld xmlns:a="http://schemas.openxmlformats.org/drawingml/2006/main" xmlns:r="http://schemas.openxmlformats.org/officeDocument/2006/relationships" xmlns:p="http://schemas.openxmlformats.org/presentationml/2006/main">
+  <p:cSld>
+    <p:spTree>
+      <p:nvGrpSpPr>
+        <p:cNvPr id="1" name=""/>
+        <p:cNvGrpSpPr/>
+        <p:nvPr/>
+      </p:nvGrpSpPr>
+      <p:grpSpPr>
+        <a:xfrm>
+          <a:off x="0" y="0"/>
+          <a:ext cx="0" cy="0"/>
+          <a:chOff x="0" y="0"/>
+          <a:chExt cx="0" cy="0"/>
+        </a:xfrm>
+      </p:grpSpPr>
+      <p:sp>
+        <p:nvSpPr>
+          <p:cNvPr id="2" name="Title 1">
+            <a:extLst>
+              <a:ext uri="{FF2B5EF4-FFF2-40B4-BE49-F238E27FC236}">
+                <a16:creationId xmlns:a16="http://schemas.microsoft.com/office/drawing/2014/main" id="{DC1D1A22-93E7-53F5-3D1C-BA3AE5668A21}"/>
+              </a:ext>
+            </a:extLst>
+          </p:cNvPr>
+          <p:cNvSpPr>
+            <a:spLocks noGrp="1"/>
+          </p:cNvSpPr>
+          <p:nvPr>
+            <p:ph type="title"/>
+          </p:nvPr>
+        </p:nvSpPr>
+        <p:spPr/>
+        <p:txBody>
+          <a:bodyPr/>
+          <a:lstStyle/>
+          <a:p>
+            <a:pPr lvl="0" indent="0" marL="0">
+              <a:buNone/>
+            </a:pPr>
+            <a:r>
+              <a:rPr/>
+              <a:t>Recommendation Systems</a:t>
+            </a:r>
+          </a:p>
+        </p:txBody>
+      </p:sp>
+      <p:sp>
+        <p:nvSpPr>
+          <p:cNvPr id="3" name="Content Placeholder 2">
+            <a:extLst>
+              <a:ext uri="{FF2B5EF4-FFF2-40B4-BE49-F238E27FC236}">
+                <a16:creationId xmlns:a16="http://schemas.microsoft.com/office/drawing/2014/main" id="{89184A04-97C2-C83B-3F52-CA55E676823D}"/>
+              </a:ext>
+            </a:extLst>
+          </p:cNvPr>
+          <p:cNvSpPr>
+            <a:spLocks noGrp="1"/>
+          </p:cNvSpPr>
+          <p:nvPr>
+            <p:ph idx="1"/>
+          </p:nvPr>
+        </p:nvSpPr>
+        <p:spPr/>
+        <p:txBody>
+          <a:bodyPr/>
+          <a:lstStyle/>
+          <a:p>
+            <a:pPr lvl="0"/>
+            <a:r>
+              <a:rPr/>
+              <a:t>This direction is closely related to embeddings, but the user experience is different from search.</a:t>
+            </a:r>
+          </a:p>
+          <a:p>
+            <a:pPr lvl="0"/>
+            <a:r>
+              <a:rPr/>
+              <a:t>Typical projects:</a:t>
+            </a:r>
+          </a:p>
+          <a:p>
+            <a:pPr lvl="1"/>
+            <a:r>
+              <a:rPr/>
+              <a:t>music or media recommender</a:t>
+            </a:r>
+          </a:p>
+          <a:p>
+            <a:pPr lvl="1"/>
+            <a:r>
+              <a:rPr/>
+              <a:t>product recommendation demo</a:t>
+            </a:r>
+          </a:p>
+          <a:p>
+            <a:pPr lvl="1"/>
+            <a:r>
+              <a:rPr/>
+              <a:t>similar-item recommender</a:t>
+            </a:r>
+          </a:p>
+          <a:p>
+            <a:pPr lvl="1"/>
+            <a:r>
+              <a:rPr/>
+              <a:t>recommendation UI based on embeddings</a:t>
+            </a:r>
+          </a:p>
+        </p:txBody>
+      </p:sp>
+    </p:spTree>
+  </p:cSld>
+</p:sld>
+</file>
+
+<file path=ppt/slides/slide23.xml><?xml version="1.0" encoding="utf-8"?>
 <p:sld xmlns:a="http://schemas.openxmlformats.org/drawingml/2006/main" xmlns:r="http://schemas.openxmlformats.org/officeDocument/2006/relationships" xmlns:p="http://schemas.openxmlformats.org/presentationml/2006/main">
   <p:cSld>
     <p:spTree>
@@ -7069,145 +7180,6 @@
 </p:sld>
 </file>
 
-<file path=ppt/slides/slide23.xml><?xml version="1.0" encoding="utf-8"?>
-<p:sld xmlns:a="http://schemas.openxmlformats.org/drawingml/2006/main" xmlns:r="http://schemas.openxmlformats.org/officeDocument/2006/relationships" xmlns:p="http://schemas.openxmlformats.org/presentationml/2006/main">
-  <p:cSld>
-    <p:spTree>
-      <p:nvGrpSpPr>
-        <p:cNvPr id="1" name=""/>
-        <p:cNvGrpSpPr/>
-        <p:nvPr/>
-      </p:nvGrpSpPr>
-      <p:grpSpPr>
-        <a:xfrm>
-          <a:off x="0" y="0"/>
-          <a:ext cx="0" cy="0"/>
-          <a:chOff x="0" y="0"/>
-          <a:chExt cx="0" cy="0"/>
-        </a:xfrm>
-      </p:grpSpPr>
-      <p:sp>
-        <p:nvSpPr>
-          <p:cNvPr id="2" name="Title 1">
-            <a:extLst>
-              <a:ext uri="{FF2B5EF4-FFF2-40B4-BE49-F238E27FC236}">
-                <a16:creationId xmlns:a16="http://schemas.microsoft.com/office/drawing/2014/main" id="{DC1D1A22-93E7-53F5-3D1C-BA3AE5668A21}"/>
-              </a:ext>
-            </a:extLst>
-          </p:cNvPr>
-          <p:cNvSpPr>
-            <a:spLocks noGrp="1"/>
-          </p:cNvSpPr>
-          <p:nvPr>
-            <p:ph type="title"/>
-          </p:nvPr>
-        </p:nvSpPr>
-        <p:spPr/>
-        <p:txBody>
-          <a:bodyPr/>
-          <a:lstStyle/>
-          <a:p>
-            <a:pPr lvl="0" indent="0" marL="0">
-              <a:buNone/>
-            </a:pPr>
-            <a:r>
-              <a:rPr/>
-              <a:t>Generative Systems Are Cross-Cutting</a:t>
-            </a:r>
-          </a:p>
-        </p:txBody>
-      </p:sp>
-      <p:sp>
-        <p:nvSpPr>
-          <p:cNvPr id="3" name="Content Placeholder 2">
-            <a:extLst>
-              <a:ext uri="{FF2B5EF4-FFF2-40B4-BE49-F238E27FC236}">
-                <a16:creationId xmlns:a16="http://schemas.microsoft.com/office/drawing/2014/main" id="{89184A04-97C2-C83B-3F52-CA55E676823D}"/>
-              </a:ext>
-            </a:extLst>
-          </p:cNvPr>
-          <p:cNvSpPr>
-            <a:spLocks noGrp="1"/>
-          </p:cNvSpPr>
-          <p:nvPr>
-            <p:ph idx="1"/>
-          </p:nvPr>
-        </p:nvSpPr>
-        <p:spPr/>
-        <p:txBody>
-          <a:bodyPr/>
-          <a:lstStyle/>
-          <a:p>
-            <a:pPr lvl="0"/>
-            <a:r>
-              <a:rPr/>
-              <a:t>Generative AI is important, but it is not one single modality.</a:t>
-            </a:r>
-          </a:p>
-          <a:p>
-            <a:pPr lvl="0"/>
-            <a:r>
-              <a:rPr/>
-              <a:t>It can appear in:</a:t>
-            </a:r>
-          </a:p>
-          <a:p>
-            <a:pPr lvl="1"/>
-            <a:r>
-              <a:rPr/>
-              <a:t>text generation</a:t>
-            </a:r>
-          </a:p>
-          <a:p>
-            <a:pPr lvl="1"/>
-            <a:r>
-              <a:rPr/>
-              <a:t>image generation</a:t>
-            </a:r>
-          </a:p>
-          <a:p>
-            <a:pPr lvl="1"/>
-            <a:r>
-              <a:rPr/>
-              <a:t>speech generation</a:t>
-            </a:r>
-          </a:p>
-          <a:p>
-            <a:pPr lvl="1"/>
-            <a:r>
-              <a:rPr/>
-              <a:t>music generation</a:t>
-            </a:r>
-          </a:p>
-          <a:p>
-            <a:pPr lvl="1"/>
-            <a:r>
-              <a:rPr/>
-              <a:t>multimodal generation</a:t>
-            </a:r>
-          </a:p>
-          <a:p>
-            <a:pPr lvl="0"/>
-            <a:r>
-              <a:rPr/>
-              <a:t>So instead of treating it as one separate box, think of it as a </a:t>
-            </a:r>
-            <a:r>
-              <a:rPr b="1"/>
-              <a:t>style of model behavior</a:t>
-            </a:r>
-            <a:r>
-              <a:rPr/>
-              <a:t> across several domains.</a:t>
-            </a:r>
-          </a:p>
-        </p:txBody>
-      </p:sp>
-    </p:spTree>
-  </p:cSld>
-</p:sld>
-</file>
-
 <file path=ppt/slides/slide24.xml><?xml version="1.0" encoding="utf-8"?>
 <p:sld xmlns:a="http://schemas.openxmlformats.org/drawingml/2006/main" xmlns:r="http://schemas.openxmlformats.org/officeDocument/2006/relationships" xmlns:p="http://schemas.openxmlformats.org/presentationml/2006/main">
   <p:cSld>
@@ -7230,7 +7202,7 @@
           <p:cNvPr id="2" name="Title 1">
             <a:extLst>
               <a:ext uri="{FF2B5EF4-FFF2-40B4-BE49-F238E27FC236}">
-                <a16:creationId xmlns:a16="http://schemas.microsoft.com/office/drawing/2014/main" id="{43AED9B2-1B96-B1B6-91DE-ED4F04AF0870}"/>
+                <a16:creationId xmlns:a16="http://schemas.microsoft.com/office/drawing/2014/main" id="{DC1D1A22-93E7-53F5-3D1C-BA3AE5668A21}"/>
               </a:ext>
             </a:extLst>
           </p:cNvPr>
@@ -7241,12 +7213,7 @@
             <p:ph type="title"/>
           </p:nvPr>
         </p:nvSpPr>
-        <p:spPr>
-          <a:xfrm>
-            <a:off x="831851" y="1709740"/>
-            <a:ext cx="10515600" cy="2852737"/>
-          </a:xfrm>
-        </p:spPr>
+        <p:spPr/>
         <p:txBody>
           <a:bodyPr/>
           <a:lstStyle/>
@@ -7256,7 +7223,93 @@
             </a:pPr>
             <a:r>
               <a:rPr/>
-              <a:t>Framework Suggestions</a:t>
+              <a:t>Generative Systems Are Cross-Cutting</a:t>
+            </a:r>
+          </a:p>
+        </p:txBody>
+      </p:sp>
+      <p:sp>
+        <p:nvSpPr>
+          <p:cNvPr id="3" name="Content Placeholder 2">
+            <a:extLst>
+              <a:ext uri="{FF2B5EF4-FFF2-40B4-BE49-F238E27FC236}">
+                <a16:creationId xmlns:a16="http://schemas.microsoft.com/office/drawing/2014/main" id="{89184A04-97C2-C83B-3F52-CA55E676823D}"/>
+              </a:ext>
+            </a:extLst>
+          </p:cNvPr>
+          <p:cNvSpPr>
+            <a:spLocks noGrp="1"/>
+          </p:cNvSpPr>
+          <p:nvPr>
+            <p:ph idx="1"/>
+          </p:nvPr>
+        </p:nvSpPr>
+        <p:spPr/>
+        <p:txBody>
+          <a:bodyPr/>
+          <a:lstStyle/>
+          <a:p>
+            <a:pPr lvl="0"/>
+            <a:r>
+              <a:rPr/>
+              <a:t>Generative AI is important, but it is not one single modality.</a:t>
+            </a:r>
+          </a:p>
+          <a:p>
+            <a:pPr lvl="0"/>
+            <a:r>
+              <a:rPr/>
+              <a:t>It can appear in:</a:t>
+            </a:r>
+          </a:p>
+          <a:p>
+            <a:pPr lvl="1"/>
+            <a:r>
+              <a:rPr/>
+              <a:t>text generation</a:t>
+            </a:r>
+          </a:p>
+          <a:p>
+            <a:pPr lvl="1"/>
+            <a:r>
+              <a:rPr/>
+              <a:t>image generation</a:t>
+            </a:r>
+          </a:p>
+          <a:p>
+            <a:pPr lvl="1"/>
+            <a:r>
+              <a:rPr/>
+              <a:t>speech generation</a:t>
+            </a:r>
+          </a:p>
+          <a:p>
+            <a:pPr lvl="1"/>
+            <a:r>
+              <a:rPr/>
+              <a:t>music generation</a:t>
+            </a:r>
+          </a:p>
+          <a:p>
+            <a:pPr lvl="1"/>
+            <a:r>
+              <a:rPr/>
+              <a:t>multimodal generation</a:t>
+            </a:r>
+          </a:p>
+          <a:p>
+            <a:pPr lvl="0"/>
+            <a:r>
+              <a:rPr/>
+              <a:t>So instead of treating it as one separate box, think of it as a </a:t>
+            </a:r>
+            <a:r>
+              <a:rPr b="1"/>
+              <a:t>style of model behavior</a:t>
+            </a:r>
+            <a:r>
+              <a:rPr/>
+              <a:t> across several domains.</a:t>
             </a:r>
           </a:p>
         </p:txBody>
@@ -7288,6 +7341,64 @@
           <p:cNvPr id="2" name="Title 1">
             <a:extLst>
               <a:ext uri="{FF2B5EF4-FFF2-40B4-BE49-F238E27FC236}">
+                <a16:creationId xmlns:a16="http://schemas.microsoft.com/office/drawing/2014/main" id="{43AED9B2-1B96-B1B6-91DE-ED4F04AF0870}"/>
+              </a:ext>
+            </a:extLst>
+          </p:cNvPr>
+          <p:cNvSpPr>
+            <a:spLocks noGrp="1"/>
+          </p:cNvSpPr>
+          <p:nvPr>
+            <p:ph type="title"/>
+          </p:nvPr>
+        </p:nvSpPr>
+        <p:spPr>
+          <a:xfrm>
+            <a:off x="831851" y="1709740"/>
+            <a:ext cx="10515600" cy="2852737"/>
+          </a:xfrm>
+        </p:spPr>
+        <p:txBody>
+          <a:bodyPr/>
+          <a:lstStyle/>
+          <a:p>
+            <a:pPr lvl="0" indent="0" marL="0">
+              <a:buNone/>
+            </a:pPr>
+            <a:r>
+              <a:rPr/>
+              <a:t>Framework Suggestions</a:t>
+            </a:r>
+          </a:p>
+        </p:txBody>
+      </p:sp>
+    </p:spTree>
+  </p:cSld>
+</p:sld>
+</file>
+
+<file path=ppt/slides/slide26.xml><?xml version="1.0" encoding="utf-8"?>
+<p:sld xmlns:a="http://schemas.openxmlformats.org/drawingml/2006/main" xmlns:r="http://schemas.openxmlformats.org/officeDocument/2006/relationships" xmlns:p="http://schemas.openxmlformats.org/presentationml/2006/main">
+  <p:cSld>
+    <p:spTree>
+      <p:nvGrpSpPr>
+        <p:cNvPr id="1" name=""/>
+        <p:cNvGrpSpPr/>
+        <p:nvPr/>
+      </p:nvGrpSpPr>
+      <p:grpSpPr>
+        <a:xfrm>
+          <a:off x="0" y="0"/>
+          <a:ext cx="0" cy="0"/>
+          <a:chOff x="0" y="0"/>
+          <a:chExt cx="0" cy="0"/>
+        </a:xfrm>
+      </p:grpSpPr>
+      <p:sp>
+        <p:nvSpPr>
+          <p:cNvPr id="2" name="Title 1">
+            <a:extLst>
+              <a:ext uri="{FF2B5EF4-FFF2-40B4-BE49-F238E27FC236}">
                 <a16:creationId xmlns:a16="http://schemas.microsoft.com/office/drawing/2014/main" id="{DC1D1A22-93E7-53F5-3D1C-BA3AE5668A21}"/>
               </a:ext>
             </a:extLst>
@@ -7425,7 +7536,7 @@
 </p:sld>
 </file>
 
-<file path=ppt/slides/slide26.xml><?xml version="1.0" encoding="utf-8"?>
+<file path=ppt/slides/slide27.xml><?xml version="1.0" encoding="utf-8"?>
 <p:sld xmlns:a="http://schemas.openxmlformats.org/drawingml/2006/main" xmlns:r="http://schemas.openxmlformats.org/officeDocument/2006/relationships" xmlns:p="http://schemas.openxmlformats.org/presentationml/2006/main">
   <p:cSld>
     <p:spTree>
@@ -7577,134 +7688,6 @@
 </p:sld>
 </file>
 
-<file path=ppt/slides/slide27.xml><?xml version="1.0" encoding="utf-8"?>
-<p:sld xmlns:a="http://schemas.openxmlformats.org/drawingml/2006/main" xmlns:r="http://schemas.openxmlformats.org/officeDocument/2006/relationships" xmlns:p="http://schemas.openxmlformats.org/presentationml/2006/main">
-  <p:cSld>
-    <p:spTree>
-      <p:nvGrpSpPr>
-        <p:cNvPr id="1" name=""/>
-        <p:cNvGrpSpPr/>
-        <p:nvPr/>
-      </p:nvGrpSpPr>
-      <p:grpSpPr>
-        <a:xfrm>
-          <a:off x="0" y="0"/>
-          <a:ext cx="0" cy="0"/>
-          <a:chOff x="0" y="0"/>
-          <a:chExt cx="0" cy="0"/>
-        </a:xfrm>
-      </p:grpSpPr>
-      <p:sp>
-        <p:nvSpPr>
-          <p:cNvPr id="2" name="Title 1">
-            <a:extLst>
-              <a:ext uri="{FF2B5EF4-FFF2-40B4-BE49-F238E27FC236}">
-                <a16:creationId xmlns:a16="http://schemas.microsoft.com/office/drawing/2014/main" id="{DC1D1A22-93E7-53F5-3D1C-BA3AE5668A21}"/>
-              </a:ext>
-            </a:extLst>
-          </p:cNvPr>
-          <p:cNvSpPr>
-            <a:spLocks noGrp="1"/>
-          </p:cNvSpPr>
-          <p:nvPr>
-            <p:ph type="title"/>
-          </p:nvPr>
-        </p:nvSpPr>
-        <p:spPr/>
-        <p:txBody>
-          <a:bodyPr/>
-          <a:lstStyle/>
-          <a:p>
-            <a:pPr lvl="0" indent="0" marL="0">
-              <a:buNone/>
-            </a:pPr>
-            <a:r>
-              <a:rPr/>
-              <a:t>My Recommendation If You Are Unsure</a:t>
-            </a:r>
-          </a:p>
-        </p:txBody>
-      </p:sp>
-      <p:sp>
-        <p:nvSpPr>
-          <p:cNvPr id="3" name="Content Placeholder 2">
-            <a:extLst>
-              <a:ext uri="{FF2B5EF4-FFF2-40B4-BE49-F238E27FC236}">
-                <a16:creationId xmlns:a16="http://schemas.microsoft.com/office/drawing/2014/main" id="{89184A04-97C2-C83B-3F52-CA55E676823D}"/>
-              </a:ext>
-            </a:extLst>
-          </p:cNvPr>
-          <p:cNvSpPr>
-            <a:spLocks noGrp="1"/>
-          </p:cNvSpPr>
-          <p:nvPr>
-            <p:ph idx="1"/>
-          </p:nvPr>
-        </p:nvSpPr>
-        <p:spPr/>
-        <p:txBody>
-          <a:bodyPr/>
-          <a:lstStyle/>
-          <a:p>
-            <a:pPr lvl="0" indent="0" marL="0">
-              <a:buNone/>
-            </a:pPr>
-            <a:r>
-              <a:rPr/>
-              <a:t>Start with one of these:</a:t>
-            </a:r>
-          </a:p>
-          <a:p>
-            <a:pPr lvl="0"/>
-            <a:r>
-              <a:rPr/>
-              <a:t>a computer vision app with YOLO or RF-DETR</a:t>
-            </a:r>
-          </a:p>
-          <a:p>
-            <a:pPr lvl="0"/>
-            <a:r>
-              <a:rPr/>
-              <a:t>an LLM app with Ollama or Transformers</a:t>
-            </a:r>
-          </a:p>
-          <a:p>
-            <a:pPr lvl="0"/>
-            <a:r>
-              <a:rPr/>
-              <a:t>a retrieval / recommendation app with Sentence Transformers</a:t>
-            </a:r>
-          </a:p>
-          <a:p>
-            <a:pPr lvl="0"/>
-            <a:r>
-              <a:rPr/>
-              <a:t>a speech tool</a:t>
-            </a:r>
-          </a:p>
-          <a:p>
-            <a:pPr lvl="0"/>
-            <a:r>
-              <a:rPr/>
-              <a:t>an edge deployment project with a ready model</a:t>
-            </a:r>
-          </a:p>
-          <a:p>
-            <a:pPr lvl="0" indent="0" marL="0">
-              <a:buNone/>
-            </a:pPr>
-            <a:r>
-              <a:rPr/>
-              <a:t>These are usually easier to scope well than reinforcement learning or large-model fine-tuning.</a:t>
-            </a:r>
-          </a:p>
-        </p:txBody>
-      </p:sp>
-    </p:spTree>
-  </p:cSld>
-</p:sld>
-</file>
-
 <file path=ppt/slides/slide28.xml><?xml version="1.0" encoding="utf-8"?>
 <p:sld xmlns:a="http://schemas.openxmlformats.org/drawingml/2006/main" xmlns:r="http://schemas.openxmlformats.org/officeDocument/2006/relationships" xmlns:p="http://schemas.openxmlformats.org/presentationml/2006/main">
   <p:cSld>
@@ -7727,7 +7710,7 @@
           <p:cNvPr id="2" name="Title 1">
             <a:extLst>
               <a:ext uri="{FF2B5EF4-FFF2-40B4-BE49-F238E27FC236}">
-                <a16:creationId xmlns:a16="http://schemas.microsoft.com/office/drawing/2014/main" id="{43AED9B2-1B96-B1B6-91DE-ED4F04AF0870}"/>
+                <a16:creationId xmlns:a16="http://schemas.microsoft.com/office/drawing/2014/main" id="{DC1D1A22-93E7-53F5-3D1C-BA3AE5668A21}"/>
               </a:ext>
             </a:extLst>
           </p:cNvPr>
@@ -7738,12 +7721,7 @@
             <p:ph type="title"/>
           </p:nvPr>
         </p:nvSpPr>
-        <p:spPr>
-          <a:xfrm>
-            <a:off x="831851" y="1709740"/>
-            <a:ext cx="10515600" cy="2852737"/>
-          </a:xfrm>
-        </p:spPr>
+        <p:spPr/>
         <p:txBody>
           <a:bodyPr/>
           <a:lstStyle/>
@@ -7753,7 +7731,89 @@
             </a:pPr>
             <a:r>
               <a:rPr/>
-              <a:t>Final Expectations</a:t>
+              <a:t>My Recommendation If You Are Unsure</a:t>
+            </a:r>
+          </a:p>
+        </p:txBody>
+      </p:sp>
+      <p:sp>
+        <p:nvSpPr>
+          <p:cNvPr id="3" name="Content Placeholder 2">
+            <a:extLst>
+              <a:ext uri="{FF2B5EF4-FFF2-40B4-BE49-F238E27FC236}">
+                <a16:creationId xmlns:a16="http://schemas.microsoft.com/office/drawing/2014/main" id="{89184A04-97C2-C83B-3F52-CA55E676823D}"/>
+              </a:ext>
+            </a:extLst>
+          </p:cNvPr>
+          <p:cNvSpPr>
+            <a:spLocks noGrp="1"/>
+          </p:cNvSpPr>
+          <p:nvPr>
+            <p:ph idx="1"/>
+          </p:nvPr>
+        </p:nvSpPr>
+        <p:spPr/>
+        <p:txBody>
+          <a:bodyPr/>
+          <a:lstStyle/>
+          <a:p>
+            <a:pPr lvl="0" indent="0" marL="0">
+              <a:buNone/>
+            </a:pPr>
+            <a:r>
+              <a:rPr/>
+              <a:t>Start with one of these:</a:t>
+            </a:r>
+          </a:p>
+          <a:p>
+            <a:pPr lvl="0"/>
+            <a:r>
+              <a:rPr/>
+              <a:t>a computer vision app with YOLO or RF-DETR</a:t>
+            </a:r>
+          </a:p>
+          <a:p>
+            <a:pPr lvl="0"/>
+            <a:r>
+              <a:rPr/>
+              <a:t>an LLM app with Ollama or Transformers</a:t>
+            </a:r>
+          </a:p>
+          <a:p>
+            <a:pPr lvl="0"/>
+            <a:r>
+              <a:rPr/>
+              <a:t>a semantic search app with Sentence Transformers</a:t>
+            </a:r>
+          </a:p>
+          <a:p>
+            <a:pPr lvl="0"/>
+            <a:r>
+              <a:rPr/>
+              <a:t>a recommendation app with Sentence Transformers</a:t>
+            </a:r>
+          </a:p>
+          <a:p>
+            <a:pPr lvl="0"/>
+            <a:r>
+              <a:rPr/>
+              <a:t>a speech tool</a:t>
+            </a:r>
+          </a:p>
+          <a:p>
+            <a:pPr lvl="0"/>
+            <a:r>
+              <a:rPr/>
+              <a:t>an edge deployment project with a ready model</a:t>
+            </a:r>
+          </a:p>
+          <a:p>
+            <a:pPr lvl="0" indent="0" marL="0">
+              <a:buNone/>
+            </a:pPr>
+            <a:r>
+              <a:rPr/>
+              <a:t>These are usually easier to scope well than reinforcement learning or large-model fine-tuning.</a:t>
             </a:r>
           </a:p>
         </p:txBody>
@@ -7785,7 +7845,7 @@
           <p:cNvPr id="2" name="Title 1">
             <a:extLst>
               <a:ext uri="{FF2B5EF4-FFF2-40B4-BE49-F238E27FC236}">
-                <a16:creationId xmlns:a16="http://schemas.microsoft.com/office/drawing/2014/main" id="{DC1D1A22-93E7-53F5-3D1C-BA3AE5668A21}"/>
+                <a16:creationId xmlns:a16="http://schemas.microsoft.com/office/drawing/2014/main" id="{43AED9B2-1B96-B1B6-91DE-ED4F04AF0870}"/>
               </a:ext>
             </a:extLst>
           </p:cNvPr>
@@ -7796,7 +7856,12 @@
             <p:ph type="title"/>
           </p:nvPr>
         </p:nvSpPr>
-        <p:spPr/>
+        <p:spPr>
+          <a:xfrm>
+            <a:off x="831851" y="1709740"/>
+            <a:ext cx="10515600" cy="2852737"/>
+          </a:xfrm>
+        </p:spPr>
         <p:txBody>
           <a:bodyPr/>
           <a:lstStyle/>
@@ -7806,71 +7871,7 @@
             </a:pPr>
             <a:r>
               <a:rPr/>
-              <a:t>What I Want to See</a:t>
-            </a:r>
-          </a:p>
-        </p:txBody>
-      </p:sp>
-      <p:sp>
-        <p:nvSpPr>
-          <p:cNvPr id="3" name="Content Placeholder 2">
-            <a:extLst>
-              <a:ext uri="{FF2B5EF4-FFF2-40B4-BE49-F238E27FC236}">
-                <a16:creationId xmlns:a16="http://schemas.microsoft.com/office/drawing/2014/main" id="{89184A04-97C2-C83B-3F52-CA55E676823D}"/>
-              </a:ext>
-            </a:extLst>
-          </p:cNvPr>
-          <p:cNvSpPr>
-            <a:spLocks noGrp="1"/>
-          </p:cNvSpPr>
-          <p:nvPr>
-            <p:ph idx="1"/>
-          </p:nvPr>
-        </p:nvSpPr>
-        <p:spPr/>
-        <p:txBody>
-          <a:bodyPr/>
-          <a:lstStyle/>
-          <a:p>
-            <a:pPr lvl="0"/>
-            <a:r>
-              <a:rPr/>
-              <a:t>a unique project</a:t>
-            </a:r>
-          </a:p>
-          <a:p>
-            <a:pPr lvl="0"/>
-            <a:r>
-              <a:rPr/>
-              <a:t>a clear technical path</a:t>
-            </a:r>
-          </a:p>
-          <a:p>
-            <a:pPr lvl="0"/>
-            <a:r>
-              <a:rPr/>
-              <a:t>one main framework stack</a:t>
-            </a:r>
-          </a:p>
-          <a:p>
-            <a:pPr lvl="0"/>
-            <a:r>
-              <a:rPr/>
-              <a:t>visible effort</a:t>
-            </a:r>
-          </a:p>
-          <a:p>
-            <a:pPr lvl="0"/>
-            <a:r>
-              <a:rPr/>
-              <a:t>a working demo or prototype</a:t>
-            </a:r>
-          </a:p>
-          <a:p>
-            <a:pPr lvl="0"/>
-            <a:r>
-              <a:rPr/>
-              <a:t>understanding of the code and architecture</a:t>
+              <a:t>Final Expectations</a:t>
             </a:r>
           </a:p>
         </p:txBody>
@@ -8083,7 +8084,7 @@
             </a:pPr>
             <a:r>
               <a:rPr/>
-              <a:t>Final Message</a:t>
+              <a:t>What I Want to See</a:t>
             </a:r>
           </a:p>
         </p:txBody>
@@ -8112,42 +8113,42 @@
             <a:pPr lvl="0"/>
             <a:r>
               <a:rPr/>
-              <a:t>Deep learning is a very broad field.</a:t>
-            </a:r>
-          </a:p>
-          <a:p>
-            <a:pPr lvl="0"/>
-            <a:r>
-              <a:rPr/>
-              <a:t>You do not need to master all of it in this course.</a:t>
-            </a:r>
-          </a:p>
-          <a:p>
-            <a:pPr lvl="0"/>
-            <a:r>
-              <a:rPr/>
-              <a:t>But I want you to leave this course with:</a:t>
-            </a:r>
-          </a:p>
-          <a:p>
-            <a:pPr lvl="1"/>
-            <a:r>
-              <a:rPr/>
-              <a:t>a better map of the field</a:t>
-            </a:r>
-          </a:p>
-          <a:p>
-            <a:pPr lvl="1"/>
-            <a:r>
-              <a:rPr/>
-              <a:t>experience building one real AI system</a:t>
-            </a:r>
-          </a:p>
-          <a:p>
-            <a:pPr lvl="1"/>
-            <a:r>
-              <a:rPr/>
-              <a:t>confidence that you can learn a new framework on your own</a:t>
+              <a:t>a unique project</a:t>
+            </a:r>
+          </a:p>
+          <a:p>
+            <a:pPr lvl="0"/>
+            <a:r>
+              <a:rPr/>
+              <a:t>a clear technical path</a:t>
+            </a:r>
+          </a:p>
+          <a:p>
+            <a:pPr lvl="0"/>
+            <a:r>
+              <a:rPr/>
+              <a:t>one main framework stack</a:t>
+            </a:r>
+          </a:p>
+          <a:p>
+            <a:pPr lvl="0"/>
+            <a:r>
+              <a:rPr/>
+              <a:t>visible effort</a:t>
+            </a:r>
+          </a:p>
+          <a:p>
+            <a:pPr lvl="0"/>
+            <a:r>
+              <a:rPr/>
+              <a:t>a working demo or prototype</a:t>
+            </a:r>
+          </a:p>
+          <a:p>
+            <a:pPr lvl="0"/>
+            <a:r>
+              <a:rPr/>
+              <a:t>understanding of the code and architecture</a:t>
             </a:r>
           </a:p>
         </p:txBody>
@@ -8200,6 +8201,123 @@
             </a:pPr>
             <a:r>
               <a:rPr/>
+              <a:t>Final Message</a:t>
+            </a:r>
+          </a:p>
+        </p:txBody>
+      </p:sp>
+      <p:sp>
+        <p:nvSpPr>
+          <p:cNvPr id="3" name="Content Placeholder 2">
+            <a:extLst>
+              <a:ext uri="{FF2B5EF4-FFF2-40B4-BE49-F238E27FC236}">
+                <a16:creationId xmlns:a16="http://schemas.microsoft.com/office/drawing/2014/main" id="{89184A04-97C2-C83B-3F52-CA55E676823D}"/>
+              </a:ext>
+            </a:extLst>
+          </p:cNvPr>
+          <p:cNvSpPr>
+            <a:spLocks noGrp="1"/>
+          </p:cNvSpPr>
+          <p:nvPr>
+            <p:ph idx="1"/>
+          </p:nvPr>
+        </p:nvSpPr>
+        <p:spPr/>
+        <p:txBody>
+          <a:bodyPr/>
+          <a:lstStyle/>
+          <a:p>
+            <a:pPr lvl="0"/>
+            <a:r>
+              <a:rPr/>
+              <a:t>Deep learning is a very broad field.</a:t>
+            </a:r>
+          </a:p>
+          <a:p>
+            <a:pPr lvl="0"/>
+            <a:r>
+              <a:rPr/>
+              <a:t>You do not need to master all of it in this course.</a:t>
+            </a:r>
+          </a:p>
+          <a:p>
+            <a:pPr lvl="0"/>
+            <a:r>
+              <a:rPr/>
+              <a:t>But I want you to leave this course with:</a:t>
+            </a:r>
+          </a:p>
+          <a:p>
+            <a:pPr lvl="1"/>
+            <a:r>
+              <a:rPr/>
+              <a:t>a better map of the field</a:t>
+            </a:r>
+          </a:p>
+          <a:p>
+            <a:pPr lvl="1"/>
+            <a:r>
+              <a:rPr/>
+              <a:t>experience building one real AI system</a:t>
+            </a:r>
+          </a:p>
+          <a:p>
+            <a:pPr lvl="1"/>
+            <a:r>
+              <a:rPr/>
+              <a:t>confidence that you can learn a new framework on your own</a:t>
+            </a:r>
+          </a:p>
+        </p:txBody>
+      </p:sp>
+    </p:spTree>
+  </p:cSld>
+</p:sld>
+</file>
+
+<file path=ppt/slides/slide32.xml><?xml version="1.0" encoding="utf-8"?>
+<p:sld xmlns:a="http://schemas.openxmlformats.org/drawingml/2006/main" xmlns:r="http://schemas.openxmlformats.org/officeDocument/2006/relationships" xmlns:p="http://schemas.openxmlformats.org/presentationml/2006/main">
+  <p:cSld>
+    <p:spTree>
+      <p:nvGrpSpPr>
+        <p:cNvPr id="1" name=""/>
+        <p:cNvGrpSpPr/>
+        <p:nvPr/>
+      </p:nvGrpSpPr>
+      <p:grpSpPr>
+        <a:xfrm>
+          <a:off x="0" y="0"/>
+          <a:ext cx="0" cy="0"/>
+          <a:chOff x="0" y="0"/>
+          <a:chExt cx="0" cy="0"/>
+        </a:xfrm>
+      </p:grpSpPr>
+      <p:sp>
+        <p:nvSpPr>
+          <p:cNvPr id="2" name="Title 1">
+            <a:extLst>
+              <a:ext uri="{FF2B5EF4-FFF2-40B4-BE49-F238E27FC236}">
+                <a16:creationId xmlns:a16="http://schemas.microsoft.com/office/drawing/2014/main" id="{DC1D1A22-93E7-53F5-3D1C-BA3AE5668A21}"/>
+              </a:ext>
+            </a:extLst>
+          </p:cNvPr>
+          <p:cNvSpPr>
+            <a:spLocks noGrp="1"/>
+          </p:cNvSpPr>
+          <p:nvPr>
+            <p:ph type="title"/>
+          </p:nvPr>
+        </p:nvSpPr>
+        <p:spPr/>
+        <p:txBody>
+          <a:bodyPr/>
+          <a:lstStyle/>
+          <a:p>
+            <a:pPr lvl="0" indent="0" marL="0">
+              <a:buNone/>
+            </a:pPr>
+            <a:r>
+              <a:rPr/>
               <a:t>What To Do Next</a:t>
             </a:r>
           </a:p>
@@ -8836,7 +8954,14 @@
             <a:pPr lvl="1"/>
             <a:r>
               <a:rPr/>
-              <a:t>semantic search / retrieval / recommendation</a:t>
+              <a:t>semantic search / retrieval</a:t>
+            </a:r>
+          </a:p>
+          <a:p>
+            <a:pPr lvl="1"/>
+            <a:r>
+              <a:rPr/>
+              <a:t>recommendation systems</a:t>
             </a:r>
           </a:p>
           <a:p>

</xml_diff>

<commit_message>
Expand technical path explanations
</commit_message>
<xml_diff>
--- a/slides/deep-learning-project-directions.pptx
+++ b/slides/deep-learning-project-directions.pptx
@@ -37,6 +37,11 @@
     <p:sldId id="285" r:id="rId31"/>
     <p:sldId id="286" r:id="rId32"/>
     <p:sldId id="287" r:id="rId33"/>
+    <p:sldId id="288" r:id="rId34"/>
+    <p:sldId id="289" r:id="rId35"/>
+    <p:sldId id="290" r:id="rId36"/>
+    <p:sldId id="291" r:id="rId37"/>
+    <p:sldId id="292" r:id="rId38"/>
   </p:sldIdLst>
   <p:sldSz cx="12192000" cy="6858000"/>
   <p:notesSz cx="6858000" cy="9144000"/>
@@ -5392,105 +5397,28 @@
             <a:pPr lvl="0"/>
             <a:r>
               <a:rPr/>
-              <a:t>This is the classical deep-learning workflow:</a:t>
-            </a:r>
-          </a:p>
-          <a:p>
-            <a:pPr lvl="1"/>
-            <a:r>
-              <a:rPr/>
-              <a:t>dataset</a:t>
-            </a:r>
-          </a:p>
-          <a:p>
-            <a:pPr lvl="1"/>
-            <a:r>
-              <a:rPr/>
-              <a:t>model</a:t>
-            </a:r>
-          </a:p>
-          <a:p>
-            <a:pPr lvl="1"/>
-            <a:r>
-              <a:rPr/>
-              <a:t>training</a:t>
-            </a:r>
-          </a:p>
-          <a:p>
-            <a:pPr lvl="1"/>
-            <a:r>
-              <a:rPr/>
-              <a:t>evaluation</a:t>
-            </a:r>
-          </a:p>
-          <a:p>
-            <a:pPr lvl="1"/>
-            <a:r>
-              <a:rPr/>
-              <a:t>deployment</a:t>
-            </a:r>
-          </a:p>
-          <a:p>
-            <a:pPr lvl="0"/>
-            <a:r>
-              <a:rPr/>
-              <a:t>Important:</a:t>
-            </a:r>
-          </a:p>
-          <a:p>
-            <a:pPr lvl="1"/>
-            <a:r>
-              <a:rPr/>
-              <a:t>this can still start from a pretrained model</a:t>
-            </a:r>
-          </a:p>
-          <a:p>
-            <a:pPr lvl="1"/>
-            <a:r>
-              <a:rPr/>
-              <a:t>for example MobileNet, YOLO, or another pretrained model</a:t>
-            </a:r>
-          </a:p>
-          <a:p>
-            <a:pPr lvl="1"/>
-            <a:r>
-              <a:rPr/>
-              <a:t>then you continue training it on your own data</a:t>
-            </a:r>
-          </a:p>
-          <a:p>
-            <a:pPr lvl="0"/>
-            <a:r>
-              <a:rPr/>
-              <a:t>Good tools:</a:t>
-            </a:r>
-          </a:p>
-          <a:p>
-            <a:pPr lvl="1"/>
-            <a:r>
-              <a:rPr/>
-              <a:t>PyTorch</a:t>
-            </a:r>
-          </a:p>
-          <a:p>
-            <a:pPr lvl="1"/>
-            <a:r>
-              <a:rPr/>
-              <a:t>torchvision / torchaudio</a:t>
-            </a:r>
-          </a:p>
-          <a:p>
-            <a:pPr lvl="1"/>
-            <a:r>
-              <a:rPr/>
-              <a:t>YOLO</a:t>
-            </a:r>
-          </a:p>
-          <a:p>
-            <a:pPr lvl="1"/>
-            <a:r>
-              <a:rPr/>
-              <a:t>RF-DETR</a:t>
+              <a:t>This is the classical deep-learning workflow.</a:t>
+            </a:r>
+          </a:p>
+          <a:p>
+            <a:pPr lvl="0"/>
+            <a:r>
+              <a:rPr/>
+              <a:t>Typical flow: dataset, model, training, evaluation, deployment.</a:t>
+            </a:r>
+          </a:p>
+          <a:p>
+            <a:pPr lvl="0"/>
+            <a:r>
+              <a:rPr/>
+              <a:t>You may start from random weights or pretrained weights.</a:t>
+            </a:r>
+          </a:p>
+          <a:p>
+            <a:pPr lvl="0"/>
+            <a:r>
+              <a:rPr/>
+              <a:t>Example: continue training MobileNet or YOLO on your own data.</a:t>
             </a:r>
           </a:p>
         </p:txBody>
@@ -5543,7 +5471,7 @@
             </a:pPr>
             <a:r>
               <a:rPr/>
-              <a:t>Path 2: Build With Pretrained Foundation Models</a:t>
+              <a:t>Path 1: Why You Might Choose It</a:t>
             </a:r>
           </a:p>
         </p:txBody>
@@ -5572,99 +5500,28 @@
             <a:pPr lvl="0"/>
             <a:r>
               <a:rPr/>
-              <a:t>Here the main work is </a:t>
-            </a:r>
-            <a:r>
-              <a:rPr b="1"/>
-              <a:t>building around a model</a:t>
-            </a:r>
-            <a:r>
-              <a:rPr/>
-              <a:t>, not training it from scratch.</a:t>
-            </a:r>
-          </a:p>
-          <a:p>
-            <a:pPr lvl="0"/>
-            <a:r>
-              <a:rPr/>
-              <a:t>This is how many modern AI applications are made.</a:t>
-            </a:r>
-          </a:p>
-          <a:p>
-            <a:pPr lvl="0"/>
-            <a:r>
-              <a:rPr/>
-              <a:t>Good examples:</a:t>
-            </a:r>
-          </a:p>
-          <a:p>
-            <a:pPr lvl="1"/>
-            <a:r>
-              <a:rPr/>
-              <a:t>chatbot</a:t>
-            </a:r>
-          </a:p>
-          <a:p>
-            <a:pPr lvl="1"/>
-            <a:r>
-              <a:rPr/>
-              <a:t>multimodal assistant</a:t>
-            </a:r>
-          </a:p>
-          <a:p>
-            <a:pPr lvl="1"/>
-            <a:r>
-              <a:rPr/>
-              <a:t>speech tool</a:t>
-            </a:r>
-          </a:p>
-          <a:p>
-            <a:pPr lvl="1"/>
-            <a:r>
-              <a:rPr/>
-              <a:t>image generator</a:t>
-            </a:r>
-          </a:p>
-          <a:p>
-            <a:pPr lvl="1"/>
-            <a:r>
-              <a:rPr/>
-              <a:t>semantic search app</a:t>
-            </a:r>
-          </a:p>
-          <a:p>
-            <a:pPr lvl="0"/>
-            <a:r>
-              <a:rPr/>
-              <a:t>Good tools:</a:t>
-            </a:r>
-          </a:p>
-          <a:p>
-            <a:pPr lvl="1"/>
-            <a:r>
-              <a:rPr/>
-              <a:t>Hugging Face Transformers</a:t>
-            </a:r>
-          </a:p>
-          <a:p>
-            <a:pPr lvl="1"/>
-            <a:r>
-              <a:rPr/>
-              <a:t>Diffusers</a:t>
-            </a:r>
-          </a:p>
-          <a:p>
-            <a:pPr lvl="1"/>
-            <a:r>
-              <a:rPr/>
-              <a:t>Ollama</a:t>
-            </a:r>
-          </a:p>
-          <a:p>
-            <a:pPr lvl="1"/>
-            <a:r>
-              <a:rPr/>
-              <a:t>Sentence Transformers</a:t>
+              <a:t>Good if you want to understand how model training really works.</a:t>
+            </a:r>
+          </a:p>
+          <a:p>
+            <a:pPr lvl="0"/>
+            <a:r>
+              <a:rPr/>
+              <a:t>Strong domains: vision, audio, time-series, classification.</a:t>
+            </a:r>
+          </a:p>
+          <a:p>
+            <a:pPr lvl="0"/>
+            <a:r>
+              <a:rPr/>
+              <a:t>Good tools: PyTorch, torchvision, torchaudio, YOLO, RF-DETR.</a:t>
+            </a:r>
+          </a:p>
+          <a:p>
+            <a:pPr lvl="0"/>
+            <a:r>
+              <a:rPr/>
+              <a:t>Good projects: classifier, detector, anomaly detector.</a:t>
             </a:r>
           </a:p>
         </p:txBody>
@@ -5717,7 +5574,7 @@
             </a:pPr>
             <a:r>
               <a:rPr/>
-              <a:t>Path 3: Adapt or Fine-Tune Large Models</a:t>
+              <a:t>Path 2: Build With Pretrained Foundation Models</a:t>
             </a:r>
           </a:p>
         </p:txBody>
@@ -5746,56 +5603,36 @@
             <a:pPr lvl="0"/>
             <a:r>
               <a:rPr/>
-              <a:t>This is different from normal transfer learning on a smaller model.</a:t>
-            </a:r>
-          </a:p>
-          <a:p>
-            <a:pPr lvl="0"/>
-            <a:r>
-              <a:rPr/>
-              <a:t>For large foundation models, it is often not practical to retrain everything.</a:t>
-            </a:r>
-          </a:p>
-          <a:p>
-            <a:pPr lvl="0"/>
-            <a:r>
-              <a:rPr/>
-              <a:t>Instead, you adapt part of the model using methods such as:</a:t>
-            </a:r>
-          </a:p>
-          <a:p>
-            <a:pPr lvl="1"/>
-            <a:r>
-              <a:rPr/>
-              <a:t>LoRA</a:t>
-            </a:r>
-          </a:p>
-          <a:p>
-            <a:pPr lvl="1"/>
-            <a:r>
-              <a:rPr/>
-              <a:t>PEFT</a:t>
-            </a:r>
-          </a:p>
-          <a:p>
-            <a:pPr lvl="1"/>
-            <a:r>
-              <a:rPr/>
-              <a:t>adapters</a:t>
-            </a:r>
-          </a:p>
-          <a:p>
-            <a:pPr lvl="1"/>
-            <a:r>
-              <a:rPr/>
-              <a:t>DreamBooth-style adaptation</a:t>
-            </a:r>
-          </a:p>
-          <a:p>
-            <a:pPr lvl="0"/>
-            <a:r>
-              <a:rPr/>
-              <a:t>This path is powerful, but more ambitious.</a:t>
+              <a:t>Here the main work is </a:t>
+            </a:r>
+            <a:r>
+              <a:rPr b="1"/>
+              <a:t>building around a model</a:t>
+            </a:r>
+            <a:r>
+              <a:rPr/>
+              <a:t>, not training it yourself.</a:t>
+            </a:r>
+          </a:p>
+          <a:p>
+            <a:pPr lvl="0"/>
+            <a:r>
+              <a:rPr/>
+              <a:t>You choose an existing model and turn it into an application.</a:t>
+            </a:r>
+          </a:p>
+          <a:p>
+            <a:pPr lvl="0"/>
+            <a:r>
+              <a:rPr/>
+              <a:t>This is one of the most common modern AI workflows.</a:t>
+            </a:r>
+          </a:p>
+          <a:p>
+            <a:pPr lvl="0"/>
+            <a:r>
+              <a:rPr/>
+              <a:t>Strong path for text, speech, multimodal systems, and generation.</a:t>
             </a:r>
           </a:p>
         </p:txBody>
@@ -5827,7 +5664,7 @@
           <p:cNvPr id="2" name="Title 1">
             <a:extLst>
               <a:ext uri="{FF2B5EF4-FFF2-40B4-BE49-F238E27FC236}">
-                <a16:creationId xmlns:a16="http://schemas.microsoft.com/office/drawing/2014/main" id="{AA599B7A-49D6-747B-0DC1-9468669DED68}"/>
+                <a16:creationId xmlns:a16="http://schemas.microsoft.com/office/drawing/2014/main" id="{DC1D1A22-93E7-53F5-3D1C-BA3AE5668A21}"/>
               </a:ext>
             </a:extLst>
           </p:cNvPr>
@@ -5835,15 +5672,10 @@
             <a:spLocks noGrp="1"/>
           </p:cNvSpPr>
           <p:nvPr>
-            <p:ph hasCustomPrompt="1" type="title"/>
-          </p:nvPr>
-        </p:nvSpPr>
-        <p:spPr>
-          <a:xfrm>
-            <a:off x="839787" y="363600"/>
-            <a:ext cx="10515600" cy="1324800"/>
-          </a:xfrm>
-        </p:spPr>
+            <p:ph type="title"/>
+          </p:nvPr>
+        </p:nvSpPr>
+        <p:spPr/>
         <p:txBody>
           <a:bodyPr/>
           <a:lstStyle/>
@@ -5853,17 +5685,17 @@
             </a:pPr>
             <a:r>
               <a:rPr/>
-              <a:t>Path 4: Reinforcement Learning</a:t>
-            </a:r>
-          </a:p>
-        </p:txBody>
-      </p:sp>
-      <p:sp>
-        <p:nvSpPr>
-          <p:cNvPr id="4" name="Text Placeholder 3">
+              <a:t>Path 2: Where To Explore</a:t>
+            </a:r>
+          </a:p>
+        </p:txBody>
+      </p:sp>
+      <p:sp>
+        <p:nvSpPr>
+          <p:cNvPr id="3" name="Content Placeholder 2">
             <a:extLst>
               <a:ext uri="{FF2B5EF4-FFF2-40B4-BE49-F238E27FC236}">
-                <a16:creationId xmlns:a16="http://schemas.microsoft.com/office/drawing/2014/main" id="{002DFCD0-D549-8541-2E96-5E270DA67E5E}"/>
+                <a16:creationId xmlns:a16="http://schemas.microsoft.com/office/drawing/2014/main" id="{89184A04-97C2-C83B-3F52-CA55E676823D}"/>
               </a:ext>
             </a:extLst>
           </p:cNvPr>
@@ -5871,7 +5703,7 @@
             <a:spLocks noGrp="1"/>
           </p:cNvSpPr>
           <p:nvPr>
-            <p:ph hasCustomPrompt="1" idx="2" sz="half" type="body"/>
+            <p:ph idx="1"/>
           </p:nvPr>
         </p:nvSpPr>
         <p:spPr/>
@@ -5882,118 +5714,32 @@
             <a:pPr lvl="0"/>
             <a:r>
               <a:rPr/>
-              <a:t>Reinforcement learning is about learning through:</a:t>
-            </a:r>
-          </a:p>
-          <a:p>
-            <a:pPr lvl="1"/>
-            <a:r>
-              <a:rPr/>
-              <a:t>interaction</a:t>
-            </a:r>
-          </a:p>
-          <a:p>
-            <a:pPr lvl="1"/>
-            <a:r>
-              <a:rPr/>
-              <a:t>reward</a:t>
-            </a:r>
-          </a:p>
-          <a:p>
-            <a:pPr lvl="1"/>
-            <a:r>
-              <a:rPr/>
-              <a:t>trial and error</a:t>
-            </a:r>
-          </a:p>
-          <a:p>
-            <a:pPr lvl="0"/>
-            <a:r>
-              <a:rPr/>
-              <a:t>In this course, the most realistic projects are probably:</a:t>
-            </a:r>
-          </a:p>
-          <a:p>
-            <a:pPr lvl="1"/>
-            <a:r>
-              <a:rPr/>
-              <a:t>games</a:t>
-            </a:r>
-          </a:p>
-          <a:p>
-            <a:pPr lvl="1"/>
-            <a:r>
-              <a:rPr/>
-              <a:t>simulations</a:t>
-            </a:r>
-          </a:p>
-          <a:p>
-            <a:pPr lvl="1"/>
-            <a:r>
-              <a:rPr/>
-              <a:t>simple control tasks</a:t>
-            </a:r>
-          </a:p>
-          <a:p>
-            <a:pPr lvl="0"/>
-            <a:r>
-              <a:rPr/>
-              <a:t>Good tools:</a:t>
-            </a:r>
-          </a:p>
-          <a:p>
-            <a:pPr lvl="1"/>
-            <a:r>
-              <a:rPr/>
-              <a:t>Gymnasium</a:t>
-            </a:r>
-          </a:p>
-          <a:p>
-            <a:pPr lvl="1"/>
-            <a:r>
-              <a:rPr/>
-              <a:t>Stable-Baselines3</a:t>
-            </a:r>
-          </a:p>
-          <a:p>
-            <a:pPr lvl="1"/>
-            <a:r>
-              <a:rPr/>
-              <a:t>TorchRL</a:t>
-            </a:r>
-          </a:p>
-        </p:txBody>
-      </p:sp>
-      <p:pic>
-        <p:nvPicPr>
-          <p:cNvPr descr="media/chaining-llms.png" id="0" name="Picture 1"/>
-          <p:cNvPicPr>
-            <a:picLocks noGrp="1" noChangeAspect="1"/>
-          </p:cNvPicPr>
-          <p:nvPr/>
-        </p:nvPicPr>
-        <p:blipFill>
-          <a:blip r:embed="rId2"/>
-          <a:stretch>
-            <a:fillRect/>
-          </a:stretch>
-        </p:blipFill>
-        <p:spPr bwMode="auto">
-          <a:xfrm>
-            <a:off x="7848600" y="2819400"/>
-            <a:ext cx="3797300" cy="3797300"/>
-          </a:xfrm>
-          <a:prstGeom prst="rect">
-            <a:avLst/>
-          </a:prstGeom>
-          <a:noFill/>
-          <a:ln w="9525">
-            <a:noFill/>
-            <a:headEnd/>
-            <a:tailEnd/>
-          </a:ln>
-        </p:spPr>
-      </p:pic>
+              <a:t>Hugging Face is one of the best places to browse models, tasks, and examples.</a:t>
+            </a:r>
+          </a:p>
+          <a:p>
+            <a:pPr lvl="0"/>
+            <a:r>
+              <a:rPr/>
+              <a:t>Model cards help you understand what a model can do.</a:t>
+            </a:r>
+          </a:p>
+          <a:p>
+            <a:pPr lvl="0"/>
+            <a:r>
+              <a:rPr/>
+              <a:t>Good tools: Transformers, Diffusers, Sentence Transformers, Ollama.</a:t>
+            </a:r>
+          </a:p>
+          <a:p>
+            <a:pPr lvl="0"/>
+            <a:r>
+              <a:rPr/>
+              <a:t>Good projects: chatbot, speech tool, image generator, document assistant.</a:t>
+            </a:r>
+          </a:p>
+        </p:txBody>
+      </p:sp>
     </p:spTree>
   </p:cSld>
 </p:sld>
@@ -6021,7 +5767,7 @@
           <p:cNvPr id="2" name="Title 1">
             <a:extLst>
               <a:ext uri="{FF2B5EF4-FFF2-40B4-BE49-F238E27FC236}">
-                <a16:creationId xmlns:a16="http://schemas.microsoft.com/office/drawing/2014/main" id="{AA599B7A-49D6-747B-0DC1-9468669DED68}"/>
+                <a16:creationId xmlns:a16="http://schemas.microsoft.com/office/drawing/2014/main" id="{DC1D1A22-93E7-53F5-3D1C-BA3AE5668A21}"/>
               </a:ext>
             </a:extLst>
           </p:cNvPr>
@@ -6029,15 +5775,10 @@
             <a:spLocks noGrp="1"/>
           </p:cNvSpPr>
           <p:nvPr>
-            <p:ph hasCustomPrompt="1" type="title"/>
-          </p:nvPr>
-        </p:nvSpPr>
-        <p:spPr>
-          <a:xfrm>
-            <a:off x="839787" y="363600"/>
-            <a:ext cx="10515600" cy="1324800"/>
-          </a:xfrm>
-        </p:spPr>
+            <p:ph type="title"/>
+          </p:nvPr>
+        </p:nvSpPr>
+        <p:spPr/>
         <p:txBody>
           <a:bodyPr/>
           <a:lstStyle/>
@@ -6047,17 +5788,17 @@
             </a:pPr>
             <a:r>
               <a:rPr/>
-              <a:t>Path 5: Edge AI and Deployment</a:t>
-            </a:r>
-          </a:p>
-        </p:txBody>
-      </p:sp>
-      <p:sp>
-        <p:nvSpPr>
-          <p:cNvPr id="4" name="Text Placeholder 3">
+              <a:t>Path 3: Adapt or Fine-Tune Large Models</a:t>
+            </a:r>
+          </a:p>
+        </p:txBody>
+      </p:sp>
+      <p:sp>
+        <p:nvSpPr>
+          <p:cNvPr id="3" name="Content Placeholder 2">
             <a:extLst>
               <a:ext uri="{FF2B5EF4-FFF2-40B4-BE49-F238E27FC236}">
-                <a16:creationId xmlns:a16="http://schemas.microsoft.com/office/drawing/2014/main" id="{002DFCD0-D549-8541-2E96-5E270DA67E5E}"/>
+                <a16:creationId xmlns:a16="http://schemas.microsoft.com/office/drawing/2014/main" id="{89184A04-97C2-C83B-3F52-CA55E676823D}"/>
               </a:ext>
             </a:extLst>
           </p:cNvPr>
@@ -6065,7 +5806,7 @@
             <a:spLocks noGrp="1"/>
           </p:cNvSpPr>
           <p:nvPr>
-            <p:ph hasCustomPrompt="1" idx="2" sz="half" type="body"/>
+            <p:ph idx="1"/>
           </p:nvPr>
         </p:nvSpPr>
         <p:spPr/>
@@ -6076,119 +5817,32 @@
             <a:pPr lvl="0"/>
             <a:r>
               <a:rPr/>
-              <a:t>You may want to focus less on training and more on </a:t>
-            </a:r>
-            <a:r>
-              <a:rPr b="1"/>
-              <a:t>getting AI to run well on real hardware</a:t>
-            </a:r>
-            <a:r>
-              <a:rPr/>
-              <a:t>.</a:t>
-            </a:r>
-          </a:p>
-          <a:p>
-            <a:pPr lvl="0"/>
-            <a:r>
-              <a:rPr/>
-              <a:t>That is a very valid project path.</a:t>
-            </a:r>
-          </a:p>
-          <a:p>
-            <a:pPr lvl="0"/>
-            <a:r>
-              <a:rPr/>
-              <a:t>Good examples:</a:t>
-            </a:r>
-          </a:p>
-          <a:p>
-            <a:pPr lvl="1"/>
-            <a:r>
-              <a:rPr/>
-              <a:t>deploy a vision model to an edge device</a:t>
-            </a:r>
-          </a:p>
-          <a:p>
-            <a:pPr lvl="1"/>
-            <a:r>
-              <a:rPr/>
-              <a:t>compare runtimes</a:t>
-            </a:r>
-          </a:p>
-          <a:p>
-            <a:pPr lvl="1"/>
-            <a:r>
-              <a:rPr/>
-              <a:t>optimize latency</a:t>
-            </a:r>
-          </a:p>
-          <a:p>
-            <a:pPr lvl="1"/>
-            <a:r>
-              <a:rPr/>
-              <a:t>deploy a small local LLM</a:t>
-            </a:r>
-          </a:p>
-          <a:p>
-            <a:pPr lvl="0"/>
-            <a:r>
-              <a:rPr/>
-              <a:t>Good tools:</a:t>
-            </a:r>
-          </a:p>
-          <a:p>
-            <a:pPr lvl="1"/>
-            <a:r>
-              <a:rPr/>
-              <a:t>ONNX Runtime</a:t>
-            </a:r>
-          </a:p>
-          <a:p>
-            <a:pPr lvl="1"/>
-            <a:r>
-              <a:rPr/>
-              <a:t>Jetson / JetPack / TensorRT</a:t>
-            </a:r>
-          </a:p>
-          <a:p>
-            <a:pPr lvl="1"/>
-            <a:r>
-              <a:rPr/>
-              <a:t>Ollama or llama.cpp</a:t>
-            </a:r>
-          </a:p>
-        </p:txBody>
-      </p:sp>
-      <p:pic>
-        <p:nvPicPr>
-          <p:cNvPr descr="media/edge-ai-hardware-reference.jpg" id="0" name="Picture 1"/>
-          <p:cNvPicPr>
-            <a:picLocks noGrp="1" noChangeAspect="1"/>
-          </p:cNvPicPr>
-          <p:nvPr/>
-        </p:nvPicPr>
-        <p:blipFill>
-          <a:blip r:embed="rId2"/>
-          <a:stretch>
-            <a:fillRect/>
-          </a:stretch>
-        </p:blipFill>
-        <p:spPr bwMode="auto">
-          <a:xfrm>
-            <a:off x="7556500" y="3251200"/>
-            <a:ext cx="4394200" cy="2933700"/>
-          </a:xfrm>
-          <a:prstGeom prst="rect">
-            <a:avLst/>
-          </a:prstGeom>
-          <a:noFill/>
-          <a:ln w="9525">
-            <a:noFill/>
-            <a:headEnd/>
-            <a:tailEnd/>
-          </a:ln>
-        </p:spPr>
-      </p:pic>
+              <a:t>This is more than prompting, but less than training from scratch.</a:t>
+            </a:r>
+          </a:p>
+          <a:p>
+            <a:pPr lvl="0"/>
+            <a:r>
+              <a:rPr/>
+              <a:t>For large models, retraining everything is often too expensive.</a:t>
+            </a:r>
+          </a:p>
+          <a:p>
+            <a:pPr lvl="0"/>
+            <a:r>
+              <a:rPr/>
+              <a:t>Instead, you adapt part of the model.</a:t>
+            </a:r>
+          </a:p>
+          <a:p>
+            <a:pPr lvl="0"/>
+            <a:r>
+              <a:rPr/>
+              <a:t>Common methods: LoRA, PEFT, adapters.</a:t>
+            </a:r>
+          </a:p>
+        </p:txBody>
+      </p:sp>
     </p:spTree>
   </p:cSld>
 </p:sld>
@@ -6216,7 +5870,7 @@
           <p:cNvPr id="2" name="Title 1">
             <a:extLst>
               <a:ext uri="{FF2B5EF4-FFF2-40B4-BE49-F238E27FC236}">
-                <a16:creationId xmlns:a16="http://schemas.microsoft.com/office/drawing/2014/main" id="{43AED9B2-1B96-B1B6-91DE-ED4F04AF0870}"/>
+                <a16:creationId xmlns:a16="http://schemas.microsoft.com/office/drawing/2014/main" id="{DC1D1A22-93E7-53F5-3D1C-BA3AE5668A21}"/>
               </a:ext>
             </a:extLst>
           </p:cNvPr>
@@ -6227,12 +5881,7 @@
             <p:ph type="title"/>
           </p:nvPr>
         </p:nvSpPr>
-        <p:spPr>
-          <a:xfrm>
-            <a:off x="831851" y="1709740"/>
-            <a:ext cx="10515600" cy="2852737"/>
-          </a:xfrm>
-        </p:spPr>
+        <p:spPr/>
         <p:txBody>
           <a:bodyPr/>
           <a:lstStyle/>
@@ -6242,7 +5891,57 @@
             </a:pPr>
             <a:r>
               <a:rPr/>
-              <a:t>Application Directions</a:t>
+              <a:t>Path 3: Concrete Example</a:t>
+            </a:r>
+          </a:p>
+        </p:txBody>
+      </p:sp>
+      <p:sp>
+        <p:nvSpPr>
+          <p:cNvPr id="3" name="Content Placeholder 2">
+            <a:extLst>
+              <a:ext uri="{FF2B5EF4-FFF2-40B4-BE49-F238E27FC236}">
+                <a16:creationId xmlns:a16="http://schemas.microsoft.com/office/drawing/2014/main" id="{89184A04-97C2-C83B-3F52-CA55E676823D}"/>
+              </a:ext>
+            </a:extLst>
+          </p:cNvPr>
+          <p:cNvSpPr>
+            <a:spLocks noGrp="1"/>
+          </p:cNvSpPr>
+          <p:nvPr>
+            <p:ph idx="1"/>
+          </p:nvPr>
+        </p:nvSpPr>
+        <p:spPr/>
+        <p:txBody>
+          <a:bodyPr/>
+          <a:lstStyle/>
+          <a:p>
+            <a:pPr lvl="0"/>
+            <a:r>
+              <a:rPr/>
+              <a:t>Example: fine-tune an image model on your own face or visual style.</a:t>
+            </a:r>
+          </a:p>
+          <a:p>
+            <a:pPr lvl="0"/>
+            <a:r>
+              <a:rPr/>
+              <a:t>Example: adapt an LLM to a narrow domain.</a:t>
+            </a:r>
+          </a:p>
+          <a:p>
+            <a:pPr lvl="0"/>
+            <a:r>
+              <a:rPr/>
+              <a:t>Good tools: Transformers training stack, PEFT, Diffusers, PyTorch.</a:t>
+            </a:r>
+          </a:p>
+          <a:p>
+            <a:pPr lvl="0"/>
+            <a:r>
+              <a:rPr/>
+              <a:t>This path is powerful, but more ambitious than simple inference.</a:t>
             </a:r>
           </a:p>
         </p:txBody>
@@ -6295,7 +5994,7 @@
             </a:pPr>
             <a:r>
               <a:rPr/>
-              <a:t>Computer Vision</a:t>
+              <a:t>Path 4: Reinforcement Learning</a:t>
             </a:r>
           </a:p>
         </p:txBody>
@@ -6324,77 +6023,28 @@
             <a:pPr lvl="0"/>
             <a:r>
               <a:rPr/>
-              <a:t>Probably one of the easiest directions to demo well.</a:t>
-            </a:r>
-          </a:p>
-          <a:p>
-            <a:pPr lvl="0"/>
-            <a:r>
-              <a:rPr/>
-              <a:t>Typical tasks:</a:t>
-            </a:r>
-          </a:p>
-          <a:p>
-            <a:pPr lvl="1"/>
-            <a:r>
-              <a:rPr/>
-              <a:t>classification</a:t>
-            </a:r>
-          </a:p>
-          <a:p>
-            <a:pPr lvl="1"/>
-            <a:r>
-              <a:rPr/>
-              <a:t>object detection</a:t>
-            </a:r>
-          </a:p>
-          <a:p>
-            <a:pPr lvl="1"/>
-            <a:r>
-              <a:rPr/>
-              <a:t>segmentation</a:t>
-            </a:r>
-          </a:p>
-          <a:p>
-            <a:pPr lvl="1"/>
-            <a:r>
-              <a:rPr/>
-              <a:t>visual inspection</a:t>
-            </a:r>
-          </a:p>
-          <a:p>
-            <a:pPr lvl="0"/>
-            <a:r>
-              <a:rPr/>
-              <a:t>Strong frameworks:</a:t>
-            </a:r>
-          </a:p>
-          <a:p>
-            <a:pPr lvl="1"/>
-            <a:r>
-              <a:rPr/>
-              <a:t>PyTorch</a:t>
-            </a:r>
-          </a:p>
-          <a:p>
-            <a:pPr lvl="1"/>
-            <a:r>
-              <a:rPr/>
-              <a:t>Ultralytics YOLO</a:t>
-            </a:r>
-          </a:p>
-          <a:p>
-            <a:pPr lvl="1"/>
-            <a:r>
-              <a:rPr/>
-              <a:t>RF-DETR</a:t>
-            </a:r>
-          </a:p>
-          <a:p>
-            <a:pPr lvl="1"/>
-            <a:r>
-              <a:rPr/>
-              <a:t>OpenCV</a:t>
+              <a:t>This path is very different from supervised learning.</a:t>
+            </a:r>
+          </a:p>
+          <a:p>
+            <a:pPr lvl="0"/>
+            <a:r>
+              <a:rPr/>
+              <a:t>The model learns by interacting with an environment.</a:t>
+            </a:r>
+          </a:p>
+          <a:p>
+            <a:pPr lvl="0"/>
+            <a:r>
+              <a:rPr/>
+              <a:t>It tries actions, gets rewards, and improves over time.</a:t>
+            </a:r>
+          </a:p>
+          <a:p>
+            <a:pPr lvl="0"/>
+            <a:r>
+              <a:rPr/>
+              <a:t>The environment can be a game, simulation, or physical system.</a:t>
             </a:r>
           </a:p>
         </p:txBody>
@@ -6447,7 +6097,7 @@
             </a:pPr>
             <a:r>
               <a:rPr/>
-              <a:t>Language Models, Chat Systems, and Text Apps</a:t>
+              <a:t>Path 4: Why It Is Interesting</a:t>
             </a:r>
           </a:p>
         </p:txBody>
@@ -6476,77 +6126,28 @@
             <a:pPr lvl="0"/>
             <a:r>
               <a:rPr/>
-              <a:t>Strong option if you want to build something useful quickly.</a:t>
-            </a:r>
-          </a:p>
-          <a:p>
-            <a:pPr lvl="0"/>
-            <a:r>
-              <a:rPr/>
-              <a:t>Typical tasks:</a:t>
-            </a:r>
-          </a:p>
-          <a:p>
-            <a:pPr lvl="1"/>
-            <a:r>
-              <a:rPr/>
-              <a:t>chatbot</a:t>
-            </a:r>
-          </a:p>
-          <a:p>
-            <a:pPr lvl="1"/>
-            <a:r>
-              <a:rPr/>
-              <a:t>summarization</a:t>
-            </a:r>
-          </a:p>
-          <a:p>
-            <a:pPr lvl="1"/>
-            <a:r>
-              <a:rPr/>
-              <a:t>classification</a:t>
-            </a:r>
-          </a:p>
-          <a:p>
-            <a:pPr lvl="1"/>
-            <a:r>
-              <a:rPr/>
-              <a:t>tool calling</a:t>
-            </a:r>
-          </a:p>
-          <a:p>
-            <a:pPr lvl="1"/>
-            <a:r>
-              <a:rPr/>
-              <a:t>text transformation</a:t>
-            </a:r>
-          </a:p>
-          <a:p>
-            <a:pPr lvl="0"/>
-            <a:r>
-              <a:rPr/>
-              <a:t>Strong frameworks:</a:t>
-            </a:r>
-          </a:p>
-          <a:p>
-            <a:pPr lvl="1"/>
-            <a:r>
-              <a:rPr/>
-              <a:t>Ollama</a:t>
-            </a:r>
-          </a:p>
-          <a:p>
-            <a:pPr lvl="1"/>
-            <a:r>
-              <a:rPr/>
-              <a:t>Transformers</a:t>
-            </a:r>
-          </a:p>
-          <a:p>
-            <a:pPr lvl="1"/>
-            <a:r>
-              <a:rPr/>
-              <a:t>Sentence Transformers</a:t>
+              <a:t>The system discovers strategies by itself instead of copying labels.</a:t>
+            </a:r>
+          </a:p>
+          <a:p>
+            <a:pPr lvl="0"/>
+            <a:r>
+              <a:rPr/>
+              <a:t>Good projects: game agent, simulator, small control task.</a:t>
+            </a:r>
+          </a:p>
+          <a:p>
+            <a:pPr lvl="0"/>
+            <a:r>
+              <a:rPr/>
+              <a:t>Good tools: Gymnasium, Stable-Baselines3, TorchRL.</a:t>
+            </a:r>
+          </a:p>
+          <a:p>
+            <a:pPr lvl="0"/>
+            <a:r>
+              <a:rPr/>
+              <a:t>This path can need more compute and more time.</a:t>
             </a:r>
           </a:p>
         </p:txBody>
@@ -6657,7 +6258,7 @@
             </a:pPr>
             <a:r>
               <a:rPr/>
-              <a:t>Multimodal and Document AI</a:t>
+              <a:t>Path 5: Edge AI and Deployment</a:t>
             </a:r>
           </a:p>
         </p:txBody>
@@ -6686,70 +6287,28 @@
             <a:pPr lvl="0"/>
             <a:r>
               <a:rPr/>
-              <a:t>This is where language meets images, documents, or audio.</a:t>
-            </a:r>
-          </a:p>
-          <a:p>
-            <a:pPr lvl="0"/>
-            <a:r>
-              <a:rPr/>
-              <a:t>Typical tasks:</a:t>
-            </a:r>
-          </a:p>
-          <a:p>
-            <a:pPr lvl="1"/>
-            <a:r>
-              <a:rPr/>
-              <a:t>visual question answering</a:t>
-            </a:r>
-          </a:p>
-          <a:p>
-            <a:pPr lvl="1"/>
-            <a:r>
-              <a:rPr/>
-              <a:t>document understanding</a:t>
-            </a:r>
-          </a:p>
-          <a:p>
-            <a:pPr lvl="1"/>
-            <a:r>
-              <a:rPr/>
-              <a:t>receipt or invoice reading</a:t>
-            </a:r>
-          </a:p>
-          <a:p>
-            <a:pPr lvl="1"/>
-            <a:r>
-              <a:rPr/>
-              <a:t>image-aware assistants</a:t>
-            </a:r>
-          </a:p>
-          <a:p>
-            <a:pPr lvl="0"/>
-            <a:r>
-              <a:rPr/>
-              <a:t>Strong frameworks:</a:t>
-            </a:r>
-          </a:p>
-          <a:p>
-            <a:pPr lvl="1"/>
-            <a:r>
-              <a:rPr/>
-              <a:t>Transformers</a:t>
-            </a:r>
-          </a:p>
-          <a:p>
-            <a:pPr lvl="1"/>
-            <a:r>
-              <a:rPr/>
-              <a:t>vision-capable local models</a:t>
-            </a:r>
-          </a:p>
-          <a:p>
-            <a:pPr lvl="1"/>
-            <a:r>
-              <a:rPr/>
-              <a:t>document tools such as docTR</a:t>
+              <a:t>Most of you will run models on your GPU server.</a:t>
+            </a:r>
+          </a:p>
+          <a:p>
+            <a:pPr lvl="0"/>
+            <a:r>
+              <a:rPr/>
+              <a:t>Edge AI means running the model somewhere else locally.</a:t>
+            </a:r>
+          </a:p>
+          <a:p>
+            <a:pPr lvl="0"/>
+            <a:r>
+              <a:rPr/>
+              <a:t>Examples: laptop, Jetson, Raspberry Pi, embedded device.</a:t>
+            </a:r>
+          </a:p>
+          <a:p>
+            <a:pPr lvl="0"/>
+            <a:r>
+              <a:rPr/>
+              <a:t>The challenge is export, optimization, latency, and runtime choice.</a:t>
             </a:r>
           </a:p>
         </p:txBody>
@@ -6802,7 +6361,7 @@
             </a:pPr>
             <a:r>
               <a:rPr/>
-              <a:t>Semantic Search and Retrieval</a:t>
+              <a:t>Path 5: Why It Matters</a:t>
             </a:r>
           </a:p>
         </p:txBody>
@@ -6831,56 +6390,28 @@
             <a:pPr lvl="0"/>
             <a:r>
               <a:rPr/>
-              <a:t>This is one of the most practical modern AI directions.</a:t>
-            </a:r>
-          </a:p>
-          <a:p>
-            <a:pPr lvl="0"/>
-            <a:r>
-              <a:rPr/>
-              <a:t>It is based on embeddings:</a:t>
-            </a:r>
-          </a:p>
-          <a:p>
-            <a:pPr lvl="1"/>
-            <a:r>
-              <a:rPr/>
-              <a:t>represent items as vectors</a:t>
-            </a:r>
-          </a:p>
-          <a:p>
-            <a:pPr lvl="1"/>
-            <a:r>
-              <a:rPr/>
-              <a:t>compare them by meaning, not only by exact words</a:t>
-            </a:r>
-          </a:p>
-          <a:p>
-            <a:pPr lvl="0"/>
-            <a:r>
-              <a:rPr/>
-              <a:t>Typical projects:</a:t>
-            </a:r>
-          </a:p>
-          <a:p>
-            <a:pPr lvl="1"/>
-            <a:r>
-              <a:rPr/>
-              <a:t>semantic search</a:t>
-            </a:r>
-          </a:p>
-          <a:p>
-            <a:pPr lvl="1"/>
-            <a:r>
-              <a:rPr/>
-              <a:t>retrieval-augmented chatbot</a:t>
-            </a:r>
-          </a:p>
-          <a:p>
-            <a:pPr lvl="1"/>
-            <a:r>
-              <a:rPr/>
-              <a:t>similar-item finder</a:t>
+              <a:t>Good if you like systems, deployment, and performance engineering.</a:t>
+            </a:r>
+          </a:p>
+          <a:p>
+            <a:pPr lvl="0"/>
+            <a:r>
+              <a:rPr/>
+              <a:t>You can focus on making an existing model run well.</a:t>
+            </a:r>
+          </a:p>
+          <a:p>
+            <a:pPr lvl="0"/>
+            <a:r>
+              <a:rPr/>
+              <a:t>Good tools: ONNX Runtime, JetPack, TensorRT, Ollama, llama.cpp.</a:t>
+            </a:r>
+          </a:p>
+          <a:p>
+            <a:pPr lvl="0"/>
+            <a:r>
+              <a:rPr/>
+              <a:t>Strong examples: deploy vision, compare runtimes, run a local LLM.</a:t>
             </a:r>
           </a:p>
         </p:txBody>
@@ -6912,7 +6443,7 @@
           <p:cNvPr id="2" name="Title 1">
             <a:extLst>
               <a:ext uri="{FF2B5EF4-FFF2-40B4-BE49-F238E27FC236}">
-                <a16:creationId xmlns:a16="http://schemas.microsoft.com/office/drawing/2014/main" id="{DC1D1A22-93E7-53F5-3D1C-BA3AE5668A21}"/>
+                <a16:creationId xmlns:a16="http://schemas.microsoft.com/office/drawing/2014/main" id="{43AED9B2-1B96-B1B6-91DE-ED4F04AF0870}"/>
               </a:ext>
             </a:extLst>
           </p:cNvPr>
@@ -6923,7 +6454,12 @@
             <p:ph type="title"/>
           </p:nvPr>
         </p:nvSpPr>
-        <p:spPr/>
+        <p:spPr>
+          <a:xfrm>
+            <a:off x="831851" y="1709740"/>
+            <a:ext cx="10515600" cy="2852737"/>
+          </a:xfrm>
+        </p:spPr>
         <p:txBody>
           <a:bodyPr/>
           <a:lstStyle/>
@@ -6933,71 +6469,7 @@
             </a:pPr>
             <a:r>
               <a:rPr/>
-              <a:t>Recommendation Systems</a:t>
-            </a:r>
-          </a:p>
-        </p:txBody>
-      </p:sp>
-      <p:sp>
-        <p:nvSpPr>
-          <p:cNvPr id="3" name="Content Placeholder 2">
-            <a:extLst>
-              <a:ext uri="{FF2B5EF4-FFF2-40B4-BE49-F238E27FC236}">
-                <a16:creationId xmlns:a16="http://schemas.microsoft.com/office/drawing/2014/main" id="{89184A04-97C2-C83B-3F52-CA55E676823D}"/>
-              </a:ext>
-            </a:extLst>
-          </p:cNvPr>
-          <p:cNvSpPr>
-            <a:spLocks noGrp="1"/>
-          </p:cNvSpPr>
-          <p:nvPr>
-            <p:ph idx="1"/>
-          </p:nvPr>
-        </p:nvSpPr>
-        <p:spPr/>
-        <p:txBody>
-          <a:bodyPr/>
-          <a:lstStyle/>
-          <a:p>
-            <a:pPr lvl="0"/>
-            <a:r>
-              <a:rPr/>
-              <a:t>This direction is closely related to embeddings, but the user experience is different from search.</a:t>
-            </a:r>
-          </a:p>
-          <a:p>
-            <a:pPr lvl="0"/>
-            <a:r>
-              <a:rPr/>
-              <a:t>Typical projects:</a:t>
-            </a:r>
-          </a:p>
-          <a:p>
-            <a:pPr lvl="1"/>
-            <a:r>
-              <a:rPr/>
-              <a:t>music or media recommender</a:t>
-            </a:r>
-          </a:p>
-          <a:p>
-            <a:pPr lvl="1"/>
-            <a:r>
-              <a:rPr/>
-              <a:t>product recommendation demo</a:t>
-            </a:r>
-          </a:p>
-          <a:p>
-            <a:pPr lvl="1"/>
-            <a:r>
-              <a:rPr/>
-              <a:t>similar-item recommender</a:t>
-            </a:r>
-          </a:p>
-          <a:p>
-            <a:pPr lvl="1"/>
-            <a:r>
-              <a:rPr/>
-              <a:t>recommendation UI based on embeddings</a:t>
+              <a:t>Application Directions</a:t>
             </a:r>
           </a:p>
         </p:txBody>
@@ -7008,6 +6480,703 @@
 </file>
 
 <file path=ppt/slides/slide23.xml><?xml version="1.0" encoding="utf-8"?>
+<p:sld xmlns:a="http://schemas.openxmlformats.org/drawingml/2006/main" xmlns:r="http://schemas.openxmlformats.org/officeDocument/2006/relationships" xmlns:p="http://schemas.openxmlformats.org/presentationml/2006/main">
+  <p:cSld>
+    <p:spTree>
+      <p:nvGrpSpPr>
+        <p:cNvPr id="1" name=""/>
+        <p:cNvGrpSpPr/>
+        <p:nvPr/>
+      </p:nvGrpSpPr>
+      <p:grpSpPr>
+        <a:xfrm>
+          <a:off x="0" y="0"/>
+          <a:ext cx="0" cy="0"/>
+          <a:chOff x="0" y="0"/>
+          <a:chExt cx="0" cy="0"/>
+        </a:xfrm>
+      </p:grpSpPr>
+      <p:sp>
+        <p:nvSpPr>
+          <p:cNvPr id="2" name="Title 1">
+            <a:extLst>
+              <a:ext uri="{FF2B5EF4-FFF2-40B4-BE49-F238E27FC236}">
+                <a16:creationId xmlns:a16="http://schemas.microsoft.com/office/drawing/2014/main" id="{DC1D1A22-93E7-53F5-3D1C-BA3AE5668A21}"/>
+              </a:ext>
+            </a:extLst>
+          </p:cNvPr>
+          <p:cNvSpPr>
+            <a:spLocks noGrp="1"/>
+          </p:cNvSpPr>
+          <p:nvPr>
+            <p:ph type="title"/>
+          </p:nvPr>
+        </p:nvSpPr>
+        <p:spPr/>
+        <p:txBody>
+          <a:bodyPr/>
+          <a:lstStyle/>
+          <a:p>
+            <a:pPr lvl="0" indent="0" marL="0">
+              <a:buNone/>
+            </a:pPr>
+            <a:r>
+              <a:rPr/>
+              <a:t>Computer Vision</a:t>
+            </a:r>
+          </a:p>
+        </p:txBody>
+      </p:sp>
+      <p:sp>
+        <p:nvSpPr>
+          <p:cNvPr id="3" name="Content Placeholder 2">
+            <a:extLst>
+              <a:ext uri="{FF2B5EF4-FFF2-40B4-BE49-F238E27FC236}">
+                <a16:creationId xmlns:a16="http://schemas.microsoft.com/office/drawing/2014/main" id="{89184A04-97C2-C83B-3F52-CA55E676823D}"/>
+              </a:ext>
+            </a:extLst>
+          </p:cNvPr>
+          <p:cNvSpPr>
+            <a:spLocks noGrp="1"/>
+          </p:cNvSpPr>
+          <p:nvPr>
+            <p:ph idx="1"/>
+          </p:nvPr>
+        </p:nvSpPr>
+        <p:spPr/>
+        <p:txBody>
+          <a:bodyPr/>
+          <a:lstStyle/>
+          <a:p>
+            <a:pPr lvl="0"/>
+            <a:r>
+              <a:rPr/>
+              <a:t>Probably one of the easiest directions to demo well.</a:t>
+            </a:r>
+          </a:p>
+          <a:p>
+            <a:pPr lvl="0"/>
+            <a:r>
+              <a:rPr/>
+              <a:t>Typical tasks:</a:t>
+            </a:r>
+          </a:p>
+          <a:p>
+            <a:pPr lvl="1"/>
+            <a:r>
+              <a:rPr/>
+              <a:t>classification</a:t>
+            </a:r>
+          </a:p>
+          <a:p>
+            <a:pPr lvl="1"/>
+            <a:r>
+              <a:rPr/>
+              <a:t>object detection</a:t>
+            </a:r>
+          </a:p>
+          <a:p>
+            <a:pPr lvl="1"/>
+            <a:r>
+              <a:rPr/>
+              <a:t>segmentation</a:t>
+            </a:r>
+          </a:p>
+          <a:p>
+            <a:pPr lvl="1"/>
+            <a:r>
+              <a:rPr/>
+              <a:t>visual inspection</a:t>
+            </a:r>
+          </a:p>
+          <a:p>
+            <a:pPr lvl="0"/>
+            <a:r>
+              <a:rPr/>
+              <a:t>Strong frameworks:</a:t>
+            </a:r>
+          </a:p>
+          <a:p>
+            <a:pPr lvl="1"/>
+            <a:r>
+              <a:rPr/>
+              <a:t>PyTorch</a:t>
+            </a:r>
+          </a:p>
+          <a:p>
+            <a:pPr lvl="1"/>
+            <a:r>
+              <a:rPr/>
+              <a:t>Ultralytics YOLO</a:t>
+            </a:r>
+          </a:p>
+          <a:p>
+            <a:pPr lvl="1"/>
+            <a:r>
+              <a:rPr/>
+              <a:t>RF-DETR</a:t>
+            </a:r>
+          </a:p>
+          <a:p>
+            <a:pPr lvl="1"/>
+            <a:r>
+              <a:rPr/>
+              <a:t>OpenCV</a:t>
+            </a:r>
+          </a:p>
+        </p:txBody>
+      </p:sp>
+    </p:spTree>
+  </p:cSld>
+</p:sld>
+</file>
+
+<file path=ppt/slides/slide24.xml><?xml version="1.0" encoding="utf-8"?>
+<p:sld xmlns:a="http://schemas.openxmlformats.org/drawingml/2006/main" xmlns:r="http://schemas.openxmlformats.org/officeDocument/2006/relationships" xmlns:p="http://schemas.openxmlformats.org/presentationml/2006/main">
+  <p:cSld>
+    <p:spTree>
+      <p:nvGrpSpPr>
+        <p:cNvPr id="1" name=""/>
+        <p:cNvGrpSpPr/>
+        <p:nvPr/>
+      </p:nvGrpSpPr>
+      <p:grpSpPr>
+        <a:xfrm>
+          <a:off x="0" y="0"/>
+          <a:ext cx="0" cy="0"/>
+          <a:chOff x="0" y="0"/>
+          <a:chExt cx="0" cy="0"/>
+        </a:xfrm>
+      </p:grpSpPr>
+      <p:sp>
+        <p:nvSpPr>
+          <p:cNvPr id="2" name="Title 1">
+            <a:extLst>
+              <a:ext uri="{FF2B5EF4-FFF2-40B4-BE49-F238E27FC236}">
+                <a16:creationId xmlns:a16="http://schemas.microsoft.com/office/drawing/2014/main" id="{DC1D1A22-93E7-53F5-3D1C-BA3AE5668A21}"/>
+              </a:ext>
+            </a:extLst>
+          </p:cNvPr>
+          <p:cNvSpPr>
+            <a:spLocks noGrp="1"/>
+          </p:cNvSpPr>
+          <p:nvPr>
+            <p:ph type="title"/>
+          </p:nvPr>
+        </p:nvSpPr>
+        <p:spPr/>
+        <p:txBody>
+          <a:bodyPr/>
+          <a:lstStyle/>
+          <a:p>
+            <a:pPr lvl="0" indent="0" marL="0">
+              <a:buNone/>
+            </a:pPr>
+            <a:r>
+              <a:rPr/>
+              <a:t>Language Models, Chat Systems, and Text Apps</a:t>
+            </a:r>
+          </a:p>
+        </p:txBody>
+      </p:sp>
+      <p:sp>
+        <p:nvSpPr>
+          <p:cNvPr id="3" name="Content Placeholder 2">
+            <a:extLst>
+              <a:ext uri="{FF2B5EF4-FFF2-40B4-BE49-F238E27FC236}">
+                <a16:creationId xmlns:a16="http://schemas.microsoft.com/office/drawing/2014/main" id="{89184A04-97C2-C83B-3F52-CA55E676823D}"/>
+              </a:ext>
+            </a:extLst>
+          </p:cNvPr>
+          <p:cNvSpPr>
+            <a:spLocks noGrp="1"/>
+          </p:cNvSpPr>
+          <p:nvPr>
+            <p:ph idx="1"/>
+          </p:nvPr>
+        </p:nvSpPr>
+        <p:spPr/>
+        <p:txBody>
+          <a:bodyPr/>
+          <a:lstStyle/>
+          <a:p>
+            <a:pPr lvl="0"/>
+            <a:r>
+              <a:rPr/>
+              <a:t>Strong option if you want to build something useful quickly.</a:t>
+            </a:r>
+          </a:p>
+          <a:p>
+            <a:pPr lvl="0"/>
+            <a:r>
+              <a:rPr/>
+              <a:t>Typical tasks:</a:t>
+            </a:r>
+          </a:p>
+          <a:p>
+            <a:pPr lvl="1"/>
+            <a:r>
+              <a:rPr/>
+              <a:t>chatbot</a:t>
+            </a:r>
+          </a:p>
+          <a:p>
+            <a:pPr lvl="1"/>
+            <a:r>
+              <a:rPr/>
+              <a:t>summarization</a:t>
+            </a:r>
+          </a:p>
+          <a:p>
+            <a:pPr lvl="1"/>
+            <a:r>
+              <a:rPr/>
+              <a:t>classification</a:t>
+            </a:r>
+          </a:p>
+          <a:p>
+            <a:pPr lvl="1"/>
+            <a:r>
+              <a:rPr/>
+              <a:t>tool calling</a:t>
+            </a:r>
+          </a:p>
+          <a:p>
+            <a:pPr lvl="1"/>
+            <a:r>
+              <a:rPr/>
+              <a:t>text transformation</a:t>
+            </a:r>
+          </a:p>
+          <a:p>
+            <a:pPr lvl="0"/>
+            <a:r>
+              <a:rPr/>
+              <a:t>Strong frameworks:</a:t>
+            </a:r>
+          </a:p>
+          <a:p>
+            <a:pPr lvl="1"/>
+            <a:r>
+              <a:rPr/>
+              <a:t>Ollama</a:t>
+            </a:r>
+          </a:p>
+          <a:p>
+            <a:pPr lvl="1"/>
+            <a:r>
+              <a:rPr/>
+              <a:t>Transformers</a:t>
+            </a:r>
+          </a:p>
+          <a:p>
+            <a:pPr lvl="1"/>
+            <a:r>
+              <a:rPr/>
+              <a:t>Sentence Transformers</a:t>
+            </a:r>
+          </a:p>
+        </p:txBody>
+      </p:sp>
+    </p:spTree>
+  </p:cSld>
+</p:sld>
+</file>
+
+<file path=ppt/slides/slide25.xml><?xml version="1.0" encoding="utf-8"?>
+<p:sld xmlns:a="http://schemas.openxmlformats.org/drawingml/2006/main" xmlns:r="http://schemas.openxmlformats.org/officeDocument/2006/relationships" xmlns:p="http://schemas.openxmlformats.org/presentationml/2006/main">
+  <p:cSld>
+    <p:spTree>
+      <p:nvGrpSpPr>
+        <p:cNvPr id="1" name=""/>
+        <p:cNvGrpSpPr/>
+        <p:nvPr/>
+      </p:nvGrpSpPr>
+      <p:grpSpPr>
+        <a:xfrm>
+          <a:off x="0" y="0"/>
+          <a:ext cx="0" cy="0"/>
+          <a:chOff x="0" y="0"/>
+          <a:chExt cx="0" cy="0"/>
+        </a:xfrm>
+      </p:grpSpPr>
+      <p:sp>
+        <p:nvSpPr>
+          <p:cNvPr id="2" name="Title 1">
+            <a:extLst>
+              <a:ext uri="{FF2B5EF4-FFF2-40B4-BE49-F238E27FC236}">
+                <a16:creationId xmlns:a16="http://schemas.microsoft.com/office/drawing/2014/main" id="{DC1D1A22-93E7-53F5-3D1C-BA3AE5668A21}"/>
+              </a:ext>
+            </a:extLst>
+          </p:cNvPr>
+          <p:cNvSpPr>
+            <a:spLocks noGrp="1"/>
+          </p:cNvSpPr>
+          <p:nvPr>
+            <p:ph type="title"/>
+          </p:nvPr>
+        </p:nvSpPr>
+        <p:spPr/>
+        <p:txBody>
+          <a:bodyPr/>
+          <a:lstStyle/>
+          <a:p>
+            <a:pPr lvl="0" indent="0" marL="0">
+              <a:buNone/>
+            </a:pPr>
+            <a:r>
+              <a:rPr/>
+              <a:t>Multimodal and Document AI</a:t>
+            </a:r>
+          </a:p>
+        </p:txBody>
+      </p:sp>
+      <p:sp>
+        <p:nvSpPr>
+          <p:cNvPr id="3" name="Content Placeholder 2">
+            <a:extLst>
+              <a:ext uri="{FF2B5EF4-FFF2-40B4-BE49-F238E27FC236}">
+                <a16:creationId xmlns:a16="http://schemas.microsoft.com/office/drawing/2014/main" id="{89184A04-97C2-C83B-3F52-CA55E676823D}"/>
+              </a:ext>
+            </a:extLst>
+          </p:cNvPr>
+          <p:cNvSpPr>
+            <a:spLocks noGrp="1"/>
+          </p:cNvSpPr>
+          <p:nvPr>
+            <p:ph idx="1"/>
+          </p:nvPr>
+        </p:nvSpPr>
+        <p:spPr/>
+        <p:txBody>
+          <a:bodyPr/>
+          <a:lstStyle/>
+          <a:p>
+            <a:pPr lvl="0"/>
+            <a:r>
+              <a:rPr/>
+              <a:t>This is where language meets images, documents, or audio.</a:t>
+            </a:r>
+          </a:p>
+          <a:p>
+            <a:pPr lvl="0"/>
+            <a:r>
+              <a:rPr/>
+              <a:t>Typical tasks:</a:t>
+            </a:r>
+          </a:p>
+          <a:p>
+            <a:pPr lvl="1"/>
+            <a:r>
+              <a:rPr/>
+              <a:t>visual question answering</a:t>
+            </a:r>
+          </a:p>
+          <a:p>
+            <a:pPr lvl="1"/>
+            <a:r>
+              <a:rPr/>
+              <a:t>document understanding</a:t>
+            </a:r>
+          </a:p>
+          <a:p>
+            <a:pPr lvl="1"/>
+            <a:r>
+              <a:rPr/>
+              <a:t>receipt or invoice reading</a:t>
+            </a:r>
+          </a:p>
+          <a:p>
+            <a:pPr lvl="1"/>
+            <a:r>
+              <a:rPr/>
+              <a:t>image-aware assistants</a:t>
+            </a:r>
+          </a:p>
+          <a:p>
+            <a:pPr lvl="0"/>
+            <a:r>
+              <a:rPr/>
+              <a:t>Strong frameworks:</a:t>
+            </a:r>
+          </a:p>
+          <a:p>
+            <a:pPr lvl="1"/>
+            <a:r>
+              <a:rPr/>
+              <a:t>Transformers</a:t>
+            </a:r>
+          </a:p>
+          <a:p>
+            <a:pPr lvl="1"/>
+            <a:r>
+              <a:rPr/>
+              <a:t>vision-capable local models</a:t>
+            </a:r>
+          </a:p>
+          <a:p>
+            <a:pPr lvl="1"/>
+            <a:r>
+              <a:rPr/>
+              <a:t>document tools such as docTR</a:t>
+            </a:r>
+          </a:p>
+        </p:txBody>
+      </p:sp>
+    </p:spTree>
+  </p:cSld>
+</p:sld>
+</file>
+
+<file path=ppt/slides/slide26.xml><?xml version="1.0" encoding="utf-8"?>
+<p:sld xmlns:a="http://schemas.openxmlformats.org/drawingml/2006/main" xmlns:r="http://schemas.openxmlformats.org/officeDocument/2006/relationships" xmlns:p="http://schemas.openxmlformats.org/presentationml/2006/main">
+  <p:cSld>
+    <p:spTree>
+      <p:nvGrpSpPr>
+        <p:cNvPr id="1" name=""/>
+        <p:cNvGrpSpPr/>
+        <p:nvPr/>
+      </p:nvGrpSpPr>
+      <p:grpSpPr>
+        <a:xfrm>
+          <a:off x="0" y="0"/>
+          <a:ext cx="0" cy="0"/>
+          <a:chOff x="0" y="0"/>
+          <a:chExt cx="0" cy="0"/>
+        </a:xfrm>
+      </p:grpSpPr>
+      <p:sp>
+        <p:nvSpPr>
+          <p:cNvPr id="2" name="Title 1">
+            <a:extLst>
+              <a:ext uri="{FF2B5EF4-FFF2-40B4-BE49-F238E27FC236}">
+                <a16:creationId xmlns:a16="http://schemas.microsoft.com/office/drawing/2014/main" id="{DC1D1A22-93E7-53F5-3D1C-BA3AE5668A21}"/>
+              </a:ext>
+            </a:extLst>
+          </p:cNvPr>
+          <p:cNvSpPr>
+            <a:spLocks noGrp="1"/>
+          </p:cNvSpPr>
+          <p:nvPr>
+            <p:ph type="title"/>
+          </p:nvPr>
+        </p:nvSpPr>
+        <p:spPr/>
+        <p:txBody>
+          <a:bodyPr/>
+          <a:lstStyle/>
+          <a:p>
+            <a:pPr lvl="0" indent="0" marL="0">
+              <a:buNone/>
+            </a:pPr>
+            <a:r>
+              <a:rPr/>
+              <a:t>Semantic Search and Retrieval</a:t>
+            </a:r>
+          </a:p>
+        </p:txBody>
+      </p:sp>
+      <p:sp>
+        <p:nvSpPr>
+          <p:cNvPr id="3" name="Content Placeholder 2">
+            <a:extLst>
+              <a:ext uri="{FF2B5EF4-FFF2-40B4-BE49-F238E27FC236}">
+                <a16:creationId xmlns:a16="http://schemas.microsoft.com/office/drawing/2014/main" id="{89184A04-97C2-C83B-3F52-CA55E676823D}"/>
+              </a:ext>
+            </a:extLst>
+          </p:cNvPr>
+          <p:cNvSpPr>
+            <a:spLocks noGrp="1"/>
+          </p:cNvSpPr>
+          <p:nvPr>
+            <p:ph idx="1"/>
+          </p:nvPr>
+        </p:nvSpPr>
+        <p:spPr/>
+        <p:txBody>
+          <a:bodyPr/>
+          <a:lstStyle/>
+          <a:p>
+            <a:pPr lvl="0"/>
+            <a:r>
+              <a:rPr/>
+              <a:t>This is one of the most practical modern AI directions.</a:t>
+            </a:r>
+          </a:p>
+          <a:p>
+            <a:pPr lvl="0"/>
+            <a:r>
+              <a:rPr/>
+              <a:t>It is based on embeddings:</a:t>
+            </a:r>
+          </a:p>
+          <a:p>
+            <a:pPr lvl="1"/>
+            <a:r>
+              <a:rPr/>
+              <a:t>represent items as vectors</a:t>
+            </a:r>
+          </a:p>
+          <a:p>
+            <a:pPr lvl="1"/>
+            <a:r>
+              <a:rPr/>
+              <a:t>compare them by meaning, not only by exact words</a:t>
+            </a:r>
+          </a:p>
+          <a:p>
+            <a:pPr lvl="0"/>
+            <a:r>
+              <a:rPr/>
+              <a:t>Typical projects:</a:t>
+            </a:r>
+          </a:p>
+          <a:p>
+            <a:pPr lvl="1"/>
+            <a:r>
+              <a:rPr/>
+              <a:t>semantic search</a:t>
+            </a:r>
+          </a:p>
+          <a:p>
+            <a:pPr lvl="1"/>
+            <a:r>
+              <a:rPr/>
+              <a:t>retrieval-augmented chatbot</a:t>
+            </a:r>
+          </a:p>
+          <a:p>
+            <a:pPr lvl="1"/>
+            <a:r>
+              <a:rPr/>
+              <a:t>similar-item finder</a:t>
+            </a:r>
+          </a:p>
+        </p:txBody>
+      </p:sp>
+    </p:spTree>
+  </p:cSld>
+</p:sld>
+</file>
+
+<file path=ppt/slides/slide27.xml><?xml version="1.0" encoding="utf-8"?>
+<p:sld xmlns:a="http://schemas.openxmlformats.org/drawingml/2006/main" xmlns:r="http://schemas.openxmlformats.org/officeDocument/2006/relationships" xmlns:p="http://schemas.openxmlformats.org/presentationml/2006/main">
+  <p:cSld>
+    <p:spTree>
+      <p:nvGrpSpPr>
+        <p:cNvPr id="1" name=""/>
+        <p:cNvGrpSpPr/>
+        <p:nvPr/>
+      </p:nvGrpSpPr>
+      <p:grpSpPr>
+        <a:xfrm>
+          <a:off x="0" y="0"/>
+          <a:ext cx="0" cy="0"/>
+          <a:chOff x="0" y="0"/>
+          <a:chExt cx="0" cy="0"/>
+        </a:xfrm>
+      </p:grpSpPr>
+      <p:sp>
+        <p:nvSpPr>
+          <p:cNvPr id="2" name="Title 1">
+            <a:extLst>
+              <a:ext uri="{FF2B5EF4-FFF2-40B4-BE49-F238E27FC236}">
+                <a16:creationId xmlns:a16="http://schemas.microsoft.com/office/drawing/2014/main" id="{DC1D1A22-93E7-53F5-3D1C-BA3AE5668A21}"/>
+              </a:ext>
+            </a:extLst>
+          </p:cNvPr>
+          <p:cNvSpPr>
+            <a:spLocks noGrp="1"/>
+          </p:cNvSpPr>
+          <p:nvPr>
+            <p:ph type="title"/>
+          </p:nvPr>
+        </p:nvSpPr>
+        <p:spPr/>
+        <p:txBody>
+          <a:bodyPr/>
+          <a:lstStyle/>
+          <a:p>
+            <a:pPr lvl="0" indent="0" marL="0">
+              <a:buNone/>
+            </a:pPr>
+            <a:r>
+              <a:rPr/>
+              <a:t>Recommendation Systems</a:t>
+            </a:r>
+          </a:p>
+        </p:txBody>
+      </p:sp>
+      <p:sp>
+        <p:nvSpPr>
+          <p:cNvPr id="3" name="Content Placeholder 2">
+            <a:extLst>
+              <a:ext uri="{FF2B5EF4-FFF2-40B4-BE49-F238E27FC236}">
+                <a16:creationId xmlns:a16="http://schemas.microsoft.com/office/drawing/2014/main" id="{89184A04-97C2-C83B-3F52-CA55E676823D}"/>
+              </a:ext>
+            </a:extLst>
+          </p:cNvPr>
+          <p:cNvSpPr>
+            <a:spLocks noGrp="1"/>
+          </p:cNvSpPr>
+          <p:nvPr>
+            <p:ph idx="1"/>
+          </p:nvPr>
+        </p:nvSpPr>
+        <p:spPr/>
+        <p:txBody>
+          <a:bodyPr/>
+          <a:lstStyle/>
+          <a:p>
+            <a:pPr lvl="0"/>
+            <a:r>
+              <a:rPr/>
+              <a:t>This direction is closely related to embeddings, but the user experience is different from search.</a:t>
+            </a:r>
+          </a:p>
+          <a:p>
+            <a:pPr lvl="0"/>
+            <a:r>
+              <a:rPr/>
+              <a:t>Typical projects:</a:t>
+            </a:r>
+          </a:p>
+          <a:p>
+            <a:pPr lvl="1"/>
+            <a:r>
+              <a:rPr/>
+              <a:t>music or media recommender</a:t>
+            </a:r>
+          </a:p>
+          <a:p>
+            <a:pPr lvl="1"/>
+            <a:r>
+              <a:rPr/>
+              <a:t>product recommendation demo</a:t>
+            </a:r>
+          </a:p>
+          <a:p>
+            <a:pPr lvl="1"/>
+            <a:r>
+              <a:rPr/>
+              <a:t>similar-item recommender</a:t>
+            </a:r>
+          </a:p>
+          <a:p>
+            <a:pPr lvl="1"/>
+            <a:r>
+              <a:rPr/>
+              <a:t>recommendation UI based on embeddings</a:t>
+            </a:r>
+          </a:p>
+        </p:txBody>
+      </p:sp>
+    </p:spTree>
+  </p:cSld>
+</p:sld>
+</file>
+
+<file path=ppt/slides/slide28.xml><?xml version="1.0" encoding="utf-8"?>
 <p:sld xmlns:a="http://schemas.openxmlformats.org/drawingml/2006/main" xmlns:r="http://schemas.openxmlformats.org/officeDocument/2006/relationships" xmlns:p="http://schemas.openxmlformats.org/presentationml/2006/main">
   <p:cSld>
     <p:spTree>
@@ -7180,649 +7349,6 @@
 </p:sld>
 </file>
 
-<file path=ppt/slides/slide24.xml><?xml version="1.0" encoding="utf-8"?>
-<p:sld xmlns:a="http://schemas.openxmlformats.org/drawingml/2006/main" xmlns:r="http://schemas.openxmlformats.org/officeDocument/2006/relationships" xmlns:p="http://schemas.openxmlformats.org/presentationml/2006/main">
-  <p:cSld>
-    <p:spTree>
-      <p:nvGrpSpPr>
-        <p:cNvPr id="1" name=""/>
-        <p:cNvGrpSpPr/>
-        <p:nvPr/>
-      </p:nvGrpSpPr>
-      <p:grpSpPr>
-        <a:xfrm>
-          <a:off x="0" y="0"/>
-          <a:ext cx="0" cy="0"/>
-          <a:chOff x="0" y="0"/>
-          <a:chExt cx="0" cy="0"/>
-        </a:xfrm>
-      </p:grpSpPr>
-      <p:sp>
-        <p:nvSpPr>
-          <p:cNvPr id="2" name="Title 1">
-            <a:extLst>
-              <a:ext uri="{FF2B5EF4-FFF2-40B4-BE49-F238E27FC236}">
-                <a16:creationId xmlns:a16="http://schemas.microsoft.com/office/drawing/2014/main" id="{DC1D1A22-93E7-53F5-3D1C-BA3AE5668A21}"/>
-              </a:ext>
-            </a:extLst>
-          </p:cNvPr>
-          <p:cNvSpPr>
-            <a:spLocks noGrp="1"/>
-          </p:cNvSpPr>
-          <p:nvPr>
-            <p:ph type="title"/>
-          </p:nvPr>
-        </p:nvSpPr>
-        <p:spPr/>
-        <p:txBody>
-          <a:bodyPr/>
-          <a:lstStyle/>
-          <a:p>
-            <a:pPr lvl="0" indent="0" marL="0">
-              <a:buNone/>
-            </a:pPr>
-            <a:r>
-              <a:rPr/>
-              <a:t>Generative Systems Are Cross-Cutting</a:t>
-            </a:r>
-          </a:p>
-        </p:txBody>
-      </p:sp>
-      <p:sp>
-        <p:nvSpPr>
-          <p:cNvPr id="3" name="Content Placeholder 2">
-            <a:extLst>
-              <a:ext uri="{FF2B5EF4-FFF2-40B4-BE49-F238E27FC236}">
-                <a16:creationId xmlns:a16="http://schemas.microsoft.com/office/drawing/2014/main" id="{89184A04-97C2-C83B-3F52-CA55E676823D}"/>
-              </a:ext>
-            </a:extLst>
-          </p:cNvPr>
-          <p:cNvSpPr>
-            <a:spLocks noGrp="1"/>
-          </p:cNvSpPr>
-          <p:nvPr>
-            <p:ph idx="1"/>
-          </p:nvPr>
-        </p:nvSpPr>
-        <p:spPr/>
-        <p:txBody>
-          <a:bodyPr/>
-          <a:lstStyle/>
-          <a:p>
-            <a:pPr lvl="0"/>
-            <a:r>
-              <a:rPr/>
-              <a:t>Generative AI is important, but it is not one single modality.</a:t>
-            </a:r>
-          </a:p>
-          <a:p>
-            <a:pPr lvl="0"/>
-            <a:r>
-              <a:rPr/>
-              <a:t>It can appear in:</a:t>
-            </a:r>
-          </a:p>
-          <a:p>
-            <a:pPr lvl="1"/>
-            <a:r>
-              <a:rPr/>
-              <a:t>text generation</a:t>
-            </a:r>
-          </a:p>
-          <a:p>
-            <a:pPr lvl="1"/>
-            <a:r>
-              <a:rPr/>
-              <a:t>image generation</a:t>
-            </a:r>
-          </a:p>
-          <a:p>
-            <a:pPr lvl="1"/>
-            <a:r>
-              <a:rPr/>
-              <a:t>speech generation</a:t>
-            </a:r>
-          </a:p>
-          <a:p>
-            <a:pPr lvl="1"/>
-            <a:r>
-              <a:rPr/>
-              <a:t>music generation</a:t>
-            </a:r>
-          </a:p>
-          <a:p>
-            <a:pPr lvl="1"/>
-            <a:r>
-              <a:rPr/>
-              <a:t>multimodal generation</a:t>
-            </a:r>
-          </a:p>
-          <a:p>
-            <a:pPr lvl="0"/>
-            <a:r>
-              <a:rPr/>
-              <a:t>So instead of treating it as one separate box, think of it as a </a:t>
-            </a:r>
-            <a:r>
-              <a:rPr b="1"/>
-              <a:t>style of model behavior</a:t>
-            </a:r>
-            <a:r>
-              <a:rPr/>
-              <a:t> across several domains.</a:t>
-            </a:r>
-          </a:p>
-        </p:txBody>
-      </p:sp>
-    </p:spTree>
-  </p:cSld>
-</p:sld>
-</file>
-
-<file path=ppt/slides/slide25.xml><?xml version="1.0" encoding="utf-8"?>
-<p:sld xmlns:a="http://schemas.openxmlformats.org/drawingml/2006/main" xmlns:r="http://schemas.openxmlformats.org/officeDocument/2006/relationships" xmlns:p="http://schemas.openxmlformats.org/presentationml/2006/main">
-  <p:cSld>
-    <p:spTree>
-      <p:nvGrpSpPr>
-        <p:cNvPr id="1" name=""/>
-        <p:cNvGrpSpPr/>
-        <p:nvPr/>
-      </p:nvGrpSpPr>
-      <p:grpSpPr>
-        <a:xfrm>
-          <a:off x="0" y="0"/>
-          <a:ext cx="0" cy="0"/>
-          <a:chOff x="0" y="0"/>
-          <a:chExt cx="0" cy="0"/>
-        </a:xfrm>
-      </p:grpSpPr>
-      <p:sp>
-        <p:nvSpPr>
-          <p:cNvPr id="2" name="Title 1">
-            <a:extLst>
-              <a:ext uri="{FF2B5EF4-FFF2-40B4-BE49-F238E27FC236}">
-                <a16:creationId xmlns:a16="http://schemas.microsoft.com/office/drawing/2014/main" id="{43AED9B2-1B96-B1B6-91DE-ED4F04AF0870}"/>
-              </a:ext>
-            </a:extLst>
-          </p:cNvPr>
-          <p:cNvSpPr>
-            <a:spLocks noGrp="1"/>
-          </p:cNvSpPr>
-          <p:nvPr>
-            <p:ph type="title"/>
-          </p:nvPr>
-        </p:nvSpPr>
-        <p:spPr>
-          <a:xfrm>
-            <a:off x="831851" y="1709740"/>
-            <a:ext cx="10515600" cy="2852737"/>
-          </a:xfrm>
-        </p:spPr>
-        <p:txBody>
-          <a:bodyPr/>
-          <a:lstStyle/>
-          <a:p>
-            <a:pPr lvl="0" indent="0" marL="0">
-              <a:buNone/>
-            </a:pPr>
-            <a:r>
-              <a:rPr/>
-              <a:t>Framework Suggestions</a:t>
-            </a:r>
-          </a:p>
-        </p:txBody>
-      </p:sp>
-    </p:spTree>
-  </p:cSld>
-</p:sld>
-</file>
-
-<file path=ppt/slides/slide26.xml><?xml version="1.0" encoding="utf-8"?>
-<p:sld xmlns:a="http://schemas.openxmlformats.org/drawingml/2006/main" xmlns:r="http://schemas.openxmlformats.org/officeDocument/2006/relationships" xmlns:p="http://schemas.openxmlformats.org/presentationml/2006/main">
-  <p:cSld>
-    <p:spTree>
-      <p:nvGrpSpPr>
-        <p:cNvPr id="1" name=""/>
-        <p:cNvGrpSpPr/>
-        <p:nvPr/>
-      </p:nvGrpSpPr>
-      <p:grpSpPr>
-        <a:xfrm>
-          <a:off x="0" y="0"/>
-          <a:ext cx="0" cy="0"/>
-          <a:chOff x="0" y="0"/>
-          <a:chExt cx="0" cy="0"/>
-        </a:xfrm>
-      </p:grpSpPr>
-      <p:sp>
-        <p:nvSpPr>
-          <p:cNvPr id="2" name="Title 1">
-            <a:extLst>
-              <a:ext uri="{FF2B5EF4-FFF2-40B4-BE49-F238E27FC236}">
-                <a16:creationId xmlns:a16="http://schemas.microsoft.com/office/drawing/2014/main" id="{DC1D1A22-93E7-53F5-3D1C-BA3AE5668A21}"/>
-              </a:ext>
-            </a:extLst>
-          </p:cNvPr>
-          <p:cNvSpPr>
-            <a:spLocks noGrp="1"/>
-          </p:cNvSpPr>
-          <p:nvPr>
-            <p:ph type="title"/>
-          </p:nvPr>
-        </p:nvSpPr>
-        <p:spPr/>
-        <p:txBody>
-          <a:bodyPr/>
-          <a:lstStyle/>
-          <a:p>
-            <a:pPr lvl="0" indent="0" marL="0">
-              <a:buNone/>
-            </a:pPr>
-            <a:r>
-              <a:rPr/>
-              <a:t>Main AI Frameworks Worth Exploring</a:t>
-            </a:r>
-          </a:p>
-        </p:txBody>
-      </p:sp>
-      <p:sp>
-        <p:nvSpPr>
-          <p:cNvPr id="3" name="Content Placeholder 2">
-            <a:extLst>
-              <a:ext uri="{FF2B5EF4-FFF2-40B4-BE49-F238E27FC236}">
-                <a16:creationId xmlns:a16="http://schemas.microsoft.com/office/drawing/2014/main" id="{89184A04-97C2-C83B-3F52-CA55E676823D}"/>
-              </a:ext>
-            </a:extLst>
-          </p:cNvPr>
-          <p:cNvSpPr>
-            <a:spLocks noGrp="1"/>
-          </p:cNvSpPr>
-          <p:nvPr>
-            <p:ph idx="1"/>
-          </p:nvPr>
-        </p:nvSpPr>
-        <p:spPr/>
-        <p:txBody>
-          <a:bodyPr/>
-          <a:lstStyle/>
-          <a:p>
-            <a:pPr lvl="0"/>
-            <a:r>
-              <a:rPr b="1"/>
-              <a:t>PyTorch</a:t>
-            </a:r>
-          </a:p>
-          <a:p>
-            <a:pPr lvl="1"/>
-            <a:r>
-              <a:rPr/>
-              <a:t>best for direct training or retraining</a:t>
-            </a:r>
-          </a:p>
-          <a:p>
-            <a:pPr lvl="0"/>
-            <a:r>
-              <a:rPr b="1"/>
-              <a:t>Transformers</a:t>
-            </a:r>
-          </a:p>
-          <a:p>
-            <a:pPr lvl="1"/>
-            <a:r>
-              <a:rPr/>
-              <a:t>best for pretrained language, multimodal, and speech models</a:t>
-            </a:r>
-          </a:p>
-          <a:p>
-            <a:pPr lvl="0"/>
-            <a:r>
-              <a:rPr b="1"/>
-              <a:t>Diffusers</a:t>
-            </a:r>
-          </a:p>
-          <a:p>
-            <a:pPr lvl="1"/>
-            <a:r>
-              <a:rPr/>
-              <a:t>best for image generation and related workflows</a:t>
-            </a:r>
-          </a:p>
-          <a:p>
-            <a:pPr lvl="0"/>
-            <a:r>
-              <a:rPr b="1"/>
-              <a:t>Sentence Transformers</a:t>
-            </a:r>
-          </a:p>
-          <a:p>
-            <a:pPr lvl="1"/>
-            <a:r>
-              <a:rPr/>
-              <a:t>best for embeddings, retrieval, and recommendation</a:t>
-            </a:r>
-          </a:p>
-          <a:p>
-            <a:pPr lvl="0"/>
-            <a:r>
-              <a:rPr b="1"/>
-              <a:t>Stable-Baselines3</a:t>
-            </a:r>
-          </a:p>
-          <a:p>
-            <a:pPr lvl="1"/>
-            <a:r>
-              <a:rPr/>
-              <a:t>easiest RL starting point</a:t>
-            </a:r>
-          </a:p>
-          <a:p>
-            <a:pPr lvl="0"/>
-            <a:r>
-              <a:rPr b="1"/>
-              <a:t>ONNX Runtime</a:t>
-            </a:r>
-          </a:p>
-          <a:p>
-            <a:pPr lvl="1"/>
-            <a:r>
-              <a:rPr/>
-              <a:t>strong deployment path</a:t>
-            </a:r>
-          </a:p>
-        </p:txBody>
-      </p:sp>
-    </p:spTree>
-  </p:cSld>
-</p:sld>
-</file>
-
-<file path=ppt/slides/slide27.xml><?xml version="1.0" encoding="utf-8"?>
-<p:sld xmlns:a="http://schemas.openxmlformats.org/drawingml/2006/main" xmlns:r="http://schemas.openxmlformats.org/officeDocument/2006/relationships" xmlns:p="http://schemas.openxmlformats.org/presentationml/2006/main">
-  <p:cSld>
-    <p:spTree>
-      <p:nvGrpSpPr>
-        <p:cNvPr id="1" name=""/>
-        <p:cNvGrpSpPr/>
-        <p:nvPr/>
-      </p:nvGrpSpPr>
-      <p:grpSpPr>
-        <a:xfrm>
-          <a:off x="0" y="0"/>
-          <a:ext cx="0" cy="0"/>
-          <a:chOff x="0" y="0"/>
-          <a:chExt cx="0" cy="0"/>
-        </a:xfrm>
-      </p:grpSpPr>
-      <p:sp>
-        <p:nvSpPr>
-          <p:cNvPr id="2" name="Title 1">
-            <a:extLst>
-              <a:ext uri="{FF2B5EF4-FFF2-40B4-BE49-F238E27FC236}">
-                <a16:creationId xmlns:a16="http://schemas.microsoft.com/office/drawing/2014/main" id="{AA599B7A-49D6-747B-0DC1-9468669DED68}"/>
-              </a:ext>
-            </a:extLst>
-          </p:cNvPr>
-          <p:cNvSpPr>
-            <a:spLocks noGrp="1"/>
-          </p:cNvSpPr>
-          <p:nvPr>
-            <p:ph hasCustomPrompt="1" type="title"/>
-          </p:nvPr>
-        </p:nvSpPr>
-        <p:spPr>
-          <a:xfrm>
-            <a:off x="839787" y="363600"/>
-            <a:ext cx="10515600" cy="1324800"/>
-          </a:xfrm>
-        </p:spPr>
-        <p:txBody>
-          <a:bodyPr/>
-          <a:lstStyle/>
-          <a:p>
-            <a:pPr lvl="0" indent="0" marL="0">
-              <a:buNone/>
-            </a:pPr>
-            <a:r>
-              <a:rPr/>
-              <a:t>Supporting Tools</a:t>
-            </a:r>
-          </a:p>
-        </p:txBody>
-      </p:sp>
-      <p:sp>
-        <p:nvSpPr>
-          <p:cNvPr id="4" name="Text Placeholder 3">
-            <a:extLst>
-              <a:ext uri="{FF2B5EF4-FFF2-40B4-BE49-F238E27FC236}">
-                <a16:creationId xmlns:a16="http://schemas.microsoft.com/office/drawing/2014/main" id="{002DFCD0-D549-8541-2E96-5E270DA67E5E}"/>
-              </a:ext>
-            </a:extLst>
-          </p:cNvPr>
-          <p:cNvSpPr>
-            <a:spLocks noGrp="1"/>
-          </p:cNvSpPr>
-          <p:nvPr>
-            <p:ph hasCustomPrompt="1" idx="2" sz="half" type="body"/>
-          </p:nvPr>
-        </p:nvSpPr>
-        <p:spPr/>
-        <p:txBody>
-          <a:bodyPr/>
-          <a:lstStyle/>
-          <a:p>
-            <a:pPr lvl="0"/>
-            <a:r>
-              <a:rPr/>
-              <a:t>These are useful, but they are not the main AI choice:</a:t>
-            </a:r>
-          </a:p>
-          <a:p>
-            <a:pPr lvl="1"/>
-            <a:r>
-              <a:rPr/>
-              <a:t>Gradio</a:t>
-            </a:r>
-          </a:p>
-          <a:p>
-            <a:pPr lvl="1"/>
-            <a:r>
-              <a:rPr/>
-              <a:t>Streamlit</a:t>
-            </a:r>
-          </a:p>
-          <a:p>
-            <a:pPr lvl="1"/>
-            <a:r>
-              <a:rPr/>
-              <a:t>FastAPI</a:t>
-            </a:r>
-          </a:p>
-          <a:p>
-            <a:pPr lvl="0"/>
-            <a:r>
-              <a:rPr/>
-              <a:t>Most of you will probably build some kind of interface.</a:t>
-            </a:r>
-          </a:p>
-          <a:p>
-            <a:pPr lvl="0"/>
-            <a:r>
-              <a:rPr/>
-              <a:t>Gradio is a very good default if you want to move fast.</a:t>
-            </a:r>
-          </a:p>
-        </p:txBody>
-      </p:sp>
-      <p:pic>
-        <p:nvPicPr>
-          <p:cNvPr descr="media/frontend-user-interfaces.jpg" id="0" name="Picture 1"/>
-          <p:cNvPicPr>
-            <a:picLocks noGrp="1" noChangeAspect="1"/>
-          </p:cNvPicPr>
-          <p:nvPr/>
-        </p:nvPicPr>
-        <p:blipFill>
-          <a:blip r:embed="rId2"/>
-          <a:stretch>
-            <a:fillRect/>
-          </a:stretch>
-        </p:blipFill>
-        <p:spPr bwMode="auto">
-          <a:xfrm>
-            <a:off x="7556500" y="3251200"/>
-            <a:ext cx="4394200" cy="2933700"/>
-          </a:xfrm>
-          <a:prstGeom prst="rect">
-            <a:avLst/>
-          </a:prstGeom>
-          <a:noFill/>
-          <a:ln w="9525">
-            <a:noFill/>
-            <a:headEnd/>
-            <a:tailEnd/>
-          </a:ln>
-        </p:spPr>
-      </p:pic>
-    </p:spTree>
-  </p:cSld>
-</p:sld>
-</file>
-
-<file path=ppt/slides/slide28.xml><?xml version="1.0" encoding="utf-8"?>
-<p:sld xmlns:a="http://schemas.openxmlformats.org/drawingml/2006/main" xmlns:r="http://schemas.openxmlformats.org/officeDocument/2006/relationships" xmlns:p="http://schemas.openxmlformats.org/presentationml/2006/main">
-  <p:cSld>
-    <p:spTree>
-      <p:nvGrpSpPr>
-        <p:cNvPr id="1" name=""/>
-        <p:cNvGrpSpPr/>
-        <p:nvPr/>
-      </p:nvGrpSpPr>
-      <p:grpSpPr>
-        <a:xfrm>
-          <a:off x="0" y="0"/>
-          <a:ext cx="0" cy="0"/>
-          <a:chOff x="0" y="0"/>
-          <a:chExt cx="0" cy="0"/>
-        </a:xfrm>
-      </p:grpSpPr>
-      <p:sp>
-        <p:nvSpPr>
-          <p:cNvPr id="2" name="Title 1">
-            <a:extLst>
-              <a:ext uri="{FF2B5EF4-FFF2-40B4-BE49-F238E27FC236}">
-                <a16:creationId xmlns:a16="http://schemas.microsoft.com/office/drawing/2014/main" id="{DC1D1A22-93E7-53F5-3D1C-BA3AE5668A21}"/>
-              </a:ext>
-            </a:extLst>
-          </p:cNvPr>
-          <p:cNvSpPr>
-            <a:spLocks noGrp="1"/>
-          </p:cNvSpPr>
-          <p:nvPr>
-            <p:ph type="title"/>
-          </p:nvPr>
-        </p:nvSpPr>
-        <p:spPr/>
-        <p:txBody>
-          <a:bodyPr/>
-          <a:lstStyle/>
-          <a:p>
-            <a:pPr lvl="0" indent="0" marL="0">
-              <a:buNone/>
-            </a:pPr>
-            <a:r>
-              <a:rPr/>
-              <a:t>My Recommendation If You Are Unsure</a:t>
-            </a:r>
-          </a:p>
-        </p:txBody>
-      </p:sp>
-      <p:sp>
-        <p:nvSpPr>
-          <p:cNvPr id="3" name="Content Placeholder 2">
-            <a:extLst>
-              <a:ext uri="{FF2B5EF4-FFF2-40B4-BE49-F238E27FC236}">
-                <a16:creationId xmlns:a16="http://schemas.microsoft.com/office/drawing/2014/main" id="{89184A04-97C2-C83B-3F52-CA55E676823D}"/>
-              </a:ext>
-            </a:extLst>
-          </p:cNvPr>
-          <p:cNvSpPr>
-            <a:spLocks noGrp="1"/>
-          </p:cNvSpPr>
-          <p:nvPr>
-            <p:ph idx="1"/>
-          </p:nvPr>
-        </p:nvSpPr>
-        <p:spPr/>
-        <p:txBody>
-          <a:bodyPr/>
-          <a:lstStyle/>
-          <a:p>
-            <a:pPr lvl="0" indent="0" marL="0">
-              <a:buNone/>
-            </a:pPr>
-            <a:r>
-              <a:rPr/>
-              <a:t>Start with one of these:</a:t>
-            </a:r>
-          </a:p>
-          <a:p>
-            <a:pPr lvl="0"/>
-            <a:r>
-              <a:rPr/>
-              <a:t>a computer vision app with YOLO or RF-DETR</a:t>
-            </a:r>
-          </a:p>
-          <a:p>
-            <a:pPr lvl="0"/>
-            <a:r>
-              <a:rPr/>
-              <a:t>an LLM app with Ollama or Transformers</a:t>
-            </a:r>
-          </a:p>
-          <a:p>
-            <a:pPr lvl="0"/>
-            <a:r>
-              <a:rPr/>
-              <a:t>a semantic search app with Sentence Transformers</a:t>
-            </a:r>
-          </a:p>
-          <a:p>
-            <a:pPr lvl="0"/>
-            <a:r>
-              <a:rPr/>
-              <a:t>a recommendation app with Sentence Transformers</a:t>
-            </a:r>
-          </a:p>
-          <a:p>
-            <a:pPr lvl="0"/>
-            <a:r>
-              <a:rPr/>
-              <a:t>a speech tool</a:t>
-            </a:r>
-          </a:p>
-          <a:p>
-            <a:pPr lvl="0"/>
-            <a:r>
-              <a:rPr/>
-              <a:t>an edge deployment project with a ready model</a:t>
-            </a:r>
-          </a:p>
-          <a:p>
-            <a:pPr lvl="0" indent="0" marL="0">
-              <a:buNone/>
-            </a:pPr>
-            <a:r>
-              <a:rPr/>
-              <a:t>These are usually easier to scope well than reinforcement learning or large-model fine-tuning.</a:t>
-            </a:r>
-          </a:p>
-        </p:txBody>
-      </p:sp>
-    </p:spTree>
-  </p:cSld>
-</p:sld>
-</file>
-
 <file path=ppt/slides/slide29.xml><?xml version="1.0" encoding="utf-8"?>
 <p:sld xmlns:a="http://schemas.openxmlformats.org/drawingml/2006/main" xmlns:r="http://schemas.openxmlformats.org/officeDocument/2006/relationships" xmlns:p="http://schemas.openxmlformats.org/presentationml/2006/main">
   <p:cSld>
@@ -7845,7 +7371,7 @@
           <p:cNvPr id="2" name="Title 1">
             <a:extLst>
               <a:ext uri="{FF2B5EF4-FFF2-40B4-BE49-F238E27FC236}">
-                <a16:creationId xmlns:a16="http://schemas.microsoft.com/office/drawing/2014/main" id="{43AED9B2-1B96-B1B6-91DE-ED4F04AF0870}"/>
+                <a16:creationId xmlns:a16="http://schemas.microsoft.com/office/drawing/2014/main" id="{DC1D1A22-93E7-53F5-3D1C-BA3AE5668A21}"/>
               </a:ext>
             </a:extLst>
           </p:cNvPr>
@@ -7856,12 +7382,7 @@
             <p:ph type="title"/>
           </p:nvPr>
         </p:nvSpPr>
-        <p:spPr>
-          <a:xfrm>
-            <a:off x="831851" y="1709740"/>
-            <a:ext cx="10515600" cy="2852737"/>
-          </a:xfrm>
-        </p:spPr>
+        <p:spPr/>
         <p:txBody>
           <a:bodyPr/>
           <a:lstStyle/>
@@ -7871,7 +7392,93 @@
             </a:pPr>
             <a:r>
               <a:rPr/>
-              <a:t>Final Expectations</a:t>
+              <a:t>Generative Systems Are Cross-Cutting</a:t>
+            </a:r>
+          </a:p>
+        </p:txBody>
+      </p:sp>
+      <p:sp>
+        <p:nvSpPr>
+          <p:cNvPr id="3" name="Content Placeholder 2">
+            <a:extLst>
+              <a:ext uri="{FF2B5EF4-FFF2-40B4-BE49-F238E27FC236}">
+                <a16:creationId xmlns:a16="http://schemas.microsoft.com/office/drawing/2014/main" id="{89184A04-97C2-C83B-3F52-CA55E676823D}"/>
+              </a:ext>
+            </a:extLst>
+          </p:cNvPr>
+          <p:cNvSpPr>
+            <a:spLocks noGrp="1"/>
+          </p:cNvSpPr>
+          <p:nvPr>
+            <p:ph idx="1"/>
+          </p:nvPr>
+        </p:nvSpPr>
+        <p:spPr/>
+        <p:txBody>
+          <a:bodyPr/>
+          <a:lstStyle/>
+          <a:p>
+            <a:pPr lvl="0"/>
+            <a:r>
+              <a:rPr/>
+              <a:t>Generative AI is important, but it is not one single modality.</a:t>
+            </a:r>
+          </a:p>
+          <a:p>
+            <a:pPr lvl="0"/>
+            <a:r>
+              <a:rPr/>
+              <a:t>It can appear in:</a:t>
+            </a:r>
+          </a:p>
+          <a:p>
+            <a:pPr lvl="1"/>
+            <a:r>
+              <a:rPr/>
+              <a:t>text generation</a:t>
+            </a:r>
+          </a:p>
+          <a:p>
+            <a:pPr lvl="1"/>
+            <a:r>
+              <a:rPr/>
+              <a:t>image generation</a:t>
+            </a:r>
+          </a:p>
+          <a:p>
+            <a:pPr lvl="1"/>
+            <a:r>
+              <a:rPr/>
+              <a:t>speech generation</a:t>
+            </a:r>
+          </a:p>
+          <a:p>
+            <a:pPr lvl="1"/>
+            <a:r>
+              <a:rPr/>
+              <a:t>music generation</a:t>
+            </a:r>
+          </a:p>
+          <a:p>
+            <a:pPr lvl="1"/>
+            <a:r>
+              <a:rPr/>
+              <a:t>multimodal generation</a:t>
+            </a:r>
+          </a:p>
+          <a:p>
+            <a:pPr lvl="0"/>
+            <a:r>
+              <a:rPr/>
+              <a:t>So instead of treating it as one separate box, think of it as a </a:t>
+            </a:r>
+            <a:r>
+              <a:rPr b="1"/>
+              <a:t>style of model behavior</a:t>
+            </a:r>
+            <a:r>
+              <a:rPr/>
+              <a:t> across several domains.</a:t>
             </a:r>
           </a:p>
         </p:txBody>
@@ -8063,7 +7670,7 @@
           <p:cNvPr id="2" name="Title 1">
             <a:extLst>
               <a:ext uri="{FF2B5EF4-FFF2-40B4-BE49-F238E27FC236}">
-                <a16:creationId xmlns:a16="http://schemas.microsoft.com/office/drawing/2014/main" id="{DC1D1A22-93E7-53F5-3D1C-BA3AE5668A21}"/>
+                <a16:creationId xmlns:a16="http://schemas.microsoft.com/office/drawing/2014/main" id="{43AED9B2-1B96-B1B6-91DE-ED4F04AF0870}"/>
               </a:ext>
             </a:extLst>
           </p:cNvPr>
@@ -8074,7 +7681,12 @@
             <p:ph type="title"/>
           </p:nvPr>
         </p:nvSpPr>
-        <p:spPr/>
+        <p:spPr>
+          <a:xfrm>
+            <a:off x="831851" y="1709740"/>
+            <a:ext cx="10515600" cy="2852737"/>
+          </a:xfrm>
+        </p:spPr>
         <p:txBody>
           <a:bodyPr/>
           <a:lstStyle/>
@@ -8084,71 +7696,7 @@
             </a:pPr>
             <a:r>
               <a:rPr/>
-              <a:t>What I Want to See</a:t>
-            </a:r>
-          </a:p>
-        </p:txBody>
-      </p:sp>
-      <p:sp>
-        <p:nvSpPr>
-          <p:cNvPr id="3" name="Content Placeholder 2">
-            <a:extLst>
-              <a:ext uri="{FF2B5EF4-FFF2-40B4-BE49-F238E27FC236}">
-                <a16:creationId xmlns:a16="http://schemas.microsoft.com/office/drawing/2014/main" id="{89184A04-97C2-C83B-3F52-CA55E676823D}"/>
-              </a:ext>
-            </a:extLst>
-          </p:cNvPr>
-          <p:cNvSpPr>
-            <a:spLocks noGrp="1"/>
-          </p:cNvSpPr>
-          <p:nvPr>
-            <p:ph idx="1"/>
-          </p:nvPr>
-        </p:nvSpPr>
-        <p:spPr/>
-        <p:txBody>
-          <a:bodyPr/>
-          <a:lstStyle/>
-          <a:p>
-            <a:pPr lvl="0"/>
-            <a:r>
-              <a:rPr/>
-              <a:t>a unique project</a:t>
-            </a:r>
-          </a:p>
-          <a:p>
-            <a:pPr lvl="0"/>
-            <a:r>
-              <a:rPr/>
-              <a:t>a clear technical path</a:t>
-            </a:r>
-          </a:p>
-          <a:p>
-            <a:pPr lvl="0"/>
-            <a:r>
-              <a:rPr/>
-              <a:t>one main framework stack</a:t>
-            </a:r>
-          </a:p>
-          <a:p>
-            <a:pPr lvl="0"/>
-            <a:r>
-              <a:rPr/>
-              <a:t>visible effort</a:t>
-            </a:r>
-          </a:p>
-          <a:p>
-            <a:pPr lvl="0"/>
-            <a:r>
-              <a:rPr/>
-              <a:t>a working demo or prototype</a:t>
-            </a:r>
-          </a:p>
-          <a:p>
-            <a:pPr lvl="0"/>
-            <a:r>
-              <a:rPr/>
-              <a:t>understanding of the code and architecture</a:t>
+              <a:t>Framework Suggestions</a:t>
             </a:r>
           </a:p>
         </p:txBody>
@@ -8201,7 +7749,7 @@
             </a:pPr>
             <a:r>
               <a:rPr/>
-              <a:t>Final Message</a:t>
+              <a:t>Main AI Frameworks Worth Exploring</a:t>
             </a:r>
           </a:p>
         </p:txBody>
@@ -8229,43 +7777,85 @@
           <a:p>
             <a:pPr lvl="0"/>
             <a:r>
-              <a:rPr/>
-              <a:t>Deep learning is a very broad field.</a:t>
-            </a:r>
-          </a:p>
-          <a:p>
-            <a:pPr lvl="0"/>
-            <a:r>
-              <a:rPr/>
-              <a:t>You do not need to master all of it in this course.</a:t>
-            </a:r>
-          </a:p>
-          <a:p>
-            <a:pPr lvl="0"/>
-            <a:r>
-              <a:rPr/>
-              <a:t>But I want you to leave this course with:</a:t>
+              <a:rPr b="1"/>
+              <a:t>PyTorch</a:t>
             </a:r>
           </a:p>
           <a:p>
             <a:pPr lvl="1"/>
             <a:r>
               <a:rPr/>
-              <a:t>a better map of the field</a:t>
+              <a:t>best for direct training or retraining</a:t>
+            </a:r>
+          </a:p>
+          <a:p>
+            <a:pPr lvl="0"/>
+            <a:r>
+              <a:rPr b="1"/>
+              <a:t>Transformers</a:t>
             </a:r>
           </a:p>
           <a:p>
             <a:pPr lvl="1"/>
             <a:r>
               <a:rPr/>
-              <a:t>experience building one real AI system</a:t>
+              <a:t>best for pretrained language, multimodal, and speech models</a:t>
+            </a:r>
+          </a:p>
+          <a:p>
+            <a:pPr lvl="0"/>
+            <a:r>
+              <a:rPr b="1"/>
+              <a:t>Diffusers</a:t>
             </a:r>
           </a:p>
           <a:p>
             <a:pPr lvl="1"/>
             <a:r>
               <a:rPr/>
-              <a:t>confidence that you can learn a new framework on your own</a:t>
+              <a:t>best for image generation and related workflows</a:t>
+            </a:r>
+          </a:p>
+          <a:p>
+            <a:pPr lvl="0"/>
+            <a:r>
+              <a:rPr b="1"/>
+              <a:t>Sentence Transformers</a:t>
+            </a:r>
+          </a:p>
+          <a:p>
+            <a:pPr lvl="1"/>
+            <a:r>
+              <a:rPr/>
+              <a:t>best for embeddings, retrieval, and recommendation</a:t>
+            </a:r>
+          </a:p>
+          <a:p>
+            <a:pPr lvl="0"/>
+            <a:r>
+              <a:rPr b="1"/>
+              <a:t>Stable-Baselines3</a:t>
+            </a:r>
+          </a:p>
+          <a:p>
+            <a:pPr lvl="1"/>
+            <a:r>
+              <a:rPr/>
+              <a:t>easiest RL starting point</a:t>
+            </a:r>
+          </a:p>
+          <a:p>
+            <a:pPr lvl="0"/>
+            <a:r>
+              <a:rPr b="1"/>
+              <a:t>ONNX Runtime</a:t>
+            </a:r>
+          </a:p>
+          <a:p>
+            <a:pPr lvl="1"/>
+            <a:r>
+              <a:rPr/>
+              <a:t>strong deployment path</a:t>
             </a:r>
           </a:p>
         </p:txBody>
@@ -8276,6 +7866,585 @@
 </file>
 
 <file path=ppt/slides/slide32.xml><?xml version="1.0" encoding="utf-8"?>
+<p:sld xmlns:a="http://schemas.openxmlformats.org/drawingml/2006/main" xmlns:r="http://schemas.openxmlformats.org/officeDocument/2006/relationships" xmlns:p="http://schemas.openxmlformats.org/presentationml/2006/main">
+  <p:cSld>
+    <p:spTree>
+      <p:nvGrpSpPr>
+        <p:cNvPr id="1" name=""/>
+        <p:cNvGrpSpPr/>
+        <p:nvPr/>
+      </p:nvGrpSpPr>
+      <p:grpSpPr>
+        <a:xfrm>
+          <a:off x="0" y="0"/>
+          <a:ext cx="0" cy="0"/>
+          <a:chOff x="0" y="0"/>
+          <a:chExt cx="0" cy="0"/>
+        </a:xfrm>
+      </p:grpSpPr>
+      <p:sp>
+        <p:nvSpPr>
+          <p:cNvPr id="2" name="Title 1">
+            <a:extLst>
+              <a:ext uri="{FF2B5EF4-FFF2-40B4-BE49-F238E27FC236}">
+                <a16:creationId xmlns:a16="http://schemas.microsoft.com/office/drawing/2014/main" id="{AA599B7A-49D6-747B-0DC1-9468669DED68}"/>
+              </a:ext>
+            </a:extLst>
+          </p:cNvPr>
+          <p:cNvSpPr>
+            <a:spLocks noGrp="1"/>
+          </p:cNvSpPr>
+          <p:nvPr>
+            <p:ph hasCustomPrompt="1" type="title"/>
+          </p:nvPr>
+        </p:nvSpPr>
+        <p:spPr>
+          <a:xfrm>
+            <a:off x="839787" y="363600"/>
+            <a:ext cx="10515600" cy="1324800"/>
+          </a:xfrm>
+        </p:spPr>
+        <p:txBody>
+          <a:bodyPr/>
+          <a:lstStyle/>
+          <a:p>
+            <a:pPr lvl="0" indent="0" marL="0">
+              <a:buNone/>
+            </a:pPr>
+            <a:r>
+              <a:rPr/>
+              <a:t>Supporting Tools</a:t>
+            </a:r>
+          </a:p>
+        </p:txBody>
+      </p:sp>
+      <p:sp>
+        <p:nvSpPr>
+          <p:cNvPr id="4" name="Text Placeholder 3">
+            <a:extLst>
+              <a:ext uri="{FF2B5EF4-FFF2-40B4-BE49-F238E27FC236}">
+                <a16:creationId xmlns:a16="http://schemas.microsoft.com/office/drawing/2014/main" id="{002DFCD0-D549-8541-2E96-5E270DA67E5E}"/>
+              </a:ext>
+            </a:extLst>
+          </p:cNvPr>
+          <p:cNvSpPr>
+            <a:spLocks noGrp="1"/>
+          </p:cNvSpPr>
+          <p:nvPr>
+            <p:ph hasCustomPrompt="1" idx="2" sz="half" type="body"/>
+          </p:nvPr>
+        </p:nvSpPr>
+        <p:spPr/>
+        <p:txBody>
+          <a:bodyPr/>
+          <a:lstStyle/>
+          <a:p>
+            <a:pPr lvl="0"/>
+            <a:r>
+              <a:rPr/>
+              <a:t>These are useful, but they are not the main AI choice:</a:t>
+            </a:r>
+          </a:p>
+          <a:p>
+            <a:pPr lvl="1"/>
+            <a:r>
+              <a:rPr/>
+              <a:t>Gradio</a:t>
+            </a:r>
+          </a:p>
+          <a:p>
+            <a:pPr lvl="1"/>
+            <a:r>
+              <a:rPr/>
+              <a:t>Streamlit</a:t>
+            </a:r>
+          </a:p>
+          <a:p>
+            <a:pPr lvl="1"/>
+            <a:r>
+              <a:rPr/>
+              <a:t>FastAPI</a:t>
+            </a:r>
+          </a:p>
+          <a:p>
+            <a:pPr lvl="0"/>
+            <a:r>
+              <a:rPr/>
+              <a:t>Most of you will probably build some kind of interface.</a:t>
+            </a:r>
+          </a:p>
+          <a:p>
+            <a:pPr lvl="0"/>
+            <a:r>
+              <a:rPr/>
+              <a:t>Gradio is a very good default if you want to move fast.</a:t>
+            </a:r>
+          </a:p>
+        </p:txBody>
+      </p:sp>
+      <p:pic>
+        <p:nvPicPr>
+          <p:cNvPr descr="media/frontend-user-interfaces.jpg" id="0" name="Picture 1"/>
+          <p:cNvPicPr>
+            <a:picLocks noGrp="1" noChangeAspect="1"/>
+          </p:cNvPicPr>
+          <p:nvPr/>
+        </p:nvPicPr>
+        <p:blipFill>
+          <a:blip r:embed="rId2"/>
+          <a:stretch>
+            <a:fillRect/>
+          </a:stretch>
+        </p:blipFill>
+        <p:spPr bwMode="auto">
+          <a:xfrm>
+            <a:off x="7556500" y="3251200"/>
+            <a:ext cx="4394200" cy="2933700"/>
+          </a:xfrm>
+          <a:prstGeom prst="rect">
+            <a:avLst/>
+          </a:prstGeom>
+          <a:noFill/>
+          <a:ln w="9525">
+            <a:noFill/>
+            <a:headEnd/>
+            <a:tailEnd/>
+          </a:ln>
+        </p:spPr>
+      </p:pic>
+    </p:spTree>
+  </p:cSld>
+</p:sld>
+</file>
+
+<file path=ppt/slides/slide33.xml><?xml version="1.0" encoding="utf-8"?>
+<p:sld xmlns:a="http://schemas.openxmlformats.org/drawingml/2006/main" xmlns:r="http://schemas.openxmlformats.org/officeDocument/2006/relationships" xmlns:p="http://schemas.openxmlformats.org/presentationml/2006/main">
+  <p:cSld>
+    <p:spTree>
+      <p:nvGrpSpPr>
+        <p:cNvPr id="1" name=""/>
+        <p:cNvGrpSpPr/>
+        <p:nvPr/>
+      </p:nvGrpSpPr>
+      <p:grpSpPr>
+        <a:xfrm>
+          <a:off x="0" y="0"/>
+          <a:ext cx="0" cy="0"/>
+          <a:chOff x="0" y="0"/>
+          <a:chExt cx="0" cy="0"/>
+        </a:xfrm>
+      </p:grpSpPr>
+      <p:sp>
+        <p:nvSpPr>
+          <p:cNvPr id="2" name="Title 1">
+            <a:extLst>
+              <a:ext uri="{FF2B5EF4-FFF2-40B4-BE49-F238E27FC236}">
+                <a16:creationId xmlns:a16="http://schemas.microsoft.com/office/drawing/2014/main" id="{DC1D1A22-93E7-53F5-3D1C-BA3AE5668A21}"/>
+              </a:ext>
+            </a:extLst>
+          </p:cNvPr>
+          <p:cNvSpPr>
+            <a:spLocks noGrp="1"/>
+          </p:cNvSpPr>
+          <p:nvPr>
+            <p:ph type="title"/>
+          </p:nvPr>
+        </p:nvSpPr>
+        <p:spPr/>
+        <p:txBody>
+          <a:bodyPr/>
+          <a:lstStyle/>
+          <a:p>
+            <a:pPr lvl="0" indent="0" marL="0">
+              <a:buNone/>
+            </a:pPr>
+            <a:r>
+              <a:rPr/>
+              <a:t>My Recommendation If You Are Unsure</a:t>
+            </a:r>
+          </a:p>
+        </p:txBody>
+      </p:sp>
+      <p:sp>
+        <p:nvSpPr>
+          <p:cNvPr id="3" name="Content Placeholder 2">
+            <a:extLst>
+              <a:ext uri="{FF2B5EF4-FFF2-40B4-BE49-F238E27FC236}">
+                <a16:creationId xmlns:a16="http://schemas.microsoft.com/office/drawing/2014/main" id="{89184A04-97C2-C83B-3F52-CA55E676823D}"/>
+              </a:ext>
+            </a:extLst>
+          </p:cNvPr>
+          <p:cNvSpPr>
+            <a:spLocks noGrp="1"/>
+          </p:cNvSpPr>
+          <p:nvPr>
+            <p:ph idx="1"/>
+          </p:nvPr>
+        </p:nvSpPr>
+        <p:spPr/>
+        <p:txBody>
+          <a:bodyPr/>
+          <a:lstStyle/>
+          <a:p>
+            <a:pPr lvl="0" indent="0" marL="0">
+              <a:buNone/>
+            </a:pPr>
+            <a:r>
+              <a:rPr/>
+              <a:t>Start with one of these:</a:t>
+            </a:r>
+          </a:p>
+          <a:p>
+            <a:pPr lvl="0"/>
+            <a:r>
+              <a:rPr/>
+              <a:t>a computer vision app with YOLO or RF-DETR</a:t>
+            </a:r>
+          </a:p>
+          <a:p>
+            <a:pPr lvl="0"/>
+            <a:r>
+              <a:rPr/>
+              <a:t>an LLM app with Ollama or Transformers</a:t>
+            </a:r>
+          </a:p>
+          <a:p>
+            <a:pPr lvl="0"/>
+            <a:r>
+              <a:rPr/>
+              <a:t>a semantic search app with Sentence Transformers</a:t>
+            </a:r>
+          </a:p>
+          <a:p>
+            <a:pPr lvl="0"/>
+            <a:r>
+              <a:rPr/>
+              <a:t>a recommendation app with Sentence Transformers</a:t>
+            </a:r>
+          </a:p>
+          <a:p>
+            <a:pPr lvl="0"/>
+            <a:r>
+              <a:rPr/>
+              <a:t>a speech tool</a:t>
+            </a:r>
+          </a:p>
+          <a:p>
+            <a:pPr lvl="0"/>
+            <a:r>
+              <a:rPr/>
+              <a:t>an edge deployment project with a ready model</a:t>
+            </a:r>
+          </a:p>
+          <a:p>
+            <a:pPr lvl="0" indent="0" marL="0">
+              <a:buNone/>
+            </a:pPr>
+            <a:r>
+              <a:rPr/>
+              <a:t>These are usually easier to scope well than reinforcement learning or large-model fine-tuning.</a:t>
+            </a:r>
+          </a:p>
+        </p:txBody>
+      </p:sp>
+    </p:spTree>
+  </p:cSld>
+</p:sld>
+</file>
+
+<file path=ppt/slides/slide34.xml><?xml version="1.0" encoding="utf-8"?>
+<p:sld xmlns:a="http://schemas.openxmlformats.org/drawingml/2006/main" xmlns:r="http://schemas.openxmlformats.org/officeDocument/2006/relationships" xmlns:p="http://schemas.openxmlformats.org/presentationml/2006/main">
+  <p:cSld>
+    <p:spTree>
+      <p:nvGrpSpPr>
+        <p:cNvPr id="1" name=""/>
+        <p:cNvGrpSpPr/>
+        <p:nvPr/>
+      </p:nvGrpSpPr>
+      <p:grpSpPr>
+        <a:xfrm>
+          <a:off x="0" y="0"/>
+          <a:ext cx="0" cy="0"/>
+          <a:chOff x="0" y="0"/>
+          <a:chExt cx="0" cy="0"/>
+        </a:xfrm>
+      </p:grpSpPr>
+      <p:sp>
+        <p:nvSpPr>
+          <p:cNvPr id="2" name="Title 1">
+            <a:extLst>
+              <a:ext uri="{FF2B5EF4-FFF2-40B4-BE49-F238E27FC236}">
+                <a16:creationId xmlns:a16="http://schemas.microsoft.com/office/drawing/2014/main" id="{43AED9B2-1B96-B1B6-91DE-ED4F04AF0870}"/>
+              </a:ext>
+            </a:extLst>
+          </p:cNvPr>
+          <p:cNvSpPr>
+            <a:spLocks noGrp="1"/>
+          </p:cNvSpPr>
+          <p:nvPr>
+            <p:ph type="title"/>
+          </p:nvPr>
+        </p:nvSpPr>
+        <p:spPr>
+          <a:xfrm>
+            <a:off x="831851" y="1709740"/>
+            <a:ext cx="10515600" cy="2852737"/>
+          </a:xfrm>
+        </p:spPr>
+        <p:txBody>
+          <a:bodyPr/>
+          <a:lstStyle/>
+          <a:p>
+            <a:pPr lvl="0" indent="0" marL="0">
+              <a:buNone/>
+            </a:pPr>
+            <a:r>
+              <a:rPr/>
+              <a:t>Final Expectations</a:t>
+            </a:r>
+          </a:p>
+        </p:txBody>
+      </p:sp>
+    </p:spTree>
+  </p:cSld>
+</p:sld>
+</file>
+
+<file path=ppt/slides/slide35.xml><?xml version="1.0" encoding="utf-8"?>
+<p:sld xmlns:a="http://schemas.openxmlformats.org/drawingml/2006/main" xmlns:r="http://schemas.openxmlformats.org/officeDocument/2006/relationships" xmlns:p="http://schemas.openxmlformats.org/presentationml/2006/main">
+  <p:cSld>
+    <p:spTree>
+      <p:nvGrpSpPr>
+        <p:cNvPr id="1" name=""/>
+        <p:cNvGrpSpPr/>
+        <p:nvPr/>
+      </p:nvGrpSpPr>
+      <p:grpSpPr>
+        <a:xfrm>
+          <a:off x="0" y="0"/>
+          <a:ext cx="0" cy="0"/>
+          <a:chOff x="0" y="0"/>
+          <a:chExt cx="0" cy="0"/>
+        </a:xfrm>
+      </p:grpSpPr>
+      <p:sp>
+        <p:nvSpPr>
+          <p:cNvPr id="2" name="Title 1">
+            <a:extLst>
+              <a:ext uri="{FF2B5EF4-FFF2-40B4-BE49-F238E27FC236}">
+                <a16:creationId xmlns:a16="http://schemas.microsoft.com/office/drawing/2014/main" id="{DC1D1A22-93E7-53F5-3D1C-BA3AE5668A21}"/>
+              </a:ext>
+            </a:extLst>
+          </p:cNvPr>
+          <p:cNvSpPr>
+            <a:spLocks noGrp="1"/>
+          </p:cNvSpPr>
+          <p:nvPr>
+            <p:ph type="title"/>
+          </p:nvPr>
+        </p:nvSpPr>
+        <p:spPr/>
+        <p:txBody>
+          <a:bodyPr/>
+          <a:lstStyle/>
+          <a:p>
+            <a:pPr lvl="0" indent="0" marL="0">
+              <a:buNone/>
+            </a:pPr>
+            <a:r>
+              <a:rPr/>
+              <a:t>What I Want to See</a:t>
+            </a:r>
+          </a:p>
+        </p:txBody>
+      </p:sp>
+      <p:sp>
+        <p:nvSpPr>
+          <p:cNvPr id="3" name="Content Placeholder 2">
+            <a:extLst>
+              <a:ext uri="{FF2B5EF4-FFF2-40B4-BE49-F238E27FC236}">
+                <a16:creationId xmlns:a16="http://schemas.microsoft.com/office/drawing/2014/main" id="{89184A04-97C2-C83B-3F52-CA55E676823D}"/>
+              </a:ext>
+            </a:extLst>
+          </p:cNvPr>
+          <p:cNvSpPr>
+            <a:spLocks noGrp="1"/>
+          </p:cNvSpPr>
+          <p:nvPr>
+            <p:ph idx="1"/>
+          </p:nvPr>
+        </p:nvSpPr>
+        <p:spPr/>
+        <p:txBody>
+          <a:bodyPr/>
+          <a:lstStyle/>
+          <a:p>
+            <a:pPr lvl="0"/>
+            <a:r>
+              <a:rPr/>
+              <a:t>a unique project</a:t>
+            </a:r>
+          </a:p>
+          <a:p>
+            <a:pPr lvl="0"/>
+            <a:r>
+              <a:rPr/>
+              <a:t>a clear technical path</a:t>
+            </a:r>
+          </a:p>
+          <a:p>
+            <a:pPr lvl="0"/>
+            <a:r>
+              <a:rPr/>
+              <a:t>one main framework stack</a:t>
+            </a:r>
+          </a:p>
+          <a:p>
+            <a:pPr lvl="0"/>
+            <a:r>
+              <a:rPr/>
+              <a:t>visible effort</a:t>
+            </a:r>
+          </a:p>
+          <a:p>
+            <a:pPr lvl="0"/>
+            <a:r>
+              <a:rPr/>
+              <a:t>a working demo or prototype</a:t>
+            </a:r>
+          </a:p>
+          <a:p>
+            <a:pPr lvl="0"/>
+            <a:r>
+              <a:rPr/>
+              <a:t>understanding of the code and architecture</a:t>
+            </a:r>
+          </a:p>
+        </p:txBody>
+      </p:sp>
+    </p:spTree>
+  </p:cSld>
+</p:sld>
+</file>
+
+<file path=ppt/slides/slide36.xml><?xml version="1.0" encoding="utf-8"?>
+<p:sld xmlns:a="http://schemas.openxmlformats.org/drawingml/2006/main" xmlns:r="http://schemas.openxmlformats.org/officeDocument/2006/relationships" xmlns:p="http://schemas.openxmlformats.org/presentationml/2006/main">
+  <p:cSld>
+    <p:spTree>
+      <p:nvGrpSpPr>
+        <p:cNvPr id="1" name=""/>
+        <p:cNvGrpSpPr/>
+        <p:nvPr/>
+      </p:nvGrpSpPr>
+      <p:grpSpPr>
+        <a:xfrm>
+          <a:off x="0" y="0"/>
+          <a:ext cx="0" cy="0"/>
+          <a:chOff x="0" y="0"/>
+          <a:chExt cx="0" cy="0"/>
+        </a:xfrm>
+      </p:grpSpPr>
+      <p:sp>
+        <p:nvSpPr>
+          <p:cNvPr id="2" name="Title 1">
+            <a:extLst>
+              <a:ext uri="{FF2B5EF4-FFF2-40B4-BE49-F238E27FC236}">
+                <a16:creationId xmlns:a16="http://schemas.microsoft.com/office/drawing/2014/main" id="{DC1D1A22-93E7-53F5-3D1C-BA3AE5668A21}"/>
+              </a:ext>
+            </a:extLst>
+          </p:cNvPr>
+          <p:cNvSpPr>
+            <a:spLocks noGrp="1"/>
+          </p:cNvSpPr>
+          <p:nvPr>
+            <p:ph type="title"/>
+          </p:nvPr>
+        </p:nvSpPr>
+        <p:spPr/>
+        <p:txBody>
+          <a:bodyPr/>
+          <a:lstStyle/>
+          <a:p>
+            <a:pPr lvl="0" indent="0" marL="0">
+              <a:buNone/>
+            </a:pPr>
+            <a:r>
+              <a:rPr/>
+              <a:t>Final Message</a:t>
+            </a:r>
+          </a:p>
+        </p:txBody>
+      </p:sp>
+      <p:sp>
+        <p:nvSpPr>
+          <p:cNvPr id="3" name="Content Placeholder 2">
+            <a:extLst>
+              <a:ext uri="{FF2B5EF4-FFF2-40B4-BE49-F238E27FC236}">
+                <a16:creationId xmlns:a16="http://schemas.microsoft.com/office/drawing/2014/main" id="{89184A04-97C2-C83B-3F52-CA55E676823D}"/>
+              </a:ext>
+            </a:extLst>
+          </p:cNvPr>
+          <p:cNvSpPr>
+            <a:spLocks noGrp="1"/>
+          </p:cNvSpPr>
+          <p:nvPr>
+            <p:ph idx="1"/>
+          </p:nvPr>
+        </p:nvSpPr>
+        <p:spPr/>
+        <p:txBody>
+          <a:bodyPr/>
+          <a:lstStyle/>
+          <a:p>
+            <a:pPr lvl="0"/>
+            <a:r>
+              <a:rPr/>
+              <a:t>Deep learning is a very broad field.</a:t>
+            </a:r>
+          </a:p>
+          <a:p>
+            <a:pPr lvl="0"/>
+            <a:r>
+              <a:rPr/>
+              <a:t>You do not need to master all of it in this course.</a:t>
+            </a:r>
+          </a:p>
+          <a:p>
+            <a:pPr lvl="0"/>
+            <a:r>
+              <a:rPr/>
+              <a:t>But I want you to leave this course with:</a:t>
+            </a:r>
+          </a:p>
+          <a:p>
+            <a:pPr lvl="1"/>
+            <a:r>
+              <a:rPr/>
+              <a:t>a better map of the field</a:t>
+            </a:r>
+          </a:p>
+          <a:p>
+            <a:pPr lvl="1"/>
+            <a:r>
+              <a:rPr/>
+              <a:t>experience building one real AI system</a:t>
+            </a:r>
+          </a:p>
+          <a:p>
+            <a:pPr lvl="1"/>
+            <a:r>
+              <a:rPr/>
+              <a:t>confidence that you can learn a new framework on your own</a:t>
+            </a:r>
+          </a:p>
+        </p:txBody>
+      </p:sp>
+    </p:spTree>
+  </p:cSld>
+</p:sld>
+</file>
+
+<file path=ppt/slides/slide37.xml><?xml version="1.0" encoding="utf-8"?>
 <p:sld xmlns:a="http://schemas.openxmlformats.org/drawingml/2006/main" xmlns:r="http://schemas.openxmlformats.org/officeDocument/2006/relationships" xmlns:p="http://schemas.openxmlformats.org/presentationml/2006/main">
   <p:cSld>
     <p:spTree>

</xml_diff>

<commit_message>
Expand application domain guidance
</commit_message>
<xml_diff>
--- a/slides/deep-learning-project-directions.pptx
+++ b/slides/deep-learning-project-directions.pptx
@@ -42,6 +42,16 @@
     <p:sldId id="290" r:id="rId36"/>
     <p:sldId id="291" r:id="rId37"/>
     <p:sldId id="292" r:id="rId38"/>
+    <p:sldId id="293" r:id="rId39"/>
+    <p:sldId id="294" r:id="rId40"/>
+    <p:sldId id="295" r:id="rId41"/>
+    <p:sldId id="296" r:id="rId42"/>
+    <p:sldId id="297" r:id="rId43"/>
+    <p:sldId id="298" r:id="rId44"/>
+    <p:sldId id="299" r:id="rId45"/>
+    <p:sldId id="300" r:id="rId46"/>
+    <p:sldId id="301" r:id="rId47"/>
+    <p:sldId id="302" r:id="rId48"/>
   </p:sldIdLst>
   <p:sldSz cx="12192000" cy="6858000"/>
   <p:notesSz cx="6858000" cy="9144000"/>
@@ -5083,7 +5093,7 @@
             </a:pPr>
             <a:r>
               <a:rPr/>
-              <a:t>Deep Learning 2026: Project Paths, Frameworks, and Directions</a:t>
+              <a:t>Deep Learning 2026: Project Paths, Frameworks, and Domains</a:t>
             </a:r>
           </a:p>
         </p:txBody>
@@ -6469,7 +6479,7 @@
             </a:pPr>
             <a:r>
               <a:rPr/>
-              <a:t>Application Directions</a:t>
+              <a:t>Application Domains</a:t>
             </a:r>
           </a:p>
         </p:txBody>
@@ -6522,7 +6532,7 @@
             </a:pPr>
             <a:r>
               <a:rPr/>
-              <a:t>Computer Vision</a:t>
+              <a:t>What Application Domains Mean</a:t>
             </a:r>
           </a:p>
         </p:txBody>
@@ -6551,77 +6561,44 @@
             <a:pPr lvl="0"/>
             <a:r>
               <a:rPr/>
-              <a:t>Probably one of the easiest directions to demo well.</a:t>
-            </a:r>
-          </a:p>
-          <a:p>
-            <a:pPr lvl="0"/>
-            <a:r>
-              <a:rPr/>
-              <a:t>Typical tasks:</a:t>
-            </a:r>
-          </a:p>
-          <a:p>
-            <a:pPr lvl="1"/>
-            <a:r>
-              <a:rPr/>
-              <a:t>classification</a:t>
-            </a:r>
-          </a:p>
-          <a:p>
-            <a:pPr lvl="1"/>
-            <a:r>
-              <a:rPr/>
-              <a:t>object detection</a:t>
-            </a:r>
-          </a:p>
-          <a:p>
-            <a:pPr lvl="1"/>
-            <a:r>
-              <a:rPr/>
-              <a:t>segmentation</a:t>
-            </a:r>
-          </a:p>
-          <a:p>
-            <a:pPr lvl="1"/>
-            <a:r>
-              <a:rPr/>
-              <a:t>visual inspection</a:t>
-            </a:r>
-          </a:p>
-          <a:p>
-            <a:pPr lvl="0"/>
-            <a:r>
-              <a:rPr/>
-              <a:t>Strong frameworks:</a:t>
-            </a:r>
-          </a:p>
-          <a:p>
-            <a:pPr lvl="1"/>
-            <a:r>
-              <a:rPr/>
-              <a:t>PyTorch</a:t>
-            </a:r>
-          </a:p>
-          <a:p>
-            <a:pPr lvl="1"/>
-            <a:r>
-              <a:rPr/>
-              <a:t>Ultralytics YOLO</a:t>
-            </a:r>
-          </a:p>
-          <a:p>
-            <a:pPr lvl="1"/>
-            <a:r>
-              <a:rPr/>
-              <a:t>RF-DETR</a:t>
-            </a:r>
-          </a:p>
-          <a:p>
-            <a:pPr lvl="1"/>
-            <a:r>
-              <a:rPr/>
-              <a:t>OpenCV</a:t>
+              <a:t>A technical path tells you </a:t>
+            </a:r>
+            <a:r>
+              <a:rPr b="1"/>
+              <a:t>how</a:t>
+            </a:r>
+            <a:r>
+              <a:rPr/>
+              <a:t> you work with models.</a:t>
+            </a:r>
+          </a:p>
+          <a:p>
+            <a:pPr lvl="0"/>
+            <a:r>
+              <a:rPr/>
+              <a:t>An application domain tells you </a:t>
+            </a:r>
+            <a:r>
+              <a:rPr b="1"/>
+              <a:t>what kind of data or problem</a:t>
+            </a:r>
+            <a:r>
+              <a:rPr/>
+              <a:t> you work on.</a:t>
+            </a:r>
+          </a:p>
+          <a:p>
+            <a:pPr lvl="0"/>
+            <a:r>
+              <a:rPr/>
+              <a:t>One domain can combine with several paths.</a:t>
+            </a:r>
+          </a:p>
+          <a:p>
+            <a:pPr lvl="0"/>
+            <a:r>
+              <a:rPr/>
+              <a:t>Example: computer vision can use Path 1, Path 2, or Path 5.</a:t>
             </a:r>
           </a:p>
         </p:txBody>
@@ -6674,7 +6651,7 @@
             </a:pPr>
             <a:r>
               <a:rPr/>
-              <a:t>Language Models, Chat Systems, and Text Apps</a:t>
+              <a:t>Domain 1: Computer Vision</a:t>
             </a:r>
           </a:p>
         </p:txBody>
@@ -6703,7 +6680,7 @@
             <a:pPr lvl="0"/>
             <a:r>
               <a:rPr/>
-              <a:t>Strong option if you want to build something useful quickly.</a:t>
+              <a:t>AI for images and video.</a:t>
             </a:r>
           </a:p>
           <a:p>
@@ -6717,63 +6694,70 @@
             <a:pPr lvl="1"/>
             <a:r>
               <a:rPr/>
-              <a:t>chatbot</a:t>
+              <a:t>classification</a:t>
             </a:r>
           </a:p>
           <a:p>
             <a:pPr lvl="1"/>
             <a:r>
               <a:rPr/>
-              <a:t>summarization</a:t>
+              <a:t>object detection</a:t>
             </a:r>
           </a:p>
           <a:p>
             <a:pPr lvl="1"/>
             <a:r>
               <a:rPr/>
-              <a:t>classification</a:t>
+              <a:t>segmentation</a:t>
             </a:r>
           </a:p>
           <a:p>
             <a:pPr lvl="1"/>
             <a:r>
               <a:rPr/>
-              <a:t>tool calling</a:t>
+              <a:t>depth estimation</a:t>
             </a:r>
           </a:p>
           <a:p>
             <a:pPr lvl="1"/>
             <a:r>
               <a:rPr/>
-              <a:t>text transformation</a:t>
-            </a:r>
-          </a:p>
-          <a:p>
-            <a:pPr lvl="0"/>
-            <a:r>
-              <a:rPr/>
-              <a:t>Strong frameworks:</a:t>
+              <a:t>keypoint detection</a:t>
+            </a:r>
+          </a:p>
+          <a:p>
+            <a:pPr lvl="0"/>
+            <a:r>
+              <a:rPr/>
+              <a:t>Good tools:</a:t>
             </a:r>
           </a:p>
           <a:p>
             <a:pPr lvl="1"/>
             <a:r>
               <a:rPr/>
-              <a:t>Ollama</a:t>
+              <a:t>PyTorch</a:t>
             </a:r>
           </a:p>
           <a:p>
             <a:pPr lvl="1"/>
             <a:r>
               <a:rPr/>
-              <a:t>Transformers</a:t>
+              <a:t>YOLO</a:t>
             </a:r>
           </a:p>
           <a:p>
             <a:pPr lvl="1"/>
             <a:r>
               <a:rPr/>
-              <a:t>Sentence Transformers</a:t>
+              <a:t>RF-DETR</a:t>
+            </a:r>
+          </a:p>
+          <a:p>
+            <a:pPr lvl="1"/>
+            <a:r>
+              <a:rPr/>
+              <a:t>OpenCV</a:t>
             </a:r>
           </a:p>
         </p:txBody>
@@ -6826,7 +6810,7 @@
             </a:pPr>
             <a:r>
               <a:rPr/>
-              <a:t>Multimodal and Document AI</a:t>
+              <a:t>Computer Vision: Why It Matters</a:t>
             </a:r>
           </a:p>
         </p:txBody>
@@ -6855,70 +6839,28 @@
             <a:pPr lvl="0"/>
             <a:r>
               <a:rPr/>
-              <a:t>This is where language meets images, documents, or audio.</a:t>
-            </a:r>
-          </a:p>
-          <a:p>
-            <a:pPr lvl="0"/>
-            <a:r>
-              <a:rPr/>
-              <a:t>Typical tasks:</a:t>
-            </a:r>
-          </a:p>
-          <a:p>
-            <a:pPr lvl="1"/>
-            <a:r>
-              <a:rPr/>
-              <a:t>visual question answering</a:t>
-            </a:r>
-          </a:p>
-          <a:p>
-            <a:pPr lvl="1"/>
-            <a:r>
-              <a:rPr/>
-              <a:t>document understanding</a:t>
-            </a:r>
-          </a:p>
-          <a:p>
-            <a:pPr lvl="1"/>
-            <a:r>
-              <a:rPr/>
-              <a:t>receipt or invoice reading</a:t>
-            </a:r>
-          </a:p>
-          <a:p>
-            <a:pPr lvl="1"/>
-            <a:r>
-              <a:rPr/>
-              <a:t>image-aware assistants</a:t>
-            </a:r>
-          </a:p>
-          <a:p>
-            <a:pPr lvl="0"/>
-            <a:r>
-              <a:rPr/>
-              <a:t>Strong frameworks:</a:t>
-            </a:r>
-          </a:p>
-          <a:p>
-            <a:pPr lvl="1"/>
-            <a:r>
-              <a:rPr/>
-              <a:t>Transformers</a:t>
-            </a:r>
-          </a:p>
-          <a:p>
-            <a:pPr lvl="1"/>
-            <a:r>
-              <a:rPr/>
-              <a:t>vision-capable local models</a:t>
-            </a:r>
-          </a:p>
-          <a:p>
-            <a:pPr lvl="1"/>
-            <a:r>
-              <a:rPr/>
-              <a:t>document tools such as docTR</a:t>
+              <a:t>This is an established field, but still extremely powerful.</a:t>
+            </a:r>
+          </a:p>
+          <a:p>
+            <a:pPr lvl="0"/>
+            <a:r>
+              <a:rPr/>
+              <a:t>It solves many real industrial problems very well.</a:t>
+            </a:r>
+          </a:p>
+          <a:p>
+            <a:pPr lvl="0"/>
+            <a:r>
+              <a:rPr/>
+              <a:t>It also works very well on the GPU hardware you have.</a:t>
+            </a:r>
+          </a:p>
+          <a:p>
+            <a:pPr lvl="0"/>
+            <a:r>
+              <a:rPr/>
+              <a:t>Strong examples: inspection, counting, tracking, defect detection.</a:t>
             </a:r>
           </a:p>
         </p:txBody>
@@ -6971,7 +6913,7 @@
             </a:pPr>
             <a:r>
               <a:rPr/>
-              <a:t>Semantic Search and Retrieval</a:t>
+              <a:t>Domain 2: Language Models and Text Systems</a:t>
             </a:r>
           </a:p>
         </p:txBody>
@@ -7000,56 +6942,84 @@
             <a:pPr lvl="0"/>
             <a:r>
               <a:rPr/>
-              <a:t>This is one of the most practical modern AI directions.</a:t>
-            </a:r>
-          </a:p>
-          <a:p>
-            <a:pPr lvl="0"/>
-            <a:r>
-              <a:rPr/>
-              <a:t>It is based on embeddings:</a:t>
+              <a:t>This domain is mostly about pretrained or adapted models.</a:t>
+            </a:r>
+          </a:p>
+          <a:p>
+            <a:pPr lvl="0"/>
+            <a:r>
+              <a:rPr/>
+              <a:t>Training your own LLM from scratch is usually not realistic.</a:t>
+            </a:r>
+          </a:p>
+          <a:p>
+            <a:pPr lvl="0"/>
+            <a:r>
+              <a:rPr/>
+              <a:t>Typical tasks:</a:t>
             </a:r>
           </a:p>
           <a:p>
             <a:pPr lvl="1"/>
             <a:r>
               <a:rPr/>
-              <a:t>represent items as vectors</a:t>
+              <a:t>chatbot</a:t>
             </a:r>
           </a:p>
           <a:p>
             <a:pPr lvl="1"/>
             <a:r>
               <a:rPr/>
-              <a:t>compare them by meaning, not only by exact words</a:t>
-            </a:r>
-          </a:p>
-          <a:p>
-            <a:pPr lvl="0"/>
-            <a:r>
-              <a:rPr/>
-              <a:t>Typical projects:</a:t>
+              <a:t>summarization</a:t>
             </a:r>
           </a:p>
           <a:p>
             <a:pPr lvl="1"/>
             <a:r>
               <a:rPr/>
-              <a:t>semantic search</a:t>
+              <a:t>classification</a:t>
             </a:r>
           </a:p>
           <a:p>
             <a:pPr lvl="1"/>
             <a:r>
               <a:rPr/>
-              <a:t>retrieval-augmented chatbot</a:t>
+              <a:t>question answering</a:t>
             </a:r>
           </a:p>
           <a:p>
             <a:pPr lvl="1"/>
             <a:r>
               <a:rPr/>
-              <a:t>similar-item finder</a:t>
+              <a:t>tool calling</a:t>
+            </a:r>
+          </a:p>
+          <a:p>
+            <a:pPr lvl="0"/>
+            <a:r>
+              <a:rPr/>
+              <a:t>Good tools:</a:t>
+            </a:r>
+          </a:p>
+          <a:p>
+            <a:pPr lvl="1"/>
+            <a:r>
+              <a:rPr/>
+              <a:t>Ollama</a:t>
+            </a:r>
+          </a:p>
+          <a:p>
+            <a:pPr lvl="1"/>
+            <a:r>
+              <a:rPr/>
+              <a:t>Transformers</a:t>
+            </a:r>
+          </a:p>
+          <a:p>
+            <a:pPr lvl="1"/>
+            <a:r>
+              <a:rPr/>
+              <a:t>Sentence Transformers</a:t>
             </a:r>
           </a:p>
         </p:txBody>
@@ -7102,7 +7072,7 @@
             </a:pPr>
             <a:r>
               <a:rPr/>
-              <a:t>Recommendation Systems</a:t>
+              <a:t>Language Models: Tool Calling and Apps</a:t>
             </a:r>
           </a:p>
         </p:txBody>
@@ -7131,42 +7101,49 @@
             <a:pPr lvl="0"/>
             <a:r>
               <a:rPr/>
-              <a:t>This direction is closely related to embeddings, but the user experience is different from search.</a:t>
-            </a:r>
-          </a:p>
-          <a:p>
-            <a:pPr lvl="0"/>
-            <a:r>
-              <a:rPr/>
-              <a:t>Typical projects:</a:t>
+              <a:t>Tool calling means the model can decide when to use another tool.</a:t>
+            </a:r>
+          </a:p>
+          <a:p>
+            <a:pPr lvl="0"/>
+            <a:r>
+              <a:rPr/>
+              <a:t>Example tools:</a:t>
             </a:r>
           </a:p>
           <a:p>
             <a:pPr lvl="1"/>
             <a:r>
               <a:rPr/>
-              <a:t>music or media recommender</a:t>
+              <a:t>search</a:t>
             </a:r>
           </a:p>
           <a:p>
             <a:pPr lvl="1"/>
             <a:r>
               <a:rPr/>
-              <a:t>product recommendation demo</a:t>
+              <a:t>calculator</a:t>
             </a:r>
           </a:p>
           <a:p>
             <a:pPr lvl="1"/>
             <a:r>
               <a:rPr/>
-              <a:t>similar-item recommender</a:t>
+              <a:t>database lookup</a:t>
             </a:r>
           </a:p>
           <a:p>
             <a:pPr lvl="1"/>
             <a:r>
               <a:rPr/>
-              <a:t>recommendation UI based on embeddings</a:t>
+              <a:t>API call</a:t>
+            </a:r>
+          </a:p>
+          <a:p>
+            <a:pPr lvl="0"/>
+            <a:r>
+              <a:rPr/>
+              <a:t>That can become a whole project by itself.</a:t>
             </a:r>
           </a:p>
         </p:txBody>
@@ -7198,23 +7175,18 @@
           <p:cNvPr id="2" name="Title 1">
             <a:extLst>
               <a:ext uri="{FF2B5EF4-FFF2-40B4-BE49-F238E27FC236}">
-                <a16:creationId xmlns:a16="http://schemas.microsoft.com/office/drawing/2014/main" id="{AA599B7A-49D6-747B-0DC1-9468669DED68}"/>
-              </a:ext>
-            </a:extLst>
-          </p:cNvPr>
-          <p:cNvSpPr>
-            <a:spLocks noGrp="1"/>
-          </p:cNvSpPr>
-          <p:nvPr>
-            <p:ph hasCustomPrompt="1" type="title"/>
-          </p:nvPr>
-        </p:nvSpPr>
-        <p:spPr>
-          <a:xfrm>
-            <a:off x="839787" y="363600"/>
-            <a:ext cx="10515600" cy="1324800"/>
-          </a:xfrm>
-        </p:spPr>
+                <a16:creationId xmlns:a16="http://schemas.microsoft.com/office/drawing/2014/main" id="{DC1D1A22-93E7-53F5-3D1C-BA3AE5668A21}"/>
+              </a:ext>
+            </a:extLst>
+          </p:cNvPr>
+          <p:cNvSpPr>
+            <a:spLocks noGrp="1"/>
+          </p:cNvSpPr>
+          <p:nvPr>
+            <p:ph type="title"/>
+          </p:nvPr>
+        </p:nvSpPr>
+        <p:spPr/>
         <p:txBody>
           <a:bodyPr/>
           <a:lstStyle/>
@@ -7224,25 +7196,25 @@
             </a:pPr>
             <a:r>
               <a:rPr/>
-              <a:t>Speech, Audio, and Time-Series</a:t>
-            </a:r>
-          </a:p>
-        </p:txBody>
-      </p:sp>
-      <p:sp>
-        <p:nvSpPr>
-          <p:cNvPr id="4" name="Text Placeholder 3">
-            <a:extLst>
-              <a:ext uri="{FF2B5EF4-FFF2-40B4-BE49-F238E27FC236}">
-                <a16:creationId xmlns:a16="http://schemas.microsoft.com/office/drawing/2014/main" id="{002DFCD0-D549-8541-2E96-5E270DA67E5E}"/>
-              </a:ext>
-            </a:extLst>
-          </p:cNvPr>
-          <p:cNvSpPr>
-            <a:spLocks noGrp="1"/>
-          </p:cNvSpPr>
-          <p:nvPr>
-            <p:ph hasCustomPrompt="1" idx="2" sz="half" type="body"/>
+              <a:t>Domain 3: Multimodal and Document AI</a:t>
+            </a:r>
+          </a:p>
+        </p:txBody>
+      </p:sp>
+      <p:sp>
+        <p:nvSpPr>
+          <p:cNvPr id="3" name="Content Placeholder 2">
+            <a:extLst>
+              <a:ext uri="{FF2B5EF4-FFF2-40B4-BE49-F238E27FC236}">
+                <a16:creationId xmlns:a16="http://schemas.microsoft.com/office/drawing/2014/main" id="{89184A04-97C2-C83B-3F52-CA55E676823D}"/>
+              </a:ext>
+            </a:extLst>
+          </p:cNvPr>
+          <p:cNvSpPr>
+            <a:spLocks noGrp="1"/>
+          </p:cNvSpPr>
+          <p:nvPr>
+            <p:ph idx="1"/>
           </p:nvPr>
         </p:nvSpPr>
         <p:spPr/>
@@ -7253,97 +7225,81 @@
             <a:pPr lvl="0"/>
             <a:r>
               <a:rPr/>
-              <a:t>Good directions if you like signals rather than only text or images.</a:t>
-            </a:r>
-          </a:p>
-          <a:p>
-            <a:pPr lvl="0"/>
-            <a:r>
-              <a:rPr/>
-              <a:t>Audio examples:</a:t>
+              <a:t>This is where language meets images, documents, or audio.</a:t>
+            </a:r>
+          </a:p>
+          <a:p>
+            <a:pPr lvl="0"/>
+            <a:r>
+              <a:rPr/>
+              <a:t>Typical tasks:</a:t>
             </a:r>
           </a:p>
           <a:p>
             <a:pPr lvl="1"/>
             <a:r>
               <a:rPr/>
-              <a:t>speech-to-text</a:t>
+              <a:t>visual question answering</a:t>
             </a:r>
           </a:p>
           <a:p>
             <a:pPr lvl="1"/>
             <a:r>
               <a:rPr/>
-              <a:t>text-to-speech</a:t>
+              <a:t>document understanding</a:t>
             </a:r>
           </a:p>
           <a:p>
             <a:pPr lvl="1"/>
             <a:r>
               <a:rPr/>
-              <a:t>sound classification</a:t>
-            </a:r>
-          </a:p>
-          <a:p>
-            <a:pPr lvl="0"/>
-            <a:r>
-              <a:rPr/>
-              <a:t>Time-series examples:</a:t>
+              <a:t>receipt or invoice reading</a:t>
             </a:r>
           </a:p>
           <a:p>
             <a:pPr lvl="1"/>
             <a:r>
               <a:rPr/>
-              <a:t>anomaly detection</a:t>
+              <a:t>image-aware assistants</a:t>
+            </a:r>
+          </a:p>
+          <a:p>
+            <a:pPr lvl="0"/>
+            <a:r>
+              <a:rPr/>
+              <a:t>Good tools:</a:t>
             </a:r>
           </a:p>
           <a:p>
             <a:pPr lvl="1"/>
             <a:r>
               <a:rPr/>
-              <a:t>forecasting</a:t>
+              <a:t>Transformers</a:t>
             </a:r>
           </a:p>
           <a:p>
             <a:pPr lvl="1"/>
             <a:r>
               <a:rPr/>
-              <a:t>sensor monitoring</a:t>
-            </a:r>
-          </a:p>
-        </p:txBody>
-      </p:sp>
-      <p:pic>
-        <p:nvPicPr>
-          <p:cNvPr descr="media/time-series-data-graph.jpg" id="0" name="Picture 1"/>
-          <p:cNvPicPr>
-            <a:picLocks noGrp="1" noChangeAspect="1"/>
-          </p:cNvPicPr>
-          <p:nvPr/>
-        </p:nvPicPr>
-        <p:blipFill>
-          <a:blip r:embed="rId2"/>
-          <a:stretch>
-            <a:fillRect/>
-          </a:stretch>
-        </p:blipFill>
-        <p:spPr bwMode="auto">
-          <a:xfrm>
-            <a:off x="7556500" y="3073400"/>
-            <a:ext cx="4394200" cy="3302000"/>
-          </a:xfrm>
-          <a:prstGeom prst="rect">
-            <a:avLst/>
-          </a:prstGeom>
-          <a:noFill/>
-          <a:ln w="9525">
-            <a:noFill/>
-            <a:headEnd/>
-            <a:tailEnd/>
-          </a:ln>
-        </p:spPr>
-      </p:pic>
+              <a:t>vision-capable local models</a:t>
+            </a:r>
+          </a:p>
+          <a:p>
+            <a:pPr lvl="1"/>
+            <a:r>
+              <a:rPr/>
+              <a:t>document tools such as docTR</a:t>
+            </a:r>
+          </a:p>
+          <a:p>
+            <a:pPr lvl="0"/>
+            <a:r>
+              <a:rPr/>
+              <a:t>You already saw a small example of this in the generative AI workshop.</a:t>
+            </a:r>
+          </a:p>
+        </p:txBody>
+      </p:sp>
     </p:spTree>
   </p:cSld>
 </p:sld>
@@ -7392,7 +7348,7 @@
             </a:pPr>
             <a:r>
               <a:rPr/>
-              <a:t>Generative Systems Are Cross-Cutting</a:t>
+              <a:t>Multimodal: Example Projects</a:t>
             </a:r>
           </a:p>
         </p:txBody>
@@ -7421,64 +7377,28 @@
             <a:pPr lvl="0"/>
             <a:r>
               <a:rPr/>
-              <a:t>Generative AI is important, but it is not one single modality.</a:t>
-            </a:r>
-          </a:p>
-          <a:p>
-            <a:pPr lvl="0"/>
-            <a:r>
-              <a:rPr/>
-              <a:t>It can appear in:</a:t>
-            </a:r>
-          </a:p>
-          <a:p>
-            <a:pPr lvl="1"/>
-            <a:r>
-              <a:rPr/>
-              <a:t>text generation</a:t>
-            </a:r>
-          </a:p>
-          <a:p>
-            <a:pPr lvl="1"/>
-            <a:r>
-              <a:rPr/>
-              <a:t>image generation</a:t>
-            </a:r>
-          </a:p>
-          <a:p>
-            <a:pPr lvl="1"/>
-            <a:r>
-              <a:rPr/>
-              <a:t>speech generation</a:t>
-            </a:r>
-          </a:p>
-          <a:p>
-            <a:pPr lvl="1"/>
-            <a:r>
-              <a:rPr/>
-              <a:t>music generation</a:t>
-            </a:r>
-          </a:p>
-          <a:p>
-            <a:pPr lvl="1"/>
-            <a:r>
-              <a:rPr/>
-              <a:t>multimodal generation</a:t>
-            </a:r>
-          </a:p>
-          <a:p>
-            <a:pPr lvl="0"/>
-            <a:r>
-              <a:rPr/>
-              <a:t>So instead of treating it as one separate box, think of it as a </a:t>
-            </a:r>
-            <a:r>
-              <a:rPr b="1"/>
-              <a:t>style of model behavior</a:t>
-            </a:r>
-            <a:r>
-              <a:rPr/>
-              <a:t> across several domains.</a:t>
+              <a:t>upload an image and ask questions about it</a:t>
+            </a:r>
+          </a:p>
+          <a:p>
+            <a:pPr lvl="0"/>
+            <a:r>
+              <a:rPr/>
+              <a:t>analyze a receipt or invoice</a:t>
+            </a:r>
+          </a:p>
+          <a:p>
+            <a:pPr lvl="0"/>
+            <a:r>
+              <a:rPr/>
+              <a:t>build a document question-answering tool</a:t>
+            </a:r>
+          </a:p>
+          <a:p>
+            <a:pPr lvl="0"/>
+            <a:r>
+              <a:rPr/>
+              <a:t>combine voice input with image understanding</a:t>
             </a:r>
           </a:p>
         </p:txBody>
@@ -7670,7 +7590,7 @@
           <p:cNvPr id="2" name="Title 1">
             <a:extLst>
               <a:ext uri="{FF2B5EF4-FFF2-40B4-BE49-F238E27FC236}">
-                <a16:creationId xmlns:a16="http://schemas.microsoft.com/office/drawing/2014/main" id="{43AED9B2-1B96-B1B6-91DE-ED4F04AF0870}"/>
+                <a16:creationId xmlns:a16="http://schemas.microsoft.com/office/drawing/2014/main" id="{DC1D1A22-93E7-53F5-3D1C-BA3AE5668A21}"/>
               </a:ext>
             </a:extLst>
           </p:cNvPr>
@@ -7681,12 +7601,7 @@
             <p:ph type="title"/>
           </p:nvPr>
         </p:nvSpPr>
-        <p:spPr>
-          <a:xfrm>
-            <a:off x="831851" y="1709740"/>
-            <a:ext cx="10515600" cy="2852737"/>
-          </a:xfrm>
-        </p:spPr>
+        <p:spPr/>
         <p:txBody>
           <a:bodyPr/>
           <a:lstStyle/>
@@ -7696,7 +7611,78 @@
             </a:pPr>
             <a:r>
               <a:rPr/>
-              <a:t>Framework Suggestions</a:t>
+              <a:t>Domain 4: Semantic Search and Retrieval</a:t>
+            </a:r>
+          </a:p>
+        </p:txBody>
+      </p:sp>
+      <p:sp>
+        <p:nvSpPr>
+          <p:cNvPr id="3" name="Content Placeholder 2">
+            <a:extLst>
+              <a:ext uri="{FF2B5EF4-FFF2-40B4-BE49-F238E27FC236}">
+                <a16:creationId xmlns:a16="http://schemas.microsoft.com/office/drawing/2014/main" id="{89184A04-97C2-C83B-3F52-CA55E676823D}"/>
+              </a:ext>
+            </a:extLst>
+          </p:cNvPr>
+          <p:cNvSpPr>
+            <a:spLocks noGrp="1"/>
+          </p:cNvSpPr>
+          <p:nvPr>
+            <p:ph idx="1"/>
+          </p:nvPr>
+        </p:nvSpPr>
+        <p:spPr/>
+        <p:txBody>
+          <a:bodyPr/>
+          <a:lstStyle/>
+          <a:p>
+            <a:pPr lvl="0"/>
+            <a:r>
+              <a:rPr/>
+              <a:t>This domain is based on embeddings.</a:t>
+            </a:r>
+          </a:p>
+          <a:p>
+            <a:pPr lvl="0"/>
+            <a:r>
+              <a:rPr/>
+              <a:t>An embedding is a vector representation of text, image, or audio.</a:t>
+            </a:r>
+          </a:p>
+          <a:p>
+            <a:pPr lvl="0"/>
+            <a:r>
+              <a:rPr/>
+              <a:t>Similar meaning leads to nearby vectors.</a:t>
+            </a:r>
+          </a:p>
+          <a:p>
+            <a:pPr lvl="0"/>
+            <a:r>
+              <a:rPr/>
+              <a:t>Typical projects:</a:t>
+            </a:r>
+          </a:p>
+          <a:p>
+            <a:pPr lvl="1"/>
+            <a:r>
+              <a:rPr/>
+              <a:t>semantic search</a:t>
+            </a:r>
+          </a:p>
+          <a:p>
+            <a:pPr lvl="1"/>
+            <a:r>
+              <a:rPr/>
+              <a:t>retrieval-augmented chatbot</a:t>
+            </a:r>
+          </a:p>
+          <a:p>
+            <a:pPr lvl="1"/>
+            <a:r>
+              <a:rPr/>
+              <a:t>similar-item finder</a:t>
             </a:r>
           </a:p>
         </p:txBody>
@@ -7749,7 +7735,7 @@
             </a:pPr>
             <a:r>
               <a:rPr/>
-              <a:t>Main AI Frameworks Worth Exploring</a:t>
+              <a:t>Semantic Search: Why It Works</a:t>
             </a:r>
           </a:p>
         </p:txBody>
@@ -7777,85 +7763,50 @@
           <a:p>
             <a:pPr lvl="0"/>
             <a:r>
-              <a:rPr b="1"/>
-              <a:t>PyTorch</a:t>
+              <a:rPr/>
+              <a:t>You do not search only by exact words.</a:t>
+            </a:r>
+          </a:p>
+          <a:p>
+            <a:pPr lvl="0"/>
+            <a:r>
+              <a:rPr/>
+              <a:t>You search by meaning.</a:t>
+            </a:r>
+          </a:p>
+          <a:p>
+            <a:pPr lvl="0"/>
+            <a:r>
+              <a:rPr/>
+              <a:t>This is useful for:</a:t>
             </a:r>
           </a:p>
           <a:p>
             <a:pPr lvl="1"/>
             <a:r>
               <a:rPr/>
-              <a:t>best for direct training or retraining</a:t>
-            </a:r>
-          </a:p>
-          <a:p>
-            <a:pPr lvl="0"/>
-            <a:r>
-              <a:rPr b="1"/>
-              <a:t>Transformers</a:t>
+              <a:t>documents</a:t>
             </a:r>
           </a:p>
           <a:p>
             <a:pPr lvl="1"/>
             <a:r>
               <a:rPr/>
-              <a:t>best for pretrained language, multimodal, and speech models</a:t>
-            </a:r>
-          </a:p>
-          <a:p>
-            <a:pPr lvl="0"/>
-            <a:r>
-              <a:rPr b="1"/>
-              <a:t>Diffusers</a:t>
+              <a:t>notes</a:t>
             </a:r>
           </a:p>
           <a:p>
             <a:pPr lvl="1"/>
             <a:r>
               <a:rPr/>
-              <a:t>best for image generation and related workflows</a:t>
-            </a:r>
-          </a:p>
-          <a:p>
-            <a:pPr lvl="0"/>
-            <a:r>
-              <a:rPr b="1"/>
-              <a:t>Sentence Transformers</a:t>
+              <a:t>images</a:t>
             </a:r>
           </a:p>
           <a:p>
             <a:pPr lvl="1"/>
             <a:r>
               <a:rPr/>
-              <a:t>best for embeddings, retrieval, and recommendation</a:t>
-            </a:r>
-          </a:p>
-          <a:p>
-            <a:pPr lvl="0"/>
-            <a:r>
-              <a:rPr b="1"/>
-              <a:t>Stable-Baselines3</a:t>
-            </a:r>
-          </a:p>
-          <a:p>
-            <a:pPr lvl="1"/>
-            <a:r>
-              <a:rPr/>
-              <a:t>easiest RL starting point</a:t>
-            </a:r>
-          </a:p>
-          <a:p>
-            <a:pPr lvl="0"/>
-            <a:r>
-              <a:rPr b="1"/>
-              <a:t>ONNX Runtime</a:t>
-            </a:r>
-          </a:p>
-          <a:p>
-            <a:pPr lvl="1"/>
-            <a:r>
-              <a:rPr/>
-              <a:t>strong deployment path</a:t>
+              <a:t>other media</a:t>
             </a:r>
           </a:p>
         </p:txBody>
@@ -7866,6 +7817,1291 @@
 </file>
 
 <file path=ppt/slides/slide32.xml><?xml version="1.0" encoding="utf-8"?>
+<p:sld xmlns:a="http://schemas.openxmlformats.org/drawingml/2006/main" xmlns:r="http://schemas.openxmlformats.org/officeDocument/2006/relationships" xmlns:p="http://schemas.openxmlformats.org/presentationml/2006/main">
+  <p:cSld>
+    <p:spTree>
+      <p:nvGrpSpPr>
+        <p:cNvPr id="1" name=""/>
+        <p:cNvGrpSpPr/>
+        <p:nvPr/>
+      </p:nvGrpSpPr>
+      <p:grpSpPr>
+        <a:xfrm>
+          <a:off x="0" y="0"/>
+          <a:ext cx="0" cy="0"/>
+          <a:chOff x="0" y="0"/>
+          <a:chExt cx="0" cy="0"/>
+        </a:xfrm>
+      </p:grpSpPr>
+      <p:sp>
+        <p:nvSpPr>
+          <p:cNvPr id="2" name="Title 1">
+            <a:extLst>
+              <a:ext uri="{FF2B5EF4-FFF2-40B4-BE49-F238E27FC236}">
+                <a16:creationId xmlns:a16="http://schemas.microsoft.com/office/drawing/2014/main" id="{DC1D1A22-93E7-53F5-3D1C-BA3AE5668A21}"/>
+              </a:ext>
+            </a:extLst>
+          </p:cNvPr>
+          <p:cNvSpPr>
+            <a:spLocks noGrp="1"/>
+          </p:cNvSpPr>
+          <p:nvPr>
+            <p:ph type="title"/>
+          </p:nvPr>
+        </p:nvSpPr>
+        <p:spPr/>
+        <p:txBody>
+          <a:bodyPr/>
+          <a:lstStyle/>
+          <a:p>
+            <a:pPr lvl="0" indent="0" marL="0">
+              <a:buNone/>
+            </a:pPr>
+            <a:r>
+              <a:rPr/>
+              <a:t>RAG: Retrieve First, Then Generate</a:t>
+            </a:r>
+          </a:p>
+        </p:txBody>
+      </p:sp>
+      <p:sp>
+        <p:nvSpPr>
+          <p:cNvPr id="3" name="Content Placeholder 2">
+            <a:extLst>
+              <a:ext uri="{FF2B5EF4-FFF2-40B4-BE49-F238E27FC236}">
+                <a16:creationId xmlns:a16="http://schemas.microsoft.com/office/drawing/2014/main" id="{89184A04-97C2-C83B-3F52-CA55E676823D}"/>
+              </a:ext>
+            </a:extLst>
+          </p:cNvPr>
+          <p:cNvSpPr>
+            <a:spLocks noGrp="1"/>
+          </p:cNvSpPr>
+          <p:nvPr>
+            <p:ph idx="1"/>
+          </p:nvPr>
+        </p:nvSpPr>
+        <p:spPr/>
+        <p:txBody>
+          <a:bodyPr/>
+          <a:lstStyle/>
+          <a:p>
+            <a:pPr lvl="0"/>
+            <a:r>
+              <a:rPr/>
+              <a:t>Retrieval-augmented generation is part of this domain.</a:t>
+            </a:r>
+          </a:p>
+          <a:p>
+            <a:pPr lvl="0"/>
+            <a:r>
+              <a:rPr/>
+              <a:t>First retrieve the most relevant documents.</a:t>
+            </a:r>
+          </a:p>
+          <a:p>
+            <a:pPr lvl="0"/>
+            <a:r>
+              <a:rPr/>
+              <a:t>Then send that context to the language model.</a:t>
+            </a:r>
+          </a:p>
+          <a:p>
+            <a:pPr lvl="0"/>
+            <a:r>
+              <a:rPr/>
+              <a:t>Then generate the answer with better grounding.</a:t>
+            </a:r>
+          </a:p>
+        </p:txBody>
+      </p:sp>
+    </p:spTree>
+  </p:cSld>
+</p:sld>
+</file>
+
+<file path=ppt/slides/slide33.xml><?xml version="1.0" encoding="utf-8"?>
+<p:sld xmlns:a="http://schemas.openxmlformats.org/drawingml/2006/main" xmlns:r="http://schemas.openxmlformats.org/officeDocument/2006/relationships" xmlns:p="http://schemas.openxmlformats.org/presentationml/2006/main">
+  <p:cSld>
+    <p:spTree>
+      <p:nvGrpSpPr>
+        <p:cNvPr id="1" name=""/>
+        <p:cNvGrpSpPr/>
+        <p:nvPr/>
+      </p:nvGrpSpPr>
+      <p:grpSpPr>
+        <a:xfrm>
+          <a:off x="0" y="0"/>
+          <a:ext cx="0" cy="0"/>
+          <a:chOff x="0" y="0"/>
+          <a:chExt cx="0" cy="0"/>
+        </a:xfrm>
+      </p:grpSpPr>
+      <p:sp>
+        <p:nvSpPr>
+          <p:cNvPr id="2" name="Title 1">
+            <a:extLst>
+              <a:ext uri="{FF2B5EF4-FFF2-40B4-BE49-F238E27FC236}">
+                <a16:creationId xmlns:a16="http://schemas.microsoft.com/office/drawing/2014/main" id="{DC1D1A22-93E7-53F5-3D1C-BA3AE5668A21}"/>
+              </a:ext>
+            </a:extLst>
+          </p:cNvPr>
+          <p:cNvSpPr>
+            <a:spLocks noGrp="1"/>
+          </p:cNvSpPr>
+          <p:nvPr>
+            <p:ph type="title"/>
+          </p:nvPr>
+        </p:nvSpPr>
+        <p:spPr/>
+        <p:txBody>
+          <a:bodyPr/>
+          <a:lstStyle/>
+          <a:p>
+            <a:pPr lvl="0" indent="0" marL="0">
+              <a:buNone/>
+            </a:pPr>
+            <a:r>
+              <a:rPr/>
+              <a:t>Domain 5: Recommendation Systems</a:t>
+            </a:r>
+          </a:p>
+        </p:txBody>
+      </p:sp>
+      <p:sp>
+        <p:nvSpPr>
+          <p:cNvPr id="3" name="Content Placeholder 2">
+            <a:extLst>
+              <a:ext uri="{FF2B5EF4-FFF2-40B4-BE49-F238E27FC236}">
+                <a16:creationId xmlns:a16="http://schemas.microsoft.com/office/drawing/2014/main" id="{89184A04-97C2-C83B-3F52-CA55E676823D}"/>
+              </a:ext>
+            </a:extLst>
+          </p:cNvPr>
+          <p:cNvSpPr>
+            <a:spLocks noGrp="1"/>
+          </p:cNvSpPr>
+          <p:nvPr>
+            <p:ph idx="1"/>
+          </p:nvPr>
+        </p:nvSpPr>
+        <p:spPr/>
+        <p:txBody>
+          <a:bodyPr/>
+          <a:lstStyle/>
+          <a:p>
+            <a:pPr lvl="0"/>
+            <a:r>
+              <a:rPr/>
+              <a:t>This domain is closely related to embeddings, but the user experience is different from search.</a:t>
+            </a:r>
+          </a:p>
+          <a:p>
+            <a:pPr lvl="0"/>
+            <a:r>
+              <a:rPr/>
+              <a:t>Typical projects:</a:t>
+            </a:r>
+          </a:p>
+          <a:p>
+            <a:pPr lvl="1"/>
+            <a:r>
+              <a:rPr/>
+              <a:t>music or media recommender</a:t>
+            </a:r>
+          </a:p>
+          <a:p>
+            <a:pPr lvl="1"/>
+            <a:r>
+              <a:rPr/>
+              <a:t>product recommendation demo</a:t>
+            </a:r>
+          </a:p>
+          <a:p>
+            <a:pPr lvl="1"/>
+            <a:r>
+              <a:rPr/>
+              <a:t>similar-item recommender</a:t>
+            </a:r>
+          </a:p>
+          <a:p>
+            <a:pPr lvl="1"/>
+            <a:r>
+              <a:rPr/>
+              <a:t>recommendation UI based on embeddings</a:t>
+            </a:r>
+          </a:p>
+        </p:txBody>
+      </p:sp>
+    </p:spTree>
+  </p:cSld>
+</p:sld>
+</file>
+
+<file path=ppt/slides/slide34.xml><?xml version="1.0" encoding="utf-8"?>
+<p:sld xmlns:a="http://schemas.openxmlformats.org/drawingml/2006/main" xmlns:r="http://schemas.openxmlformats.org/officeDocument/2006/relationships" xmlns:p="http://schemas.openxmlformats.org/presentationml/2006/main">
+  <p:cSld>
+    <p:spTree>
+      <p:nvGrpSpPr>
+        <p:cNvPr id="1" name=""/>
+        <p:cNvGrpSpPr/>
+        <p:nvPr/>
+      </p:nvGrpSpPr>
+      <p:grpSpPr>
+        <a:xfrm>
+          <a:off x="0" y="0"/>
+          <a:ext cx="0" cy="0"/>
+          <a:chOff x="0" y="0"/>
+          <a:chExt cx="0" cy="0"/>
+        </a:xfrm>
+      </p:grpSpPr>
+      <p:sp>
+        <p:nvSpPr>
+          <p:cNvPr id="2" name="Title 1">
+            <a:extLst>
+              <a:ext uri="{FF2B5EF4-FFF2-40B4-BE49-F238E27FC236}">
+                <a16:creationId xmlns:a16="http://schemas.microsoft.com/office/drawing/2014/main" id="{DC1D1A22-93E7-53F5-3D1C-BA3AE5668A21}"/>
+              </a:ext>
+            </a:extLst>
+          </p:cNvPr>
+          <p:cNvSpPr>
+            <a:spLocks noGrp="1"/>
+          </p:cNvSpPr>
+          <p:nvPr>
+            <p:ph type="title"/>
+          </p:nvPr>
+        </p:nvSpPr>
+        <p:spPr/>
+        <p:txBody>
+          <a:bodyPr/>
+          <a:lstStyle/>
+          <a:p>
+            <a:pPr lvl="0" indent="0" marL="0">
+              <a:buNone/>
+            </a:pPr>
+            <a:r>
+              <a:rPr/>
+              <a:t>Recommendation Systems: Why They Matter</a:t>
+            </a:r>
+          </a:p>
+        </p:txBody>
+      </p:sp>
+      <p:sp>
+        <p:nvSpPr>
+          <p:cNvPr id="3" name="Content Placeholder 2">
+            <a:extLst>
+              <a:ext uri="{FF2B5EF4-FFF2-40B4-BE49-F238E27FC236}">
+                <a16:creationId xmlns:a16="http://schemas.microsoft.com/office/drawing/2014/main" id="{89184A04-97C2-C83B-3F52-CA55E676823D}"/>
+              </a:ext>
+            </a:extLst>
+          </p:cNvPr>
+          <p:cNvSpPr>
+            <a:spLocks noGrp="1"/>
+          </p:cNvSpPr>
+          <p:nvPr>
+            <p:ph idx="1"/>
+          </p:nvPr>
+        </p:nvSpPr>
+        <p:spPr/>
+        <p:txBody>
+          <a:bodyPr/>
+          <a:lstStyle/>
+          <a:p>
+            <a:pPr lvl="0"/>
+            <a:r>
+              <a:rPr/>
+              <a:t>Recommendation is everywhere on the modern web.</a:t>
+            </a:r>
+          </a:p>
+          <a:p>
+            <a:pPr lvl="0"/>
+            <a:r>
+              <a:rPr/>
+              <a:t>Modern recommenders often use embeddings and ranking.</a:t>
+            </a:r>
+          </a:p>
+          <a:p>
+            <a:pPr lvl="0"/>
+            <a:r>
+              <a:rPr/>
+              <a:t>This can be a very strong project if you like music, media, or product ideas.</a:t>
+            </a:r>
+          </a:p>
+        </p:txBody>
+      </p:sp>
+    </p:spTree>
+  </p:cSld>
+</p:sld>
+</file>
+
+<file path=ppt/slides/slide35.xml><?xml version="1.0" encoding="utf-8"?>
+<p:sld xmlns:a="http://schemas.openxmlformats.org/drawingml/2006/main" xmlns:r="http://schemas.openxmlformats.org/officeDocument/2006/relationships" xmlns:p="http://schemas.openxmlformats.org/presentationml/2006/main">
+  <p:cSld>
+    <p:spTree>
+      <p:nvGrpSpPr>
+        <p:cNvPr id="1" name=""/>
+        <p:cNvGrpSpPr/>
+        <p:nvPr/>
+      </p:nvGrpSpPr>
+      <p:grpSpPr>
+        <a:xfrm>
+          <a:off x="0" y="0"/>
+          <a:ext cx="0" cy="0"/>
+          <a:chOff x="0" y="0"/>
+          <a:chExt cx="0" cy="0"/>
+        </a:xfrm>
+      </p:grpSpPr>
+      <p:sp>
+        <p:nvSpPr>
+          <p:cNvPr id="2" name="Title 1">
+            <a:extLst>
+              <a:ext uri="{FF2B5EF4-FFF2-40B4-BE49-F238E27FC236}">
+                <a16:creationId xmlns:a16="http://schemas.microsoft.com/office/drawing/2014/main" id="{DC1D1A22-93E7-53F5-3D1C-BA3AE5668A21}"/>
+              </a:ext>
+            </a:extLst>
+          </p:cNvPr>
+          <p:cNvSpPr>
+            <a:spLocks noGrp="1"/>
+          </p:cNvSpPr>
+          <p:nvPr>
+            <p:ph type="title"/>
+          </p:nvPr>
+        </p:nvSpPr>
+        <p:spPr/>
+        <p:txBody>
+          <a:bodyPr/>
+          <a:lstStyle/>
+          <a:p>
+            <a:pPr lvl="0" indent="0" marL="0">
+              <a:buNone/>
+            </a:pPr>
+            <a:r>
+              <a:rPr/>
+              <a:t>Domain 6: Speech and Audio</a:t>
+            </a:r>
+          </a:p>
+        </p:txBody>
+      </p:sp>
+      <p:sp>
+        <p:nvSpPr>
+          <p:cNvPr id="3" name="Content Placeholder 2">
+            <a:extLst>
+              <a:ext uri="{FF2B5EF4-FFF2-40B4-BE49-F238E27FC236}">
+                <a16:creationId xmlns:a16="http://schemas.microsoft.com/office/drawing/2014/main" id="{89184A04-97C2-C83B-3F52-CA55E676823D}"/>
+              </a:ext>
+            </a:extLst>
+          </p:cNvPr>
+          <p:cNvSpPr>
+            <a:spLocks noGrp="1"/>
+          </p:cNvSpPr>
+          <p:nvPr>
+            <p:ph idx="1"/>
+          </p:nvPr>
+        </p:nvSpPr>
+        <p:spPr/>
+        <p:txBody>
+          <a:bodyPr/>
+          <a:lstStyle/>
+          <a:p>
+            <a:pPr lvl="0"/>
+            <a:r>
+              <a:rPr/>
+              <a:t>This domain can use Path 1, Path 2, or Path 3.</a:t>
+            </a:r>
+          </a:p>
+          <a:p>
+            <a:pPr lvl="0"/>
+            <a:r>
+              <a:rPr/>
+              <a:t>Typical tasks:</a:t>
+            </a:r>
+          </a:p>
+          <a:p>
+            <a:pPr lvl="1"/>
+            <a:r>
+              <a:rPr/>
+              <a:t>speech-to-text</a:t>
+            </a:r>
+          </a:p>
+          <a:p>
+            <a:pPr lvl="1"/>
+            <a:r>
+              <a:rPr/>
+              <a:t>text-to-speech</a:t>
+            </a:r>
+          </a:p>
+          <a:p>
+            <a:pPr lvl="1"/>
+            <a:r>
+              <a:rPr/>
+              <a:t>sound classification</a:t>
+            </a:r>
+          </a:p>
+          <a:p>
+            <a:pPr lvl="1"/>
+            <a:r>
+              <a:rPr/>
+              <a:t>music generation</a:t>
+            </a:r>
+          </a:p>
+          <a:p>
+            <a:pPr lvl="1"/>
+            <a:r>
+              <a:rPr/>
+              <a:t>voice adaptation</a:t>
+            </a:r>
+          </a:p>
+          <a:p>
+            <a:pPr lvl="0"/>
+            <a:r>
+              <a:rPr/>
+              <a:t>Good tools:</a:t>
+            </a:r>
+          </a:p>
+          <a:p>
+            <a:pPr lvl="1"/>
+            <a:r>
+              <a:rPr/>
+              <a:t>Whisper</a:t>
+            </a:r>
+          </a:p>
+          <a:p>
+            <a:pPr lvl="1"/>
+            <a:r>
+              <a:rPr/>
+              <a:t>torchaudio</a:t>
+            </a:r>
+          </a:p>
+          <a:p>
+            <a:pPr lvl="1"/>
+            <a:r>
+              <a:rPr/>
+              <a:t>Transformers</a:t>
+            </a:r>
+          </a:p>
+          <a:p>
+            <a:pPr lvl="1"/>
+            <a:r>
+              <a:rPr/>
+              <a:t>TTS libraries</a:t>
+            </a:r>
+          </a:p>
+        </p:txBody>
+      </p:sp>
+    </p:spTree>
+  </p:cSld>
+</p:sld>
+</file>
+
+<file path=ppt/slides/slide36.xml><?xml version="1.0" encoding="utf-8"?>
+<p:sld xmlns:a="http://schemas.openxmlformats.org/drawingml/2006/main" xmlns:r="http://schemas.openxmlformats.org/officeDocument/2006/relationships" xmlns:p="http://schemas.openxmlformats.org/presentationml/2006/main">
+  <p:cSld>
+    <p:spTree>
+      <p:nvGrpSpPr>
+        <p:cNvPr id="1" name=""/>
+        <p:cNvGrpSpPr/>
+        <p:nvPr/>
+      </p:nvGrpSpPr>
+      <p:grpSpPr>
+        <a:xfrm>
+          <a:off x="0" y="0"/>
+          <a:ext cx="0" cy="0"/>
+          <a:chOff x="0" y="0"/>
+          <a:chExt cx="0" cy="0"/>
+        </a:xfrm>
+      </p:grpSpPr>
+      <p:sp>
+        <p:nvSpPr>
+          <p:cNvPr id="2" name="Title 1">
+            <a:extLst>
+              <a:ext uri="{FF2B5EF4-FFF2-40B4-BE49-F238E27FC236}">
+                <a16:creationId xmlns:a16="http://schemas.microsoft.com/office/drawing/2014/main" id="{DC1D1A22-93E7-53F5-3D1C-BA3AE5668A21}"/>
+              </a:ext>
+            </a:extLst>
+          </p:cNvPr>
+          <p:cNvSpPr>
+            <a:spLocks noGrp="1"/>
+          </p:cNvSpPr>
+          <p:nvPr>
+            <p:ph type="title"/>
+          </p:nvPr>
+        </p:nvSpPr>
+        <p:spPr/>
+        <p:txBody>
+          <a:bodyPr/>
+          <a:lstStyle/>
+          <a:p>
+            <a:pPr lvl="0" indent="0" marL="0">
+              <a:buNone/>
+            </a:pPr>
+            <a:r>
+              <a:rPr/>
+              <a:t>Speech and Audio: Example Projects</a:t>
+            </a:r>
+          </a:p>
+        </p:txBody>
+      </p:sp>
+      <p:sp>
+        <p:nvSpPr>
+          <p:cNvPr id="3" name="Content Placeholder 2">
+            <a:extLst>
+              <a:ext uri="{FF2B5EF4-FFF2-40B4-BE49-F238E27FC236}">
+                <a16:creationId xmlns:a16="http://schemas.microsoft.com/office/drawing/2014/main" id="{89184A04-97C2-C83B-3F52-CA55E676823D}"/>
+              </a:ext>
+            </a:extLst>
+          </p:cNvPr>
+          <p:cNvSpPr>
+            <a:spLocks noGrp="1"/>
+          </p:cNvSpPr>
+          <p:nvPr>
+            <p:ph idx="1"/>
+          </p:nvPr>
+        </p:nvSpPr>
+        <p:spPr/>
+        <p:txBody>
+          <a:bodyPr/>
+          <a:lstStyle/>
+          <a:p>
+            <a:pPr lvl="0"/>
+            <a:r>
+              <a:rPr/>
+              <a:t>voice note transcriber</a:t>
+            </a:r>
+          </a:p>
+          <a:p>
+            <a:pPr lvl="0"/>
+            <a:r>
+              <a:rPr/>
+              <a:t>speech-based chatbot</a:t>
+            </a:r>
+          </a:p>
+          <a:p>
+            <a:pPr lvl="0"/>
+            <a:r>
+              <a:rPr/>
+              <a:t>sound-event detector</a:t>
+            </a:r>
+          </a:p>
+          <a:p>
+            <a:pPr lvl="0"/>
+            <a:r>
+              <a:rPr/>
+              <a:t>text-to-speech assistant</a:t>
+            </a:r>
+          </a:p>
+          <a:p>
+            <a:pPr lvl="0"/>
+            <a:r>
+              <a:rPr/>
+              <a:t>music generation demo</a:t>
+            </a:r>
+          </a:p>
+        </p:txBody>
+      </p:sp>
+    </p:spTree>
+  </p:cSld>
+</p:sld>
+</file>
+
+<file path=ppt/slides/slide37.xml><?xml version="1.0" encoding="utf-8"?>
+<p:sld xmlns:a="http://schemas.openxmlformats.org/drawingml/2006/main" xmlns:r="http://schemas.openxmlformats.org/officeDocument/2006/relationships" xmlns:p="http://schemas.openxmlformats.org/presentationml/2006/main">
+  <p:cSld>
+    <p:spTree>
+      <p:nvGrpSpPr>
+        <p:cNvPr id="1" name=""/>
+        <p:cNvGrpSpPr/>
+        <p:nvPr/>
+      </p:nvGrpSpPr>
+      <p:grpSpPr>
+        <a:xfrm>
+          <a:off x="0" y="0"/>
+          <a:ext cx="0" cy="0"/>
+          <a:chOff x="0" y="0"/>
+          <a:chExt cx="0" cy="0"/>
+        </a:xfrm>
+      </p:grpSpPr>
+      <p:sp>
+        <p:nvSpPr>
+          <p:cNvPr id="2" name="Title 1">
+            <a:extLst>
+              <a:ext uri="{FF2B5EF4-FFF2-40B4-BE49-F238E27FC236}">
+                <a16:creationId xmlns:a16="http://schemas.microsoft.com/office/drawing/2014/main" id="{DC1D1A22-93E7-53F5-3D1C-BA3AE5668A21}"/>
+              </a:ext>
+            </a:extLst>
+          </p:cNvPr>
+          <p:cNvSpPr>
+            <a:spLocks noGrp="1"/>
+          </p:cNvSpPr>
+          <p:nvPr>
+            <p:ph type="title"/>
+          </p:nvPr>
+        </p:nvSpPr>
+        <p:spPr/>
+        <p:txBody>
+          <a:bodyPr/>
+          <a:lstStyle/>
+          <a:p>
+            <a:pPr lvl="0" indent="0" marL="0">
+              <a:buNone/>
+            </a:pPr>
+            <a:r>
+              <a:rPr/>
+              <a:t>Domain 7: Time-Series and Sensor Signals</a:t>
+            </a:r>
+          </a:p>
+        </p:txBody>
+      </p:sp>
+      <p:sp>
+        <p:nvSpPr>
+          <p:cNvPr id="3" name="Content Placeholder 2">
+            <a:extLst>
+              <a:ext uri="{FF2B5EF4-FFF2-40B4-BE49-F238E27FC236}">
+                <a16:creationId xmlns:a16="http://schemas.microsoft.com/office/drawing/2014/main" id="{89184A04-97C2-C83B-3F52-CA55E676823D}"/>
+              </a:ext>
+            </a:extLst>
+          </p:cNvPr>
+          <p:cNvSpPr>
+            <a:spLocks noGrp="1"/>
+          </p:cNvSpPr>
+          <p:nvPr>
+            <p:ph idx="1"/>
+          </p:nvPr>
+        </p:nvSpPr>
+        <p:spPr/>
+        <p:txBody>
+          <a:bodyPr/>
+          <a:lstStyle/>
+          <a:p>
+            <a:pPr lvl="0"/>
+            <a:r>
+              <a:rPr/>
+              <a:t>This is more industrial and less flashy, but still important.</a:t>
+            </a:r>
+          </a:p>
+          <a:p>
+            <a:pPr lvl="0"/>
+            <a:r>
+              <a:rPr/>
+              <a:t>Typical tasks:</a:t>
+            </a:r>
+          </a:p>
+          <a:p>
+            <a:pPr lvl="1"/>
+            <a:r>
+              <a:rPr/>
+              <a:t>anomaly detection</a:t>
+            </a:r>
+          </a:p>
+          <a:p>
+            <a:pPr lvl="1"/>
+            <a:r>
+              <a:rPr/>
+              <a:t>forecasting</a:t>
+            </a:r>
+          </a:p>
+          <a:p>
+            <a:pPr lvl="1"/>
+            <a:r>
+              <a:rPr/>
+              <a:t>sensor monitoring</a:t>
+            </a:r>
+          </a:p>
+          <a:p>
+            <a:pPr lvl="0"/>
+            <a:r>
+              <a:rPr/>
+              <a:t>It is especially relevant if you already have an interesting dataset.</a:t>
+            </a:r>
+          </a:p>
+          <a:p>
+            <a:pPr lvl="0"/>
+            <a:r>
+              <a:rPr/>
+              <a:t>For this course, it is possible, but probably less attractive than image, text, or audio.</a:t>
+            </a:r>
+          </a:p>
+        </p:txBody>
+      </p:sp>
+    </p:spTree>
+  </p:cSld>
+</p:sld>
+</file>
+
+<file path=ppt/slides/slide38.xml><?xml version="1.0" encoding="utf-8"?>
+<p:sld xmlns:a="http://schemas.openxmlformats.org/drawingml/2006/main" xmlns:r="http://schemas.openxmlformats.org/officeDocument/2006/relationships" xmlns:p="http://schemas.openxmlformats.org/presentationml/2006/main">
+  <p:cSld>
+    <p:spTree>
+      <p:nvGrpSpPr>
+        <p:cNvPr id="1" name=""/>
+        <p:cNvGrpSpPr/>
+        <p:nvPr/>
+      </p:nvGrpSpPr>
+      <p:grpSpPr>
+        <a:xfrm>
+          <a:off x="0" y="0"/>
+          <a:ext cx="0" cy="0"/>
+          <a:chOff x="0" y="0"/>
+          <a:chExt cx="0" cy="0"/>
+        </a:xfrm>
+      </p:grpSpPr>
+      <p:sp>
+        <p:nvSpPr>
+          <p:cNvPr id="2" name="Title 1">
+            <a:extLst>
+              <a:ext uri="{FF2B5EF4-FFF2-40B4-BE49-F238E27FC236}">
+                <a16:creationId xmlns:a16="http://schemas.microsoft.com/office/drawing/2014/main" id="{DC1D1A22-93E7-53F5-3D1C-BA3AE5668A21}"/>
+              </a:ext>
+            </a:extLst>
+          </p:cNvPr>
+          <p:cNvSpPr>
+            <a:spLocks noGrp="1"/>
+          </p:cNvSpPr>
+          <p:nvPr>
+            <p:ph type="title"/>
+          </p:nvPr>
+        </p:nvSpPr>
+        <p:spPr/>
+        <p:txBody>
+          <a:bodyPr/>
+          <a:lstStyle/>
+          <a:p>
+            <a:pPr lvl="0" indent="0" marL="0">
+              <a:buNone/>
+            </a:pPr>
+            <a:r>
+              <a:rPr/>
+              <a:t>Domain 8: 3D, Depth, and Geometry</a:t>
+            </a:r>
+          </a:p>
+        </p:txBody>
+      </p:sp>
+      <p:sp>
+        <p:nvSpPr>
+          <p:cNvPr id="3" name="Content Placeholder 2">
+            <a:extLst>
+              <a:ext uri="{FF2B5EF4-FFF2-40B4-BE49-F238E27FC236}">
+                <a16:creationId xmlns:a16="http://schemas.microsoft.com/office/drawing/2014/main" id="{89184A04-97C2-C83B-3F52-CA55E676823D}"/>
+              </a:ext>
+            </a:extLst>
+          </p:cNvPr>
+          <p:cNvSpPr>
+            <a:spLocks noGrp="1"/>
+          </p:cNvSpPr>
+          <p:nvPr>
+            <p:ph idx="1"/>
+          </p:nvPr>
+        </p:nvSpPr>
+        <p:spPr/>
+        <p:txBody>
+          <a:bodyPr/>
+          <a:lstStyle/>
+          <a:p>
+            <a:pPr lvl="0"/>
+            <a:r>
+              <a:rPr/>
+              <a:t>This is a more niche domain, but it exists.</a:t>
+            </a:r>
+          </a:p>
+          <a:p>
+            <a:pPr lvl="0"/>
+            <a:r>
+              <a:rPr/>
+              <a:t>Examples:</a:t>
+            </a:r>
+          </a:p>
+          <a:p>
+            <a:pPr lvl="1"/>
+            <a:r>
+              <a:rPr/>
+              <a:t>depth estimation</a:t>
+            </a:r>
+          </a:p>
+          <a:p>
+            <a:pPr lvl="1"/>
+            <a:r>
+              <a:rPr/>
+              <a:t>image-to-3D</a:t>
+            </a:r>
+          </a:p>
+          <a:p>
+            <a:pPr lvl="1"/>
+            <a:r>
+              <a:rPr/>
+              <a:t>text-to-3D</a:t>
+            </a:r>
+          </a:p>
+          <a:p>
+            <a:pPr lvl="1"/>
+            <a:r>
+              <a:rPr/>
+              <a:t>3D generation workflows</a:t>
+            </a:r>
+          </a:p>
+          <a:p>
+            <a:pPr lvl="0"/>
+            <a:r>
+              <a:rPr/>
+              <a:t>Some interesting pretrained models already exist here.</a:t>
+            </a:r>
+          </a:p>
+        </p:txBody>
+      </p:sp>
+    </p:spTree>
+  </p:cSld>
+</p:sld>
+</file>
+
+<file path=ppt/slides/slide39.xml><?xml version="1.0" encoding="utf-8"?>
+<p:sld xmlns:a="http://schemas.openxmlformats.org/drawingml/2006/main" xmlns:r="http://schemas.openxmlformats.org/officeDocument/2006/relationships" xmlns:p="http://schemas.openxmlformats.org/presentationml/2006/main">
+  <p:cSld>
+    <p:spTree>
+      <p:nvGrpSpPr>
+        <p:cNvPr id="1" name=""/>
+        <p:cNvGrpSpPr/>
+        <p:nvPr/>
+      </p:nvGrpSpPr>
+      <p:grpSpPr>
+        <a:xfrm>
+          <a:off x="0" y="0"/>
+          <a:ext cx="0" cy="0"/>
+          <a:chOff x="0" y="0"/>
+          <a:chExt cx="0" cy="0"/>
+        </a:xfrm>
+      </p:grpSpPr>
+      <p:sp>
+        <p:nvSpPr>
+          <p:cNvPr id="2" name="Title 1">
+            <a:extLst>
+              <a:ext uri="{FF2B5EF4-FFF2-40B4-BE49-F238E27FC236}">
+                <a16:creationId xmlns:a16="http://schemas.microsoft.com/office/drawing/2014/main" id="{DC1D1A22-93E7-53F5-3D1C-BA3AE5668A21}"/>
+              </a:ext>
+            </a:extLst>
+          </p:cNvPr>
+          <p:cNvSpPr>
+            <a:spLocks noGrp="1"/>
+          </p:cNvSpPr>
+          <p:nvPr>
+            <p:ph type="title"/>
+          </p:nvPr>
+        </p:nvSpPr>
+        <p:spPr/>
+        <p:txBody>
+          <a:bodyPr/>
+          <a:lstStyle/>
+          <a:p>
+            <a:pPr lvl="0" indent="0" marL="0">
+              <a:buNone/>
+            </a:pPr>
+            <a:r>
+              <a:rPr/>
+              <a:t>Paths and Domains Can Be Combined</a:t>
+            </a:r>
+          </a:p>
+        </p:txBody>
+      </p:sp>
+      <p:sp>
+        <p:nvSpPr>
+          <p:cNvPr id="3" name="Content Placeholder 2">
+            <a:extLst>
+              <a:ext uri="{FF2B5EF4-FFF2-40B4-BE49-F238E27FC236}">
+                <a16:creationId xmlns:a16="http://schemas.microsoft.com/office/drawing/2014/main" id="{89184A04-97C2-C83B-3F52-CA55E676823D}"/>
+              </a:ext>
+            </a:extLst>
+          </p:cNvPr>
+          <p:cNvSpPr>
+            <a:spLocks noGrp="1"/>
+          </p:cNvSpPr>
+          <p:nvPr>
+            <p:ph idx="1"/>
+          </p:nvPr>
+        </p:nvSpPr>
+        <p:spPr/>
+        <p:txBody>
+          <a:bodyPr/>
+          <a:lstStyle/>
+          <a:p>
+            <a:pPr lvl="0"/>
+            <a:r>
+              <a:rPr/>
+              <a:t>Computer vision can use Path 1, Path 2, or Path 5.</a:t>
+            </a:r>
+          </a:p>
+          <a:p>
+            <a:pPr lvl="0"/>
+            <a:r>
+              <a:rPr/>
+              <a:t>Language models usually fit Path 2 or Path 3.</a:t>
+            </a:r>
+          </a:p>
+          <a:p>
+            <a:pPr lvl="0"/>
+            <a:r>
+              <a:rPr/>
+              <a:t>Audio can use Path 1, Path 2, or Path 3.</a:t>
+            </a:r>
+          </a:p>
+          <a:p>
+            <a:pPr lvl="0"/>
+            <a:r>
+              <a:rPr/>
+              <a:t>Edge deployment can apply to many domains.</a:t>
+            </a:r>
+          </a:p>
+          <a:p>
+            <a:pPr lvl="0"/>
+            <a:r>
+              <a:rPr/>
+              <a:t>Generative behavior can appear in text, image, audio, or multimodal systems.</a:t>
+            </a:r>
+          </a:p>
+        </p:txBody>
+      </p:sp>
+    </p:spTree>
+  </p:cSld>
+</p:sld>
+</file>
+
+<file path=ppt/slides/slide4.xml><?xml version="1.0" encoding="utf-8"?>
+<p:sld xmlns:a="http://schemas.openxmlformats.org/drawingml/2006/main" xmlns:r="http://schemas.openxmlformats.org/officeDocument/2006/relationships" xmlns:p="http://schemas.openxmlformats.org/presentationml/2006/main">
+  <p:cSld>
+    <p:spTree>
+      <p:nvGrpSpPr>
+        <p:cNvPr id="1" name=""/>
+        <p:cNvGrpSpPr/>
+        <p:nvPr/>
+      </p:nvGrpSpPr>
+      <p:grpSpPr>
+        <a:xfrm>
+          <a:off x="0" y="0"/>
+          <a:ext cx="0" cy="0"/>
+          <a:chOff x="0" y="0"/>
+          <a:chExt cx="0" cy="0"/>
+        </a:xfrm>
+      </p:grpSpPr>
+      <p:sp>
+        <p:nvSpPr>
+          <p:cNvPr id="2" name="Title 1">
+            <a:extLst>
+              <a:ext uri="{FF2B5EF4-FFF2-40B4-BE49-F238E27FC236}">
+                <a16:creationId xmlns:a16="http://schemas.microsoft.com/office/drawing/2014/main" id="{DC1D1A22-93E7-53F5-3D1C-BA3AE5668A21}"/>
+              </a:ext>
+            </a:extLst>
+          </p:cNvPr>
+          <p:cNvSpPr>
+            <a:spLocks noGrp="1"/>
+          </p:cNvSpPr>
+          <p:nvPr>
+            <p:ph type="title"/>
+          </p:nvPr>
+        </p:nvSpPr>
+        <p:spPr/>
+        <p:txBody>
+          <a:bodyPr/>
+          <a:lstStyle/>
+          <a:p>
+            <a:pPr lvl="0" indent="0" marL="0">
+              <a:buNone/>
+            </a:pPr>
+            <a:r>
+              <a:rPr/>
+              <a:t>How This Part of the Course Works</a:t>
+            </a:r>
+          </a:p>
+        </p:txBody>
+      </p:sp>
+      <p:sp>
+        <p:nvSpPr>
+          <p:cNvPr id="3" name="Content Placeholder 2">
+            <a:extLst>
+              <a:ext uri="{FF2B5EF4-FFF2-40B4-BE49-F238E27FC236}">
+                <a16:creationId xmlns:a16="http://schemas.microsoft.com/office/drawing/2014/main" id="{89184A04-97C2-C83B-3F52-CA55E676823D}"/>
+              </a:ext>
+            </a:extLst>
+          </p:cNvPr>
+          <p:cNvSpPr>
+            <a:spLocks noGrp="1"/>
+          </p:cNvSpPr>
+          <p:nvPr>
+            <p:ph idx="1"/>
+          </p:nvPr>
+        </p:nvSpPr>
+        <p:spPr/>
+        <p:txBody>
+          <a:bodyPr/>
+          <a:lstStyle/>
+          <a:p>
+            <a:pPr lvl="0"/>
+            <a:r>
+              <a:rPr/>
+              <a:t>The course is short:</a:t>
+            </a:r>
+          </a:p>
+          <a:p>
+            <a:pPr lvl="1"/>
+            <a:r>
+              <a:rPr/>
+              <a:t>4 lessons of 4 hours</a:t>
+            </a:r>
+          </a:p>
+          <a:p>
+            <a:pPr lvl="1"/>
+            <a:r>
+              <a:rPr/>
+              <a:t>plus the exam</a:t>
+            </a:r>
+          </a:p>
+          <a:p>
+            <a:pPr lvl="0"/>
+            <a:r>
+              <a:rPr/>
+              <a:t>The first lesson already introduced you to practical generative AI.</a:t>
+            </a:r>
+          </a:p>
+          <a:p>
+            <a:pPr lvl="0"/>
+            <a:r>
+              <a:rPr/>
+              <a:t>The remaining lessons are mainly for building your own project.</a:t>
+            </a:r>
+          </a:p>
+          <a:p>
+            <a:pPr lvl="0"/>
+            <a:r>
+              <a:rPr/>
+              <a:t>So today is about </a:t>
+            </a:r>
+            <a:r>
+              <a:rPr b="1"/>
+              <a:t>choosing a good path and domain</a:t>
+            </a:r>
+            <a:r>
+              <a:rPr/>
+              <a:t>.</a:t>
+            </a:r>
+          </a:p>
+        </p:txBody>
+      </p:sp>
+    </p:spTree>
+  </p:cSld>
+</p:sld>
+</file>
+
+<file path=ppt/slides/slide40.xml><?xml version="1.0" encoding="utf-8"?>
+<p:sld xmlns:a="http://schemas.openxmlformats.org/drawingml/2006/main" xmlns:r="http://schemas.openxmlformats.org/officeDocument/2006/relationships" xmlns:p="http://schemas.openxmlformats.org/presentationml/2006/main">
+  <p:cSld>
+    <p:spTree>
+      <p:nvGrpSpPr>
+        <p:cNvPr id="1" name=""/>
+        <p:cNvGrpSpPr/>
+        <p:nvPr/>
+      </p:nvGrpSpPr>
+      <p:grpSpPr>
+        <a:xfrm>
+          <a:off x="0" y="0"/>
+          <a:ext cx="0" cy="0"/>
+          <a:chOff x="0" y="0"/>
+          <a:chExt cx="0" cy="0"/>
+        </a:xfrm>
+      </p:grpSpPr>
+      <p:sp>
+        <p:nvSpPr>
+          <p:cNvPr id="2" name="Title 1">
+            <a:extLst>
+              <a:ext uri="{FF2B5EF4-FFF2-40B4-BE49-F238E27FC236}">
+                <a16:creationId xmlns:a16="http://schemas.microsoft.com/office/drawing/2014/main" id="{43AED9B2-1B96-B1B6-91DE-ED4F04AF0870}"/>
+              </a:ext>
+            </a:extLst>
+          </p:cNvPr>
+          <p:cNvSpPr>
+            <a:spLocks noGrp="1"/>
+          </p:cNvSpPr>
+          <p:nvPr>
+            <p:ph type="title"/>
+          </p:nvPr>
+        </p:nvSpPr>
+        <p:spPr>
+          <a:xfrm>
+            <a:off x="831851" y="1709740"/>
+            <a:ext cx="10515600" cy="2852737"/>
+          </a:xfrm>
+        </p:spPr>
+        <p:txBody>
+          <a:bodyPr/>
+          <a:lstStyle/>
+          <a:p>
+            <a:pPr lvl="0" indent="0" marL="0">
+              <a:buNone/>
+            </a:pPr>
+            <a:r>
+              <a:rPr/>
+              <a:t>Framework Suggestions</a:t>
+            </a:r>
+          </a:p>
+        </p:txBody>
+      </p:sp>
+    </p:spTree>
+  </p:cSld>
+</p:sld>
+</file>
+
+<file path=ppt/slides/slide41.xml><?xml version="1.0" encoding="utf-8"?>
+<p:sld xmlns:a="http://schemas.openxmlformats.org/drawingml/2006/main" xmlns:r="http://schemas.openxmlformats.org/officeDocument/2006/relationships" xmlns:p="http://schemas.openxmlformats.org/presentationml/2006/main">
+  <p:cSld>
+    <p:spTree>
+      <p:nvGrpSpPr>
+        <p:cNvPr id="1" name=""/>
+        <p:cNvGrpSpPr/>
+        <p:nvPr/>
+      </p:nvGrpSpPr>
+      <p:grpSpPr>
+        <a:xfrm>
+          <a:off x="0" y="0"/>
+          <a:ext cx="0" cy="0"/>
+          <a:chOff x="0" y="0"/>
+          <a:chExt cx="0" cy="0"/>
+        </a:xfrm>
+      </p:grpSpPr>
+      <p:sp>
+        <p:nvSpPr>
+          <p:cNvPr id="2" name="Title 1">
+            <a:extLst>
+              <a:ext uri="{FF2B5EF4-FFF2-40B4-BE49-F238E27FC236}">
+                <a16:creationId xmlns:a16="http://schemas.microsoft.com/office/drawing/2014/main" id="{DC1D1A22-93E7-53F5-3D1C-BA3AE5668A21}"/>
+              </a:ext>
+            </a:extLst>
+          </p:cNvPr>
+          <p:cNvSpPr>
+            <a:spLocks noGrp="1"/>
+          </p:cNvSpPr>
+          <p:nvPr>
+            <p:ph type="title"/>
+          </p:nvPr>
+        </p:nvSpPr>
+        <p:spPr/>
+        <p:txBody>
+          <a:bodyPr/>
+          <a:lstStyle/>
+          <a:p>
+            <a:pPr lvl="0" indent="0" marL="0">
+              <a:buNone/>
+            </a:pPr>
+            <a:r>
+              <a:rPr/>
+              <a:t>Main AI Frameworks Worth Exploring</a:t>
+            </a:r>
+          </a:p>
+        </p:txBody>
+      </p:sp>
+      <p:sp>
+        <p:nvSpPr>
+          <p:cNvPr id="3" name="Content Placeholder 2">
+            <a:extLst>
+              <a:ext uri="{FF2B5EF4-FFF2-40B4-BE49-F238E27FC236}">
+                <a16:creationId xmlns:a16="http://schemas.microsoft.com/office/drawing/2014/main" id="{89184A04-97C2-C83B-3F52-CA55E676823D}"/>
+              </a:ext>
+            </a:extLst>
+          </p:cNvPr>
+          <p:cNvSpPr>
+            <a:spLocks noGrp="1"/>
+          </p:cNvSpPr>
+          <p:nvPr>
+            <p:ph idx="1"/>
+          </p:nvPr>
+        </p:nvSpPr>
+        <p:spPr/>
+        <p:txBody>
+          <a:bodyPr/>
+          <a:lstStyle/>
+          <a:p>
+            <a:pPr lvl="0"/>
+            <a:r>
+              <a:rPr b="1"/>
+              <a:t>PyTorch</a:t>
+            </a:r>
+          </a:p>
+          <a:p>
+            <a:pPr lvl="1"/>
+            <a:r>
+              <a:rPr/>
+              <a:t>best for direct training or retraining</a:t>
+            </a:r>
+          </a:p>
+          <a:p>
+            <a:pPr lvl="0"/>
+            <a:r>
+              <a:rPr b="1"/>
+              <a:t>Transformers</a:t>
+            </a:r>
+          </a:p>
+          <a:p>
+            <a:pPr lvl="1"/>
+            <a:r>
+              <a:rPr/>
+              <a:t>best for pretrained language, multimodal, and speech models</a:t>
+            </a:r>
+          </a:p>
+          <a:p>
+            <a:pPr lvl="0"/>
+            <a:r>
+              <a:rPr b="1"/>
+              <a:t>Diffusers</a:t>
+            </a:r>
+          </a:p>
+          <a:p>
+            <a:pPr lvl="1"/>
+            <a:r>
+              <a:rPr/>
+              <a:t>best for image generation and related workflows</a:t>
+            </a:r>
+          </a:p>
+          <a:p>
+            <a:pPr lvl="0"/>
+            <a:r>
+              <a:rPr b="1"/>
+              <a:t>Sentence Transformers</a:t>
+            </a:r>
+          </a:p>
+          <a:p>
+            <a:pPr lvl="1"/>
+            <a:r>
+              <a:rPr/>
+              <a:t>best for embeddings, retrieval, and recommendation</a:t>
+            </a:r>
+          </a:p>
+          <a:p>
+            <a:pPr lvl="0"/>
+            <a:r>
+              <a:rPr b="1"/>
+              <a:t>Stable-Baselines3</a:t>
+            </a:r>
+          </a:p>
+          <a:p>
+            <a:pPr lvl="1"/>
+            <a:r>
+              <a:rPr/>
+              <a:t>easiest RL starting point</a:t>
+            </a:r>
+          </a:p>
+          <a:p>
+            <a:pPr lvl="0"/>
+            <a:r>
+              <a:rPr b="1"/>
+              <a:t>ONNX Runtime</a:t>
+            </a:r>
+          </a:p>
+          <a:p>
+            <a:pPr lvl="1"/>
+            <a:r>
+              <a:rPr/>
+              <a:t>strong deployment path</a:t>
+            </a:r>
+          </a:p>
+        </p:txBody>
+      </p:sp>
+    </p:spTree>
+  </p:cSld>
+</p:sld>
+</file>
+
+<file path=ppt/slides/slide42.xml><?xml version="1.0" encoding="utf-8"?>
 <p:sld xmlns:a="http://schemas.openxmlformats.org/drawingml/2006/main" xmlns:r="http://schemas.openxmlformats.org/officeDocument/2006/relationships" xmlns:p="http://schemas.openxmlformats.org/presentationml/2006/main">
   <p:cSld>
     <p:spTree>
@@ -8017,7 +9253,7 @@
 </p:sld>
 </file>
 
-<file path=ppt/slides/slide33.xml><?xml version="1.0" encoding="utf-8"?>
+<file path=ppt/slides/slide43.xml><?xml version="1.0" encoding="utf-8"?>
 <p:sld xmlns:a="http://schemas.openxmlformats.org/drawingml/2006/main" xmlns:r="http://schemas.openxmlformats.org/officeDocument/2006/relationships" xmlns:p="http://schemas.openxmlformats.org/presentationml/2006/main">
   <p:cSld>
     <p:spTree>
@@ -8152,7 +9388,7 @@
 </p:sld>
 </file>
 
-<file path=ppt/slides/slide34.xml><?xml version="1.0" encoding="utf-8"?>
+<file path=ppt/slides/slide44.xml><?xml version="1.0" encoding="utf-8"?>
 <p:sld xmlns:a="http://schemas.openxmlformats.org/drawingml/2006/main" xmlns:r="http://schemas.openxmlformats.org/officeDocument/2006/relationships" xmlns:p="http://schemas.openxmlformats.org/presentationml/2006/main">
   <p:cSld>
     <p:spTree>
@@ -8210,7 +9446,7 @@
 </p:sld>
 </file>
 
-<file path=ppt/slides/slide35.xml><?xml version="1.0" encoding="utf-8"?>
+<file path=ppt/slides/slide45.xml><?xml version="1.0" encoding="utf-8"?>
 <p:sld xmlns:a="http://schemas.openxmlformats.org/drawingml/2006/main" xmlns:r="http://schemas.openxmlformats.org/officeDocument/2006/relationships" xmlns:p="http://schemas.openxmlformats.org/presentationml/2006/main">
   <p:cSld>
     <p:spTree>
@@ -8327,7 +9563,7 @@
 </p:sld>
 </file>
 
-<file path=ppt/slides/slide36.xml><?xml version="1.0" encoding="utf-8"?>
+<file path=ppt/slides/slide46.xml><?xml version="1.0" encoding="utf-8"?>
 <p:sld xmlns:a="http://schemas.openxmlformats.org/drawingml/2006/main" xmlns:r="http://schemas.openxmlformats.org/officeDocument/2006/relationships" xmlns:p="http://schemas.openxmlformats.org/presentationml/2006/main">
   <p:cSld>
     <p:spTree>
@@ -8444,7 +9680,7 @@
 </p:sld>
 </file>
 
-<file path=ppt/slides/slide37.xml><?xml version="1.0" encoding="utf-8"?>
+<file path=ppt/slides/slide47.xml><?xml version="1.0" encoding="utf-8"?>
 <p:sld xmlns:a="http://schemas.openxmlformats.org/drawingml/2006/main" xmlns:r="http://schemas.openxmlformats.org/officeDocument/2006/relationships" xmlns:p="http://schemas.openxmlformats.org/presentationml/2006/main">
   <p:cSld>
     <p:spTree>
@@ -8538,131 +9774,6 @@
             <a:r>
               <a:rPr/>
               <a:t>start building</a:t>
-            </a:r>
-          </a:p>
-        </p:txBody>
-      </p:sp>
-    </p:spTree>
-  </p:cSld>
-</p:sld>
-</file>
-
-<file path=ppt/slides/slide4.xml><?xml version="1.0" encoding="utf-8"?>
-<p:sld xmlns:a="http://schemas.openxmlformats.org/drawingml/2006/main" xmlns:r="http://schemas.openxmlformats.org/officeDocument/2006/relationships" xmlns:p="http://schemas.openxmlformats.org/presentationml/2006/main">
-  <p:cSld>
-    <p:spTree>
-      <p:nvGrpSpPr>
-        <p:cNvPr id="1" name=""/>
-        <p:cNvGrpSpPr/>
-        <p:nvPr/>
-      </p:nvGrpSpPr>
-      <p:grpSpPr>
-        <a:xfrm>
-          <a:off x="0" y="0"/>
-          <a:ext cx="0" cy="0"/>
-          <a:chOff x="0" y="0"/>
-          <a:chExt cx="0" cy="0"/>
-        </a:xfrm>
-      </p:grpSpPr>
-      <p:sp>
-        <p:nvSpPr>
-          <p:cNvPr id="2" name="Title 1">
-            <a:extLst>
-              <a:ext uri="{FF2B5EF4-FFF2-40B4-BE49-F238E27FC236}">
-                <a16:creationId xmlns:a16="http://schemas.microsoft.com/office/drawing/2014/main" id="{DC1D1A22-93E7-53F5-3D1C-BA3AE5668A21}"/>
-              </a:ext>
-            </a:extLst>
-          </p:cNvPr>
-          <p:cNvSpPr>
-            <a:spLocks noGrp="1"/>
-          </p:cNvSpPr>
-          <p:nvPr>
-            <p:ph type="title"/>
-          </p:nvPr>
-        </p:nvSpPr>
-        <p:spPr/>
-        <p:txBody>
-          <a:bodyPr/>
-          <a:lstStyle/>
-          <a:p>
-            <a:pPr lvl="0" indent="0" marL="0">
-              <a:buNone/>
-            </a:pPr>
-            <a:r>
-              <a:rPr/>
-              <a:t>How This Part of the Course Works</a:t>
-            </a:r>
-          </a:p>
-        </p:txBody>
-      </p:sp>
-      <p:sp>
-        <p:nvSpPr>
-          <p:cNvPr id="3" name="Content Placeholder 2">
-            <a:extLst>
-              <a:ext uri="{FF2B5EF4-FFF2-40B4-BE49-F238E27FC236}">
-                <a16:creationId xmlns:a16="http://schemas.microsoft.com/office/drawing/2014/main" id="{89184A04-97C2-C83B-3F52-CA55E676823D}"/>
-              </a:ext>
-            </a:extLst>
-          </p:cNvPr>
-          <p:cNvSpPr>
-            <a:spLocks noGrp="1"/>
-          </p:cNvSpPr>
-          <p:nvPr>
-            <p:ph idx="1"/>
-          </p:nvPr>
-        </p:nvSpPr>
-        <p:spPr/>
-        <p:txBody>
-          <a:bodyPr/>
-          <a:lstStyle/>
-          <a:p>
-            <a:pPr lvl="0"/>
-            <a:r>
-              <a:rPr/>
-              <a:t>The course is short:</a:t>
-            </a:r>
-          </a:p>
-          <a:p>
-            <a:pPr lvl="1"/>
-            <a:r>
-              <a:rPr/>
-              <a:t>4 lessons of 4 hours</a:t>
-            </a:r>
-          </a:p>
-          <a:p>
-            <a:pPr lvl="1"/>
-            <a:r>
-              <a:rPr/>
-              <a:t>plus the exam</a:t>
-            </a:r>
-          </a:p>
-          <a:p>
-            <a:pPr lvl="0"/>
-            <a:r>
-              <a:rPr/>
-              <a:t>The first lesson already introduced you to practical generative AI.</a:t>
-            </a:r>
-          </a:p>
-          <a:p>
-            <a:pPr lvl="0"/>
-            <a:r>
-              <a:rPr/>
-              <a:t>The remaining lessons are mainly for building your own project.</a:t>
-            </a:r>
-          </a:p>
-          <a:p>
-            <a:pPr lvl="0"/>
-            <a:r>
-              <a:rPr/>
-              <a:t>So today is about </a:t>
-            </a:r>
-            <a:r>
-              <a:rPr b="1"/>
-              <a:t>choosing a good direction</a:t>
-            </a:r>
-            <a:r>
-              <a:rPr/>
-              <a:t>.</a:t>
             </a:r>
           </a:p>
         </p:txBody>
@@ -9045,7 +10156,7 @@
             </a:pPr>
             <a:r>
               <a:rPr/>
-              <a:t>Then Choose an Application Direction</a:t>
+              <a:t>Then Choose an Application Domain</a:t>
             </a:r>
           </a:p>
         </p:txBody>
@@ -9081,7 +10192,7 @@
             <a:pPr lvl="0"/>
             <a:r>
               <a:rPr/>
-              <a:t>Good directions include:</a:t>
+              <a:t>Good domains include:</a:t>
             </a:r>
           </a:p>
           <a:p>
@@ -9102,6 +10213,27 @@
             <a:pPr lvl="1"/>
             <a:r>
               <a:rPr/>
+              <a:t>multimodal and document AI</a:t>
+            </a:r>
+          </a:p>
+          <a:p>
+            <a:pPr lvl="1"/>
+            <a:r>
+              <a:rPr/>
+              <a:t>semantic search / retrieval</a:t>
+            </a:r>
+          </a:p>
+          <a:p>
+            <a:pPr lvl="1"/>
+            <a:r>
+              <a:rPr/>
+              <a:t>recommendation systems</a:t>
+            </a:r>
+          </a:p>
+          <a:p>
+            <a:pPr lvl="1"/>
+            <a:r>
+              <a:rPr/>
               <a:t>speech and audio</a:t>
             </a:r>
           </a:p>
@@ -9109,42 +10241,14 @@
             <a:pPr lvl="1"/>
             <a:r>
               <a:rPr/>
-              <a:t>multimodal and document AI</a:t>
+              <a:t>time-series and sensor signals</a:t>
             </a:r>
           </a:p>
           <a:p>
             <a:pPr lvl="1"/>
             <a:r>
               <a:rPr/>
-              <a:t>time-series and sensor signals</a:t>
-            </a:r>
-          </a:p>
-          <a:p>
-            <a:pPr lvl="1"/>
-            <a:r>
-              <a:rPr/>
-              <a:t>semantic search / retrieval</a:t>
-            </a:r>
-          </a:p>
-          <a:p>
-            <a:pPr lvl="1"/>
-            <a:r>
-              <a:rPr/>
-              <a:t>recommendation systems</a:t>
-            </a:r>
-          </a:p>
-          <a:p>
-            <a:pPr lvl="1"/>
-            <a:r>
-              <a:rPr/>
-              <a:t>reinforcement learning</a:t>
-            </a:r>
-          </a:p>
-          <a:p>
-            <a:pPr lvl="1"/>
-            <a:r>
-              <a:rPr/>
-              <a:t>edge deployment</a:t>
+              <a:t>3D / depth / geometry</a:t>
             </a:r>
           </a:p>
         </p:txBody>

</xml_diff>

<commit_message>
Tighten slide ending and domain handoff
</commit_message>
<xml_diff>
--- a/slides/deep-learning-project-directions.pptx
+++ b/slides/deep-learning-project-directions.pptx
@@ -52,6 +52,7 @@
     <p:sldId id="300" r:id="rId46"/>
     <p:sldId id="301" r:id="rId47"/>
     <p:sldId id="302" r:id="rId48"/>
+    <p:sldId id="303" r:id="rId49"/>
   </p:sldIdLst>
   <p:sldSz cx="12192000" cy="6858000"/>
   <p:notesSz cx="6858000" cy="9144000"/>
@@ -8985,7 +8986,7 @@
             </a:pPr>
             <a:r>
               <a:rPr/>
-              <a:t>Main AI Frameworks Worth Exploring</a:t>
+              <a:t>Frameworks Depend on the Domain</a:t>
             </a:r>
           </a:p>
         </p:txBody>
@@ -9013,7 +9014,28 @@
           <a:p>
             <a:pPr lvl="0"/>
             <a:r>
-              <a:rPr b="1"/>
+              <a:rPr/>
+              <a:t>You do not need to memorize every framework from this talk.</a:t>
+            </a:r>
+          </a:p>
+          <a:p>
+            <a:pPr lvl="0"/>
+            <a:r>
+              <a:rPr/>
+              <a:t>The exact framework depends on the domain you choose.</a:t>
+            </a:r>
+          </a:p>
+          <a:p>
+            <a:pPr lvl="0"/>
+            <a:r>
+              <a:rPr/>
+              <a:t>Three big names to remember:</a:t>
+            </a:r>
+          </a:p>
+          <a:p>
+            <a:pPr lvl="1"/>
+            <a:r>
+              <a:rPr/>
               <a:t>PyTorch</a:t>
             </a:r>
           </a:p>
@@ -9021,13 +9043,6 @@
             <a:pPr lvl="1"/>
             <a:r>
               <a:rPr/>
-              <a:t>best for direct training or retraining</a:t>
-            </a:r>
-          </a:p>
-          <a:p>
-            <a:pPr lvl="0"/>
-            <a:r>
-              <a:rPr b="1"/>
               <a:t>Transformers</a:t>
             </a:r>
           </a:p>
@@ -9035,63 +9050,14 @@
             <a:pPr lvl="1"/>
             <a:r>
               <a:rPr/>
-              <a:t>best for pretrained language, multimodal, and speech models</a:t>
-            </a:r>
-          </a:p>
-          <a:p>
-            <a:pPr lvl="0"/>
-            <a:r>
-              <a:rPr b="1"/>
-              <a:t>Diffusers</a:t>
-            </a:r>
-          </a:p>
-          <a:p>
-            <a:pPr lvl="1"/>
-            <a:r>
-              <a:rPr/>
-              <a:t>best for image generation and related workflows</a:t>
-            </a:r>
-          </a:p>
-          <a:p>
-            <a:pPr lvl="0"/>
-            <a:r>
-              <a:rPr b="1"/>
               <a:t>Sentence Transformers</a:t>
             </a:r>
           </a:p>
           <a:p>
-            <a:pPr lvl="1"/>
-            <a:r>
-              <a:rPr/>
-              <a:t>best for embeddings, retrieval, and recommendation</a:t>
-            </a:r>
-          </a:p>
-          <a:p>
-            <a:pPr lvl="0"/>
-            <a:r>
-              <a:rPr b="1"/>
-              <a:t>Stable-Baselines3</a:t>
-            </a:r>
-          </a:p>
-          <a:p>
-            <a:pPr lvl="1"/>
-            <a:r>
-              <a:rPr/>
-              <a:t>easiest RL starting point</a:t>
-            </a:r>
-          </a:p>
-          <a:p>
-            <a:pPr lvl="0"/>
-            <a:r>
-              <a:rPr b="1"/>
-              <a:t>ONNX Runtime</a:t>
-            </a:r>
-          </a:p>
-          <a:p>
-            <a:pPr lvl="1"/>
-            <a:r>
-              <a:rPr/>
-              <a:t>strong deployment path</a:t>
+            <a:pPr lvl="0"/>
+            <a:r>
+              <a:rPr/>
+              <a:t>After choosing a domain, read the matching notes and official docs.</a:t>
             </a:r>
           </a:p>
         </p:txBody>
@@ -9203,6 +9169,13 @@
             </a:r>
           </a:p>
           <a:p>
+            <a:pPr lvl="1"/>
+            <a:r>
+              <a:rPr/>
+              <a:t>React or another custom frontend</a:t>
+            </a:r>
+          </a:p>
+          <a:p>
             <a:pPr lvl="0"/>
             <a:r>
               <a:rPr/>
@@ -9214,6 +9187,13 @@
             <a:r>
               <a:rPr/>
               <a:t>Gradio is a very good default if you want to move fast.</a:t>
+            </a:r>
+          </a:p>
+          <a:p>
+            <a:pPr lvl="0"/>
+            <a:r>
+              <a:rPr/>
+              <a:t>React gives more control, but also more complexity.</a:t>
             </a:r>
           </a:p>
         </p:txBody>
@@ -9275,7 +9255,7 @@
           <p:cNvPr id="2" name="Title 1">
             <a:extLst>
               <a:ext uri="{FF2B5EF4-FFF2-40B4-BE49-F238E27FC236}">
-                <a16:creationId xmlns:a16="http://schemas.microsoft.com/office/drawing/2014/main" id="{DC1D1A22-93E7-53F5-3D1C-BA3AE5668A21}"/>
+                <a16:creationId xmlns:a16="http://schemas.microsoft.com/office/drawing/2014/main" id="{43AED9B2-1B96-B1B6-91DE-ED4F04AF0870}"/>
               </a:ext>
             </a:extLst>
           </p:cNvPr>
@@ -9286,7 +9266,12 @@
             <p:ph type="title"/>
           </p:nvPr>
         </p:nvSpPr>
-        <p:spPr/>
+        <p:spPr>
+          <a:xfrm>
+            <a:off x="831851" y="1709740"/>
+            <a:ext cx="10515600" cy="2852737"/>
+          </a:xfrm>
+        </p:spPr>
         <p:txBody>
           <a:bodyPr/>
           <a:lstStyle/>
@@ -9296,89 +9281,7 @@
             </a:pPr>
             <a:r>
               <a:rPr/>
-              <a:t>My Recommendation If You Are Unsure</a:t>
-            </a:r>
-          </a:p>
-        </p:txBody>
-      </p:sp>
-      <p:sp>
-        <p:nvSpPr>
-          <p:cNvPr id="3" name="Content Placeholder 2">
-            <a:extLst>
-              <a:ext uri="{FF2B5EF4-FFF2-40B4-BE49-F238E27FC236}">
-                <a16:creationId xmlns:a16="http://schemas.microsoft.com/office/drawing/2014/main" id="{89184A04-97C2-C83B-3F52-CA55E676823D}"/>
-              </a:ext>
-            </a:extLst>
-          </p:cNvPr>
-          <p:cNvSpPr>
-            <a:spLocks noGrp="1"/>
-          </p:cNvSpPr>
-          <p:nvPr>
-            <p:ph idx="1"/>
-          </p:nvPr>
-        </p:nvSpPr>
-        <p:spPr/>
-        <p:txBody>
-          <a:bodyPr/>
-          <a:lstStyle/>
-          <a:p>
-            <a:pPr lvl="0" indent="0" marL="0">
-              <a:buNone/>
-            </a:pPr>
-            <a:r>
-              <a:rPr/>
-              <a:t>Start with one of these:</a:t>
-            </a:r>
-          </a:p>
-          <a:p>
-            <a:pPr lvl="0"/>
-            <a:r>
-              <a:rPr/>
-              <a:t>a computer vision app with YOLO or RF-DETR</a:t>
-            </a:r>
-          </a:p>
-          <a:p>
-            <a:pPr lvl="0"/>
-            <a:r>
-              <a:rPr/>
-              <a:t>an LLM app with Ollama or Transformers</a:t>
-            </a:r>
-          </a:p>
-          <a:p>
-            <a:pPr lvl="0"/>
-            <a:r>
-              <a:rPr/>
-              <a:t>a semantic search app with Sentence Transformers</a:t>
-            </a:r>
-          </a:p>
-          <a:p>
-            <a:pPr lvl="0"/>
-            <a:r>
-              <a:rPr/>
-              <a:t>a recommendation app with Sentence Transformers</a:t>
-            </a:r>
-          </a:p>
-          <a:p>
-            <a:pPr lvl="0"/>
-            <a:r>
-              <a:rPr/>
-              <a:t>a speech tool</a:t>
-            </a:r>
-          </a:p>
-          <a:p>
-            <a:pPr lvl="0"/>
-            <a:r>
-              <a:rPr/>
-              <a:t>an edge deployment project with a ready model</a:t>
-            </a:r>
-          </a:p>
-          <a:p>
-            <a:pPr lvl="0" indent="0" marL="0">
-              <a:buNone/>
-            </a:pPr>
-            <a:r>
-              <a:rPr/>
-              <a:t>These are usually easier to scope well than reinforcement learning or large-model fine-tuning.</a:t>
+              <a:t>Final Expectations</a:t>
             </a:r>
           </a:p>
         </p:txBody>
@@ -9410,7 +9313,7 @@
           <p:cNvPr id="2" name="Title 1">
             <a:extLst>
               <a:ext uri="{FF2B5EF4-FFF2-40B4-BE49-F238E27FC236}">
-                <a16:creationId xmlns:a16="http://schemas.microsoft.com/office/drawing/2014/main" id="{43AED9B2-1B96-B1B6-91DE-ED4F04AF0870}"/>
+                <a16:creationId xmlns:a16="http://schemas.microsoft.com/office/drawing/2014/main" id="{DC1D1A22-93E7-53F5-3D1C-BA3AE5668A21}"/>
               </a:ext>
             </a:extLst>
           </p:cNvPr>
@@ -9421,12 +9324,7 @@
             <p:ph type="title"/>
           </p:nvPr>
         </p:nvSpPr>
-        <p:spPr>
-          <a:xfrm>
-            <a:off x="831851" y="1709740"/>
-            <a:ext cx="10515600" cy="2852737"/>
-          </a:xfrm>
-        </p:spPr>
+        <p:spPr/>
         <p:txBody>
           <a:bodyPr/>
           <a:lstStyle/>
@@ -9436,7 +9334,71 @@
             </a:pPr>
             <a:r>
               <a:rPr/>
-              <a:t>Final Expectations</a:t>
+              <a:t>What I Want to See</a:t>
+            </a:r>
+          </a:p>
+        </p:txBody>
+      </p:sp>
+      <p:sp>
+        <p:nvSpPr>
+          <p:cNvPr id="3" name="Content Placeholder 2">
+            <a:extLst>
+              <a:ext uri="{FF2B5EF4-FFF2-40B4-BE49-F238E27FC236}">
+                <a16:creationId xmlns:a16="http://schemas.microsoft.com/office/drawing/2014/main" id="{89184A04-97C2-C83B-3F52-CA55E676823D}"/>
+              </a:ext>
+            </a:extLst>
+          </p:cNvPr>
+          <p:cNvSpPr>
+            <a:spLocks noGrp="1"/>
+          </p:cNvSpPr>
+          <p:nvPr>
+            <p:ph idx="1"/>
+          </p:nvPr>
+        </p:nvSpPr>
+        <p:spPr/>
+        <p:txBody>
+          <a:bodyPr/>
+          <a:lstStyle/>
+          <a:p>
+            <a:pPr lvl="0"/>
+            <a:r>
+              <a:rPr/>
+              <a:t>a unique project</a:t>
+            </a:r>
+          </a:p>
+          <a:p>
+            <a:pPr lvl="0"/>
+            <a:r>
+              <a:rPr/>
+              <a:t>a clear technical path</a:t>
+            </a:r>
+          </a:p>
+          <a:p>
+            <a:pPr lvl="0"/>
+            <a:r>
+              <a:rPr/>
+              <a:t>one main framework stack</a:t>
+            </a:r>
+          </a:p>
+          <a:p>
+            <a:pPr lvl="0"/>
+            <a:r>
+              <a:rPr/>
+              <a:t>visible effort</a:t>
+            </a:r>
+          </a:p>
+          <a:p>
+            <a:pPr lvl="0"/>
+            <a:r>
+              <a:rPr/>
+              <a:t>a working demo or prototype</a:t>
+            </a:r>
+          </a:p>
+          <a:p>
+            <a:pPr lvl="0"/>
+            <a:r>
+              <a:rPr/>
+              <a:t>understanding of the code and architecture</a:t>
             </a:r>
           </a:p>
         </p:txBody>
@@ -9489,7 +9451,7 @@
             </a:pPr>
             <a:r>
               <a:rPr/>
-              <a:t>What I Want to See</a:t>
+              <a:t>Final Message</a:t>
             </a:r>
           </a:p>
         </p:txBody>
@@ -9518,42 +9480,42 @@
             <a:pPr lvl="0"/>
             <a:r>
               <a:rPr/>
-              <a:t>a unique project</a:t>
-            </a:r>
-          </a:p>
-          <a:p>
-            <a:pPr lvl="0"/>
-            <a:r>
-              <a:rPr/>
-              <a:t>a clear technical path</a:t>
-            </a:r>
-          </a:p>
-          <a:p>
-            <a:pPr lvl="0"/>
-            <a:r>
-              <a:rPr/>
-              <a:t>one main framework stack</a:t>
-            </a:r>
-          </a:p>
-          <a:p>
-            <a:pPr lvl="0"/>
-            <a:r>
-              <a:rPr/>
-              <a:t>visible effort</a:t>
-            </a:r>
-          </a:p>
-          <a:p>
-            <a:pPr lvl="0"/>
-            <a:r>
-              <a:rPr/>
-              <a:t>a working demo or prototype</a:t>
-            </a:r>
-          </a:p>
-          <a:p>
-            <a:pPr lvl="0"/>
-            <a:r>
-              <a:rPr/>
-              <a:t>understanding of the code and architecture</a:t>
+              <a:t>Deep learning is a very broad field.</a:t>
+            </a:r>
+          </a:p>
+          <a:p>
+            <a:pPr lvl="0"/>
+            <a:r>
+              <a:rPr/>
+              <a:t>You do not need to master all of it in this course.</a:t>
+            </a:r>
+          </a:p>
+          <a:p>
+            <a:pPr lvl="0"/>
+            <a:r>
+              <a:rPr/>
+              <a:t>But I want you to leave this course with:</a:t>
+            </a:r>
+          </a:p>
+          <a:p>
+            <a:pPr lvl="1"/>
+            <a:r>
+              <a:rPr/>
+              <a:t>a better map of the field</a:t>
+            </a:r>
+          </a:p>
+          <a:p>
+            <a:pPr lvl="1"/>
+            <a:r>
+              <a:rPr/>
+              <a:t>experience building one real AI system</a:t>
+            </a:r>
+          </a:p>
+          <a:p>
+            <a:pPr lvl="1"/>
+            <a:r>
+              <a:rPr/>
+              <a:t>confidence that you can learn a new framework on your own</a:t>
             </a:r>
           </a:p>
         </p:txBody>
@@ -9606,7 +9568,7 @@
             </a:pPr>
             <a:r>
               <a:rPr/>
-              <a:t>Final Message</a:t>
+              <a:t>What To Do Next</a:t>
             </a:r>
           </a:p>
         </p:txBody>
@@ -9635,42 +9597,28 @@
             <a:pPr lvl="0"/>
             <a:r>
               <a:rPr/>
-              <a:t>Deep learning is a very broad field.</a:t>
-            </a:r>
-          </a:p>
-          <a:p>
-            <a:pPr lvl="0"/>
-            <a:r>
-              <a:rPr/>
-              <a:t>You do not need to master all of it in this course.</a:t>
-            </a:r>
-          </a:p>
-          <a:p>
-            <a:pPr lvl="0"/>
-            <a:r>
-              <a:rPr/>
-              <a:t>But I want you to leave this course with:</a:t>
-            </a:r>
-          </a:p>
-          <a:p>
-            <a:pPr lvl="1"/>
-            <a:r>
-              <a:rPr/>
-              <a:t>a better map of the field</a:t>
-            </a:r>
-          </a:p>
-          <a:p>
-            <a:pPr lvl="1"/>
-            <a:r>
-              <a:rPr/>
-              <a:t>experience building one real AI system</a:t>
-            </a:r>
-          </a:p>
-          <a:p>
-            <a:pPr lvl="1"/>
-            <a:r>
-              <a:rPr/>
-              <a:t>confidence that you can learn a new framework on your own</a:t>
+              <a:t>choose a technical path</a:t>
+            </a:r>
+          </a:p>
+          <a:p>
+            <a:pPr lvl="0"/>
+            <a:r>
+              <a:rPr/>
+              <a:t>choose a framework stack</a:t>
+            </a:r>
+          </a:p>
+          <a:p>
+            <a:pPr lvl="0"/>
+            <a:r>
+              <a:rPr/>
+              <a:t>sketch a project idea</a:t>
+            </a:r>
+          </a:p>
+          <a:p>
+            <a:pPr lvl="0"/>
+            <a:r>
+              <a:rPr/>
+              <a:t>start building</a:t>
             </a:r>
           </a:p>
         </p:txBody>
@@ -9702,7 +9650,7 @@
           <p:cNvPr id="2" name="Title 1">
             <a:extLst>
               <a:ext uri="{FF2B5EF4-FFF2-40B4-BE49-F238E27FC236}">
-                <a16:creationId xmlns:a16="http://schemas.microsoft.com/office/drawing/2014/main" id="{DC1D1A22-93E7-53F5-3D1C-BA3AE5668A21}"/>
+                <a16:creationId xmlns:a16="http://schemas.microsoft.com/office/drawing/2014/main" id="{43AED9B2-1B96-B1B6-91DE-ED4F04AF0870}"/>
               </a:ext>
             </a:extLst>
           </p:cNvPr>
@@ -9713,67 +9661,87 @@
             <p:ph type="title"/>
           </p:nvPr>
         </p:nvSpPr>
+        <p:spPr>
+          <a:xfrm>
+            <a:off x="831851" y="1709740"/>
+            <a:ext cx="10515600" cy="2852737"/>
+          </a:xfrm>
+        </p:spPr>
+        <p:txBody>
+          <a:bodyPr/>
+          <a:lstStyle/>
+          <a:p>
+            <a:pPr lvl="0" indent="0" marL="0">
+              <a:buNone/>
+            </a:pPr>
+            <a:r>
+              <a:rPr/>
+              <a:t>Good Luck</a:t>
+            </a:r>
+          </a:p>
+        </p:txBody>
+      </p:sp>
+    </p:spTree>
+  </p:cSld>
+</p:sld>
+</file>
+
+<file path=ppt/slides/slide48.xml><?xml version="1.0" encoding="utf-8"?>
+<p:sld xmlns:a="http://schemas.openxmlformats.org/drawingml/2006/main" xmlns:r="http://schemas.openxmlformats.org/officeDocument/2006/relationships" xmlns:p="http://schemas.openxmlformats.org/presentationml/2006/main">
+  <p:cSld>
+    <p:spTree>
+      <p:nvGrpSpPr>
+        <p:cNvPr id="1" name=""/>
+        <p:cNvGrpSpPr/>
+        <p:nvPr/>
+      </p:nvGrpSpPr>
+      <p:grpSpPr>
+        <a:xfrm>
+          <a:off x="0" y="0"/>
+          <a:ext cx="0" cy="0"/>
+          <a:chOff x="0" y="0"/>
+          <a:chExt cx="0" cy="0"/>
+        </a:xfrm>
+      </p:grpSpPr>
+      <p:sp>
+        <p:nvSpPr>
+          <p:cNvPr id="3" name="Content Placeholder 2">
+            <a:extLst>
+              <a:ext uri="{FF2B5EF4-FFF2-40B4-BE49-F238E27FC236}">
+                <a16:creationId xmlns:a16="http://schemas.microsoft.com/office/drawing/2014/main" id="{89184A04-97C2-C83B-3F52-CA55E676823D}"/>
+              </a:ext>
+            </a:extLst>
+          </p:cNvPr>
+          <p:cNvSpPr>
+            <a:spLocks noGrp="1"/>
+          </p:cNvSpPr>
+          <p:nvPr>
+            <p:ph idx="1"/>
+          </p:nvPr>
+        </p:nvSpPr>
         <p:spPr/>
         <p:txBody>
           <a:bodyPr/>
           <a:lstStyle/>
           <a:p>
-            <a:pPr lvl="0" indent="0" marL="0">
-              <a:buNone/>
-            </a:pPr>
-            <a:r>
-              <a:rPr/>
-              <a:t>What To Do Next</a:t>
-            </a:r>
-          </a:p>
-        </p:txBody>
-      </p:sp>
-      <p:sp>
-        <p:nvSpPr>
-          <p:cNvPr id="3" name="Content Placeholder 2">
-            <a:extLst>
-              <a:ext uri="{FF2B5EF4-FFF2-40B4-BE49-F238E27FC236}">
-                <a16:creationId xmlns:a16="http://schemas.microsoft.com/office/drawing/2014/main" id="{89184A04-97C2-C83B-3F52-CA55E676823D}"/>
-              </a:ext>
-            </a:extLst>
-          </p:cNvPr>
-          <p:cNvSpPr>
-            <a:spLocks noGrp="1"/>
-          </p:cNvSpPr>
-          <p:nvPr>
-            <p:ph idx="1"/>
-          </p:nvPr>
-        </p:nvSpPr>
-        <p:spPr/>
-        <p:txBody>
-          <a:bodyPr/>
-          <a:lstStyle/>
-          <a:p>
-            <a:pPr lvl="0"/>
-            <a:r>
-              <a:rPr/>
-              <a:t>choose a technical path</a:t>
-            </a:r>
-          </a:p>
-          <a:p>
-            <a:pPr lvl="0"/>
-            <a:r>
-              <a:rPr/>
-              <a:t>choose a framework stack</a:t>
-            </a:r>
-          </a:p>
-          <a:p>
-            <a:pPr lvl="0"/>
-            <a:r>
-              <a:rPr/>
-              <a:t>sketch a project idea</a:t>
-            </a:r>
-          </a:p>
-          <a:p>
-            <a:pPr lvl="0"/>
-            <a:r>
-              <a:rPr/>
-              <a:t>start building</a:t>
+            <a:pPr lvl="0"/>
+            <a:r>
+              <a:rPr/>
+              <a:t>Pick something you find genuinely interesting.</a:t>
+            </a:r>
+          </a:p>
+          <a:p>
+            <a:pPr lvl="0"/>
+            <a:r>
+              <a:rPr/>
+              <a:t>Build something real.</a:t>
+            </a:r>
+          </a:p>
+          <a:p>
+            <a:pPr lvl="0"/>
+            <a:r>
+              <a:rPr/>
+              <a:t>Learn your tools deeply enough to explain what you made.</a:t>
             </a:r>
           </a:p>
         </p:txBody>

</xml_diff>

<commit_message>
Re-render slides with updated template
</commit_message>
<xml_diff>
--- a/slides/deep-learning-project-directions.pptx
+++ b/slides/deep-learning-project-directions.pptx
@@ -1300,8 +1300,8 @@
         </p:nvSpPr>
         <p:spPr>
           <a:xfrm>
-            <a:off x="7559999" y="2822714"/>
-            <a:ext cx="4397835" cy="3806859"/>
+            <a:off x="9477031" y="4162230"/>
+            <a:ext cx="2520000" cy="2520000"/>
           </a:xfrm>
         </p:spPr>
         <p:txBody>
@@ -7550,8 +7550,8 @@
         </p:blipFill>
         <p:spPr bwMode="auto">
           <a:xfrm>
-            <a:off x="7848600" y="2819400"/>
-            <a:ext cx="3797300" cy="3797300"/>
+            <a:off x="9474200" y="4152900"/>
+            <a:ext cx="2514600" cy="2514600"/>
           </a:xfrm>
           <a:prstGeom prst="rect">
             <a:avLst/>
@@ -9214,8 +9214,8 @@
         </p:blipFill>
         <p:spPr bwMode="auto">
           <a:xfrm>
-            <a:off x="7556500" y="3251200"/>
-            <a:ext cx="4394200" cy="2933700"/>
+            <a:off x="9474200" y="4572000"/>
+            <a:ext cx="2514600" cy="1676400"/>
           </a:xfrm>
           <a:prstGeom prst="rect">
             <a:avLst/>

</xml_diff>